<commit_message>
docs: Update CDAC slides with custom background layouts based on Russell-cell PPT-Design-Prompt
</commit_message>
<xml_diff>
--- a/reports/cdac_project_review.pptx
+++ b/reports/cdac_project_review.pptx
@@ -3086,14 +3086,6 @@
 <file path=ppt/slides/slide1.xml><?xml version="1.0" encoding="utf-8"?>
 <p:sld xmlns:a="http://schemas.openxmlformats.org/drawingml/2006/main" xmlns:p="http://schemas.openxmlformats.org/presentationml/2006/main" xmlns:r="http://schemas.openxmlformats.org/officeDocument/2006/relationships">
   <p:cSld>
-    <p:bg>
-      <p:bgPr>
-        <a:solidFill>
-          <a:srgbClr val="12141A"/>
-        </a:solidFill>
-        <a:effectLst/>
-      </p:bgPr>
-    </p:bg>
     <p:spTree>
       <p:nvGrpSpPr>
         <p:cNvPr id="1" name=""/>
@@ -3101,16 +3093,40 @@
         <p:nvPr/>
       </p:nvGrpSpPr>
       <p:grpSpPr/>
-      <p:sp>
-        <p:nvSpPr>
-          <p:cNvPr id="2" name="TextBox 1"/>
+      <p:pic>
+        <p:nvPicPr>
+          <p:cNvPr id="2" name="Picture 1" descr="shield_cover_visual_1783185170999.jpg"/>
+          <p:cNvPicPr>
+            <a:picLocks noChangeAspect="1"/>
+          </p:cNvPicPr>
+          <p:nvPr/>
+        </p:nvPicPr>
+        <p:blipFill>
+          <a:blip r:embed="rId2"/>
+          <a:stretch>
+            <a:fillRect/>
+          </a:stretch>
+        </p:blipFill>
+        <p:spPr>
+          <a:xfrm>
+            <a:off x="0" y="0"/>
+            <a:ext cx="12191695" cy="6858000"/>
+          </a:xfrm>
+          <a:prstGeom prst="rect">
+            <a:avLst/>
+          </a:prstGeom>
+        </p:spPr>
+      </p:pic>
+      <p:sp>
+        <p:nvSpPr>
+          <p:cNvPr id="3" name="TextBox 2"/>
           <p:cNvSpPr txBox="1"/>
           <p:nvPr/>
         </p:nvSpPr>
         <p:spPr>
           <a:xfrm>
-            <a:off x="685800" y="914400"/>
-            <a:ext cx="10817352" cy="1645920"/>
+            <a:off x="685800" y="731520"/>
+            <a:ext cx="5029200" cy="1645920"/>
           </a:xfrm>
           <a:prstGeom prst="rect">
             <a:avLst/>
@@ -3124,7 +3140,7 @@
           <a:lstStyle/>
           <a:p>
             <a:pPr>
-              <a:defRPr sz="4000" b="1">
+              <a:defRPr sz="4400" b="1">
                 <a:solidFill>
                   <a:srgbClr val="00D2FF"/>
                 </a:solidFill>
@@ -3132,51 +3148,31 @@
               </a:defRPr>
             </a:pPr>
             <a:r>
-              <a:t>SHIELD: Secure Human Identity &amp; Liveness Evaluation Detection</a:t>
+              <a:t>SHIELD</a:t>
             </a:r>
           </a:p>
           <a:p>
             <a:pPr>
               <a:spcBef>
-                <a:spcPts val="1000"/>
+                <a:spcPts val="800"/>
               </a:spcBef>
-              <a:defRPr sz="2000">
-                <a:solidFill>
-                  <a:srgbClr val="00FFAA"/>
+              <a:defRPr sz="2000" b="1">
+                <a:solidFill>
+                  <a:srgbClr val="F0F0F0"/>
                 </a:solidFill>
                 <a:latin typeface="Arial"/>
               </a:defRPr>
             </a:pPr>
             <a:r>
-              <a:t>Multimodal Real-Time Verification &amp; Spoof Prevention</a:t>
-            </a:r>
-          </a:p>
-        </p:txBody>
-      </p:sp>
-      <p:sp>
-        <p:nvSpPr>
-          <p:cNvPr id="3" name="TextBox 2"/>
-          <p:cNvSpPr txBox="1"/>
-          <p:nvPr/>
-        </p:nvSpPr>
-        <p:spPr>
-          <a:xfrm>
-            <a:off x="685800" y="2560320"/>
-            <a:ext cx="10817352" cy="731520"/>
-          </a:xfrm>
-          <a:prstGeom prst="rect">
-            <a:avLst/>
-          </a:prstGeom>
-          <a:noFill/>
-        </p:spPr>
-        <p:txBody>
-          <a:bodyPr wrap="none">
-            <a:spAutoFit/>
-          </a:bodyPr>
-          <a:lstStyle/>
+              <a:t>Secure Human Identity &amp; Liveness Evaluation Detection</a:t>
+            </a:r>
+          </a:p>
           <a:p>
             <a:pPr>
-              <a:defRPr sz="1400">
+              <a:spcBef>
+                <a:spcPts val="800"/>
+              </a:spcBef>
+              <a:defRPr sz="1300">
                 <a:solidFill>
                   <a:srgbClr val="96A0AF"/>
                 </a:solidFill>
@@ -3184,7 +3180,7 @@
               </a:defRPr>
             </a:pPr>
             <a:r>
-              <a:t>CDAC Project Review  |  Domain: Computer Vision, Biometrics &amp; Anti-Spoofing</a:t>
+              <a:t>CDAC Project Review  |  Anti-Spoofing &amp; Biometrics</a:t>
             </a:r>
           </a:p>
         </p:txBody>
@@ -3197,8 +3193,8 @@
         </p:nvSpPr>
         <p:spPr>
           <a:xfrm>
-            <a:off x="685800" y="3474720"/>
-            <a:ext cx="10817352" cy="2560320"/>
+            <a:off x="685800" y="2926080"/>
+            <a:ext cx="5029200" cy="3200400"/>
           </a:xfrm>
           <a:prstGeom prst="rect">
             <a:avLst/>
@@ -3227,11 +3223,11 @@
           </a:fontRef>
         </p:style>
         <p:txBody>
-          <a:bodyPr rtlCol="0" anchor="ctr" wrap="square" lIns="274320" tIns="274320" rIns="274320" bIns="274320"/>
+          <a:bodyPr rtlCol="0" anchor="ctr" wrap="square" lIns="182880" tIns="182880" rIns="182880" bIns="182880"/>
           <a:lstStyle/>
           <a:p>
             <a:pPr algn="ctr">
-              <a:defRPr sz="1800" b="1">
+              <a:defRPr sz="1600" b="1">
                 <a:solidFill>
                   <a:srgbClr val="00FFAA"/>
                 </a:solidFill>
@@ -3245,9 +3241,9 @@
           <a:p>
             <a:pPr>
               <a:spcBef>
-                <a:spcPts val="1000"/>
+                <a:spcPts val="800"/>
               </a:spcBef>
-              <a:defRPr sz="1400">
+              <a:defRPr sz="1200">
                 <a:solidFill>
                   <a:srgbClr val="F0F0F0"/>
                 </a:solidFill>
@@ -3255,19 +3251,19 @@
               </a:defRPr>
             </a:pPr>
             <a:r>
-              <a:t>Identity fraud and spoofing attacks have compromised remote authentication services (automated attendance and virtual interviews):</a:t>
+              <a:t>Identity fraud compromises remote verification systems:</a:t>
             </a:r>
             <a:br/>
             <a:r>
-              <a:t>• Presentation Attacks (PA): High-definition printed photos, screens playing recorded loops, and 3D silicone mask replays bypass standard biometrics.</a:t>
+              <a:t>• Spoof Attacks: Printed photos, screen video replays, and 3D silicone masks bypass typical biometrics.</a:t>
             </a:r>
             <a:br/>
             <a:r>
-              <a:t>• Identity Swap Attacks: Candidates swaps mid-session (tag-team attacks) during exams/interviews.</a:t>
+              <a:t>• Identity Swap Attacks: Users swap mid-session (tag-team attacks) during active sessions.</a:t>
             </a:r>
             <a:br/>
             <a:r>
-              <a:t>• Hardware Constraints: Traditional solutions require specialized, expensive 3D depth cameras, limiting widespread deployment.</a:t>
+              <a:t>• Hardware Constraints: Existing defenses rely on costly 3D depth cameras, limiting massive deployments.</a:t>
             </a:r>
           </a:p>
         </p:txBody>
@@ -4029,14 +4025,6 @@
 <file path=ppt/slides/slide4.xml><?xml version="1.0" encoding="utf-8"?>
 <p:sld xmlns:a="http://schemas.openxmlformats.org/drawingml/2006/main" xmlns:p="http://schemas.openxmlformats.org/presentationml/2006/main" xmlns:r="http://schemas.openxmlformats.org/officeDocument/2006/relationships">
   <p:cSld>
-    <p:bg>
-      <p:bgPr>
-        <a:solidFill>
-          <a:srgbClr val="12141A"/>
-        </a:solidFill>
-        <a:effectLst/>
-      </p:bgPr>
-    </p:bg>
     <p:spTree>
       <p:nvGrpSpPr>
         <p:cNvPr id="1" name=""/>
@@ -4044,16 +4032,40 @@
         <p:nvPr/>
       </p:nvGrpSpPr>
       <p:grpSpPr/>
-      <p:sp>
-        <p:nvSpPr>
-          <p:cNvPr id="2" name="TextBox 1"/>
+      <p:pic>
+        <p:nvPicPr>
+          <p:cNvPr id="2" name="Picture 1" descr="telemetry_visual_1783185198779.jpg"/>
+          <p:cNvPicPr>
+            <a:picLocks noChangeAspect="1"/>
+          </p:cNvPicPr>
+          <p:nvPr/>
+        </p:nvPicPr>
+        <p:blipFill>
+          <a:blip r:embed="rId2"/>
+          <a:stretch>
+            <a:fillRect/>
+          </a:stretch>
+        </p:blipFill>
+        <p:spPr>
+          <a:xfrm>
+            <a:off x="0" y="0"/>
+            <a:ext cx="12191695" cy="6858000"/>
+          </a:xfrm>
+          <a:prstGeom prst="rect">
+            <a:avLst/>
+          </a:prstGeom>
+        </p:spPr>
+      </p:pic>
+      <p:sp>
+        <p:nvSpPr>
+          <p:cNvPr id="3" name="TextBox 2"/>
           <p:cNvSpPr txBox="1"/>
           <p:nvPr/>
         </p:nvSpPr>
         <p:spPr>
           <a:xfrm>
-            <a:off x="685800" y="457200"/>
-            <a:ext cx="10817352" cy="731520"/>
+            <a:off x="685800" y="365760"/>
+            <a:ext cx="5120640" cy="731520"/>
           </a:xfrm>
           <a:prstGeom prst="rect">
             <a:avLst/>
@@ -4082,15 +4094,15 @@
       </p:sp>
       <p:graphicFrame>
         <p:nvGraphicFramePr>
-          <p:cNvPr id="3" name="Table 2"/>
+          <p:cNvPr id="4" name="Table 3"/>
           <p:cNvGraphicFramePr>
             <a:graphicFrameLocks noGrp="1"/>
           </p:cNvGraphicFramePr>
           <p:nvPr/>
         </p:nvGraphicFramePr>
         <p:xfrm>
-          <a:off x="685800" y="1645920"/>
-          <a:ext cx="6400800" cy="4114800"/>
+          <a:off x="685800" y="1188720"/>
+          <a:ext cx="5120640" cy="2011680"/>
         </p:xfrm>
         <a:graphic>
           <a:graphicData uri="http://schemas.openxmlformats.org/drawingml/2006/table">
@@ -4099,18 +4111,17 @@
                 <a:tableStyleId>{5C22544A-7EE6-4342-B048-85BDC9FD1C3A}</a:tableStyleId>
               </a:tblPr>
               <a:tblGrid>
-                <a:gridCol w="2560320"/>
-                <a:gridCol w="1371600"/>
-                <a:gridCol w="2468880"/>
+                <a:gridCol w="3291840"/>
+                <a:gridCol w="1828800"/>
               </a:tblGrid>
-              <a:tr h="822960">
+              <a:tr h="402336">
                 <a:tc>
                   <a:txBody>
                     <a:bodyPr/>
                     <a:lstStyle/>
                     <a:p>
                       <a:pPr algn="ctr">
-                        <a:defRPr sz="1500" b="1">
+                        <a:defRPr sz="1300" b="1">
                           <a:solidFill>
                             <a:srgbClr val="00D2FF"/>
                           </a:solidFill>
@@ -4118,7 +4129,7 @@
                         </a:defRPr>
                       </a:pPr>
                       <a:r>
-                        <a:t>Metric</a:t>
+                        <a:t>Metric Name</a:t>
                       </a:r>
                     </a:p>
                   </a:txBody>
@@ -4134,7 +4145,7 @@
                     <a:lstStyle/>
                     <a:p>
                       <a:pPr algn="ctr">
-                        <a:defRPr sz="1500" b="1">
+                        <a:defRPr sz="1300" b="1">
                           <a:solidFill>
                             <a:srgbClr val="00D2FF"/>
                           </a:solidFill>
@@ -4152,39 +4163,15 @@
                     </a:solidFill>
                   </a:tcPr>
                 </a:tc>
+              </a:tr>
+              <a:tr h="402336">
                 <a:tc>
                   <a:txBody>
                     <a:bodyPr/>
                     <a:lstStyle/>
                     <a:p>
                       <a:pPr algn="ctr">
-                        <a:defRPr sz="1500" b="1">
-                          <a:solidFill>
-                            <a:srgbClr val="00D2FF"/>
-                          </a:solidFill>
-                          <a:latin typeface="Arial"/>
-                        </a:defRPr>
-                      </a:pPr>
-                      <a:r>
-                        <a:t>ISO 30107-3 Standard</a:t>
-                      </a:r>
-                    </a:p>
-                  </a:txBody>
-                  <a:tcPr>
-                    <a:solidFill>
-                      <a:srgbClr val="1C202A"/>
-                    </a:solidFill>
-                  </a:tcPr>
-                </a:tc>
-              </a:tr>
-              <a:tr h="822960">
-                <a:tc>
-                  <a:txBody>
-                    <a:bodyPr/>
-                    <a:lstStyle/>
-                    <a:p>
-                      <a:pPr algn="ctr">
-                        <a:defRPr sz="1300">
+                        <a:defRPr sz="1100">
                           <a:solidFill>
                             <a:srgbClr val="F0F0F0"/>
                           </a:solidFill>
@@ -4208,7 +4195,7 @@
                     <a:lstStyle/>
                     <a:p>
                       <a:pPr algn="ctr">
-                        <a:defRPr sz="1300" b="1">
+                        <a:defRPr sz="1100" b="1">
                           <a:solidFill>
                             <a:srgbClr val="00FFAA"/>
                           </a:solidFill>
@@ -4226,39 +4213,15 @@
                     </a:solidFill>
                   </a:tcPr>
                 </a:tc>
+              </a:tr>
+              <a:tr h="402336">
                 <a:tc>
                   <a:txBody>
                     <a:bodyPr/>
                     <a:lstStyle/>
                     <a:p>
                       <a:pPr algn="ctr">
-                        <a:defRPr sz="1300">
-                          <a:solidFill>
-                            <a:srgbClr val="F0F0F0"/>
-                          </a:solidFill>
-                          <a:latin typeface="Arial"/>
-                        </a:defRPr>
-                      </a:pPr>
-                      <a:r>
-                        <a:t>&lt; 5.0% (Excellent protection)</a:t>
-                      </a:r>
-                    </a:p>
-                  </a:txBody>
-                  <a:tcPr>
-                    <a:solidFill>
-                      <a:srgbClr val="12141A"/>
-                    </a:solidFill>
-                  </a:tcPr>
-                </a:tc>
-              </a:tr>
-              <a:tr h="822960">
-                <a:tc>
-                  <a:txBody>
-                    <a:bodyPr/>
-                    <a:lstStyle/>
-                    <a:p>
-                      <a:pPr algn="ctr">
-                        <a:defRPr sz="1300">
+                        <a:defRPr sz="1100">
                           <a:solidFill>
                             <a:srgbClr val="F0F0F0"/>
                           </a:solidFill>
@@ -4282,7 +4245,7 @@
                     <a:lstStyle/>
                     <a:p>
                       <a:pPr algn="ctr">
-                        <a:defRPr sz="1300" b="1">
+                        <a:defRPr sz="1100" b="1">
                           <a:solidFill>
                             <a:srgbClr val="00FFAA"/>
                           </a:solidFill>
@@ -4300,39 +4263,15 @@
                     </a:solidFill>
                   </a:tcPr>
                 </a:tc>
+              </a:tr>
+              <a:tr h="402336">
                 <a:tc>
                   <a:txBody>
                     <a:bodyPr/>
                     <a:lstStyle/>
                     <a:p>
                       <a:pPr algn="ctr">
-                        <a:defRPr sz="1300">
-                          <a:solidFill>
-                            <a:srgbClr val="F0F0F0"/>
-                          </a:solidFill>
-                          <a:latin typeface="Arial"/>
-                        </a:defRPr>
-                      </a:pPr>
-                      <a:r>
-                        <a:t>&lt; 3.0% (Minimal false rejects)</a:t>
-                      </a:r>
-                    </a:p>
-                  </a:txBody>
-                  <a:tcPr>
-                    <a:solidFill>
-                      <a:srgbClr val="12141A"/>
-                    </a:solidFill>
-                  </a:tcPr>
-                </a:tc>
-              </a:tr>
-              <a:tr h="822960">
-                <a:tc>
-                  <a:txBody>
-                    <a:bodyPr/>
-                    <a:lstStyle/>
-                    <a:p>
-                      <a:pPr algn="ctr">
-                        <a:defRPr sz="1300">
+                        <a:defRPr sz="1100">
                           <a:solidFill>
                             <a:srgbClr val="F0F0F0"/>
                           </a:solidFill>
@@ -4356,7 +4295,7 @@
                     <a:lstStyle/>
                     <a:p>
                       <a:pPr algn="ctr">
-                        <a:defRPr sz="1300" b="1">
+                        <a:defRPr sz="1100" b="1">
                           <a:solidFill>
                             <a:srgbClr val="00FFAA"/>
                           </a:solidFill>
@@ -4374,13 +4313,15 @@
                     </a:solidFill>
                   </a:tcPr>
                 </a:tc>
+              </a:tr>
+              <a:tr h="402336">
                 <a:tc>
                   <a:txBody>
                     <a:bodyPr/>
                     <a:lstStyle/>
                     <a:p>
                       <a:pPr algn="ctr">
-                        <a:defRPr sz="1300">
+                        <a:defRPr sz="1100">
                           <a:solidFill>
                             <a:srgbClr val="F0F0F0"/>
                           </a:solidFill>
@@ -4388,33 +4329,7 @@
                         </a:defRPr>
                       </a:pPr>
                       <a:r>
-                        <a:t>&lt; 4.0% (Superior overall accuracy)</a:t>
-                      </a:r>
-                    </a:p>
-                  </a:txBody>
-                  <a:tcPr>
-                    <a:solidFill>
-                      <a:srgbClr val="12141A"/>
-                    </a:solidFill>
-                  </a:tcPr>
-                </a:tc>
-              </a:tr>
-              <a:tr h="822960">
-                <a:tc>
-                  <a:txBody>
-                    <a:bodyPr/>
-                    <a:lstStyle/>
-                    <a:p>
-                      <a:pPr algn="ctr">
-                        <a:defRPr sz="1300">
-                          <a:solidFill>
-                            <a:srgbClr val="F0F0F0"/>
-                          </a:solidFill>
-                          <a:latin typeface="Arial"/>
-                        </a:defRPr>
-                      </a:pPr>
-                      <a:r>
-                        <a:t>Latency (End-to-End)</a:t>
+                        <a:t>Inference Latency</a:t>
                       </a:r>
                     </a:p>
                   </a:txBody>
@@ -4430,7 +4345,7 @@
                     <a:lstStyle/>
                     <a:p>
                       <a:pPr algn="ctr">
-                        <a:defRPr sz="1300" b="1">
+                        <a:defRPr sz="1100" b="1">
                           <a:solidFill>
                             <a:srgbClr val="00FFAA"/>
                           </a:solidFill>
@@ -4448,30 +4363,6 @@
                     </a:solidFill>
                   </a:tcPr>
                 </a:tc>
-                <a:tc>
-                  <a:txBody>
-                    <a:bodyPr/>
-                    <a:lstStyle/>
-                    <a:p>
-                      <a:pPr algn="ctr">
-                        <a:defRPr sz="1300">
-                          <a:solidFill>
-                            <a:srgbClr val="F0F0F0"/>
-                          </a:solidFill>
-                          <a:latin typeface="Arial"/>
-                        </a:defRPr>
-                      </a:pPr>
-                      <a:r>
-                        <a:t>&lt; 150 ms (Ultra real-time capability)</a:t>
-                      </a:r>
-                    </a:p>
-                  </a:txBody>
-                  <a:tcPr>
-                    <a:solidFill>
-                      <a:srgbClr val="12141A"/>
-                    </a:solidFill>
-                  </a:tcPr>
-                </a:tc>
               </a:tr>
             </a:tbl>
           </a:graphicData>
@@ -4479,14 +4370,14 @@
       </p:graphicFrame>
       <p:sp>
         <p:nvSpPr>
-          <p:cNvPr id="4" name="TextBox 3"/>
+          <p:cNvPr id="5" name="TextBox 4"/>
           <p:cNvSpPr txBox="1"/>
           <p:nvPr/>
         </p:nvSpPr>
         <p:spPr>
           <a:xfrm>
-            <a:off x="7406640" y="1645920"/>
-            <a:ext cx="4114800" cy="4114800"/>
+            <a:off x="685800" y="3383280"/>
+            <a:ext cx="5120640" cy="3017520"/>
           </a:xfrm>
           <a:prstGeom prst="rect">
             <a:avLst/>
@@ -4501,25 +4392,25 @@
           <a:p>
             <a:pPr>
               <a:spcAft>
-                <a:spcPts val="1000"/>
+                <a:spcPts val="600"/>
               </a:spcAft>
-              <a:defRPr sz="1800" b="1">
-                <a:solidFill>
-                  <a:srgbClr val="00D2FF"/>
+              <a:defRPr sz="1600" b="1">
+                <a:solidFill>
+                  <a:srgbClr val="00FFAA"/>
                 </a:solidFill>
                 <a:latin typeface="Arial"/>
               </a:defRPr>
             </a:pPr>
             <a:r>
-              <a:t>📊 Dataset &amp; Evaluation Setup</a:t>
+              <a:t>📊 Dataset &amp; Optimization Results</a:t>
             </a:r>
           </a:p>
           <a:p>
             <a:pPr>
               <a:spcAft>
-                <a:spcPts val="1200"/>
+                <a:spcPts val="600"/>
               </a:spcAft>
-              <a:defRPr sz="1300">
+              <a:defRPr sz="1100">
                 <a:solidFill>
                   <a:srgbClr val="F0F0F0"/>
                 </a:solidFill>
@@ -4527,15 +4418,15 @@
               </a:defRPr>
             </a:pPr>
             <a:r>
-              <a:t>⚡ Tested on unified subsets of CASIA-FASD and CelebA-Spoof datasets, comprising over 10,000 frames representing high-definition prints, digital replays, and lighting shifts.</a:t>
+              <a:t>• Tested on unified sets of CASIA-FASD and CelebA-Spoof datasets, comprising over 10,000 frames.</a:t>
             </a:r>
           </a:p>
           <a:p>
             <a:pPr>
               <a:spcAft>
-                <a:spcPts val="1200"/>
+                <a:spcPts val="600"/>
               </a:spcAft>
-              <a:defRPr sz="1300">
+              <a:defRPr sz="1100">
                 <a:solidFill>
                   <a:srgbClr val="F0F0F0"/>
                 </a:solidFill>
@@ -4543,15 +4434,15 @@
               </a:defRPr>
             </a:pPr>
             <a:r>
-              <a:t>⚡ Real-Time streaming evaluation measured sustained WebSockets frame processing rates above 30 FPS.</a:t>
+              <a:t>• Real-Time evaluation verified WebSockets frame streaming rate above 30 FPS.</a:t>
             </a:r>
           </a:p>
           <a:p>
             <a:pPr>
               <a:spcAft>
-                <a:spcPts val="1200"/>
+                <a:spcPts val="600"/>
               </a:spcAft>
-              <a:defRPr sz="1300">
+              <a:defRPr sz="1100">
                 <a:solidFill>
                   <a:srgbClr val="F0F0F0"/>
                 </a:solidFill>
@@ -4559,7 +4450,7 @@
               </a:defRPr>
             </a:pPr>
             <a:r>
-              <a:t>⚡ Weighted Decision Fusion: Evaluated 1,771 weight combinations under a multi-modality constraint (min_weight=0.10) to discover the optimal engine weights: 10% rPPG, 10% Blink, 15% Antispoof, and 65% Challenge.</a:t>
+              <a:t>• Weighted Decision Fusion: Calibrated dynamically using grid search over 1,771 separate sensor weight parameter combinations.</a:t>
             </a:r>
           </a:p>
         </p:txBody>
@@ -4575,14 +4466,6 @@
 <file path=ppt/slides/slide5.xml><?xml version="1.0" encoding="utf-8"?>
 <p:sld xmlns:a="http://schemas.openxmlformats.org/drawingml/2006/main" xmlns:p="http://schemas.openxmlformats.org/presentationml/2006/main" xmlns:r="http://schemas.openxmlformats.org/officeDocument/2006/relationships">
   <p:cSld>
-    <p:bg>
-      <p:bgPr>
-        <a:solidFill>
-          <a:srgbClr val="12141A"/>
-        </a:solidFill>
-        <a:effectLst/>
-      </p:bgPr>
-    </p:bg>
     <p:spTree>
       <p:nvGrpSpPr>
         <p:cNvPr id="1" name=""/>
@@ -4590,16 +4473,40 @@
         <p:nvPr/>
       </p:nvGrpSpPr>
       <p:grpSpPr/>
-      <p:sp>
-        <p:nvSpPr>
-          <p:cNvPr id="2" name="TextBox 1"/>
+      <p:pic>
+        <p:nvPicPr>
+          <p:cNvPr id="2" name="Picture 1" descr="facial_mesh_visual_1783185185503.jpg"/>
+          <p:cNvPicPr>
+            <a:picLocks noChangeAspect="1"/>
+          </p:cNvPicPr>
+          <p:nvPr/>
+        </p:nvPicPr>
+        <p:blipFill>
+          <a:blip r:embed="rId2"/>
+          <a:stretch>
+            <a:fillRect/>
+          </a:stretch>
+        </p:blipFill>
+        <p:spPr>
+          <a:xfrm>
+            <a:off x="0" y="0"/>
+            <a:ext cx="12191695" cy="6858000"/>
+          </a:xfrm>
+          <a:prstGeom prst="rect">
+            <a:avLst/>
+          </a:prstGeom>
+        </p:spPr>
+      </p:pic>
+      <p:sp>
+        <p:nvSpPr>
+          <p:cNvPr id="3" name="TextBox 2"/>
           <p:cNvSpPr txBox="1"/>
           <p:nvPr/>
         </p:nvSpPr>
         <p:spPr>
           <a:xfrm>
-            <a:off x="685800" y="457200"/>
-            <a:ext cx="10817352" cy="731520"/>
+            <a:off x="685800" y="365760"/>
+            <a:ext cx="5120640" cy="731520"/>
           </a:xfrm>
           <a:prstGeom prst="rect">
             <a:avLst/>
@@ -4621,73 +4528,54 @@
               </a:defRPr>
             </a:pPr>
             <a:r>
-              <a:t>Novelty &amp; Custom Contributions</a:t>
-            </a:r>
-          </a:p>
-        </p:txBody>
-      </p:sp>
-      <p:sp>
-        <p:nvSpPr>
-          <p:cNvPr id="3" name="Rectangle 2"/>
-          <p:cNvSpPr/>
+              <a:t>Novelty &amp; Key Contributions</a:t>
+            </a:r>
+          </a:p>
+        </p:txBody>
+      </p:sp>
+      <p:sp>
+        <p:nvSpPr>
+          <p:cNvPr id="4" name="TextBox 3"/>
+          <p:cNvSpPr txBox="1"/>
           <p:nvPr/>
         </p:nvSpPr>
         <p:spPr>
           <a:xfrm>
-            <a:off x="685800" y="1645920"/>
-            <a:ext cx="3383280" cy="4206240"/>
+            <a:off x="685800" y="1188720"/>
+            <a:ext cx="5120640" cy="5303520"/>
           </a:xfrm>
           <a:prstGeom prst="rect">
             <a:avLst/>
           </a:prstGeom>
-          <a:solidFill>
-            <a:srgbClr val="1C202A"/>
-          </a:solidFill>
-          <a:ln w="19050">
-            <a:solidFill>
-              <a:srgbClr val="00FFAA"/>
-            </a:solidFill>
-          </a:ln>
+          <a:noFill/>
         </p:spPr>
-        <p:style>
-          <a:lnRef idx="1">
-            <a:schemeClr val="accent1"/>
-          </a:lnRef>
-          <a:fillRef idx="3">
-            <a:schemeClr val="accent1"/>
-          </a:fillRef>
-          <a:effectRef idx="2">
-            <a:schemeClr val="accent1"/>
-          </a:effectRef>
-          <a:fontRef idx="minor">
-            <a:schemeClr val="lt1"/>
-          </a:fontRef>
-        </p:style>
-        <p:txBody>
-          <a:bodyPr rtlCol="0" anchor="ctr" wrap="square" lIns="182880" tIns="182880" rIns="182880"/>
-          <a:lstStyle/>
-          <a:p>
-            <a:pPr algn="ctr">
-              <a:spcAft>
-                <a:spcPts val="1200"/>
-              </a:spcAft>
-              <a:defRPr sz="1500" b="1">
-                <a:solidFill>
-                  <a:srgbClr val="00D2FF"/>
-                </a:solidFill>
-                <a:latin typeface="Arial"/>
-              </a:defRPr>
-            </a:pPr>
-            <a:r>
-              <a:t>1. Real-Time Scale-Invariant Identity Consistency Check</a:t>
-            </a:r>
-          </a:p>
+        <p:txBody>
+          <a:bodyPr wrap="square">
+            <a:spAutoFit/>
+          </a:bodyPr>
+          <a:lstStyle/>
           <a:p>
             <a:pPr>
               <a:spcBef>
-                <a:spcPts val="500"/>
+                <a:spcPts val="800"/>
               </a:spcBef>
-              <a:defRPr sz="1200">
+              <a:defRPr sz="1400" b="1">
+                <a:solidFill>
+                  <a:srgbClr val="00FFAA"/>
+                </a:solidFill>
+                <a:latin typeface="Arial"/>
+              </a:defRPr>
+            </a:pPr>
+            <a:r>
+              <a:t>1. Real-Time Scale-Invariant Identity Consistency Check</a:t>
+            </a:r>
+          </a:p>
+          <a:p>
+            <a:pPr>
+              <a:spcAft>
+                <a:spcPts val="600"/>
+              </a:spcAft>
+              <a:defRPr sz="1100">
                 <a:solidFill>
                   <a:srgbClr val="F0F0F0"/>
                 </a:solidFill>
@@ -4695,81 +4583,39 @@
               </a:defRPr>
             </a:pPr>
             <a:r>
-              <a:t>Protects session integrity against mid-session user swaps (tag-team cheats):</a:t>
+              <a:t>Defeats mid-session user swaps (tag-team candidate swaps):</a:t>
             </a:r>
             <a:br/>
             <a:r>
-              <a:t>• Computes scale-invariant 4D signature ratios (nose, eyes, chin, lip corners) using MediaPipe landmark geometry.</a:t>
+              <a:t>• Computes scale-invariant 4D signature ratios (nose, eyes, chin, lip corners) via MediaPipe FaceMesh geometry.</a:t>
             </a:r>
             <a:br/>
             <a:r>
-              <a:t>• Signature distance is verified frame-by-frame. Connection is killed and flagged if signature variation surpasses threshold (&gt;0.20).</a:t>
-            </a:r>
-          </a:p>
-        </p:txBody>
-      </p:sp>
-      <p:sp>
-        <p:nvSpPr>
-          <p:cNvPr id="4" name="Rectangle 3"/>
-          <p:cNvSpPr/>
-          <p:nvPr/>
-        </p:nvSpPr>
-        <p:spPr>
-          <a:xfrm>
-            <a:off x="4434840" y="1645920"/>
-            <a:ext cx="3383280" cy="4206240"/>
-          </a:xfrm>
-          <a:prstGeom prst="rect">
-            <a:avLst/>
-          </a:prstGeom>
-          <a:solidFill>
-            <a:srgbClr val="1C202A"/>
-          </a:solidFill>
-          <a:ln w="19050">
-            <a:solidFill>
-              <a:srgbClr val="00FFAA"/>
-            </a:solidFill>
-          </a:ln>
-        </p:spPr>
-        <p:style>
-          <a:lnRef idx="1">
-            <a:schemeClr val="accent1"/>
-          </a:lnRef>
-          <a:fillRef idx="3">
-            <a:schemeClr val="accent1"/>
-          </a:fillRef>
-          <a:effectRef idx="2">
-            <a:schemeClr val="accent1"/>
-          </a:effectRef>
-          <a:fontRef idx="minor">
-            <a:schemeClr val="lt1"/>
-          </a:fontRef>
-        </p:style>
-        <p:txBody>
-          <a:bodyPr rtlCol="0" anchor="ctr" wrap="square" lIns="182880" tIns="182880" rIns="182880"/>
-          <a:lstStyle/>
-          <a:p>
-            <a:pPr algn="ctr">
-              <a:spcAft>
-                <a:spcPts val="1200"/>
-              </a:spcAft>
-              <a:defRPr sz="1500" b="1">
-                <a:solidFill>
-                  <a:srgbClr val="00D2FF"/>
-                </a:solidFill>
-                <a:latin typeface="Arial"/>
-              </a:defRPr>
-            </a:pPr>
-            <a:r>
-              <a:t>2. JPEG Compression Noise Defenses</a:t>
+              <a:t>• Distance is tracked frame-by-frame. Connection immediately killed and flagged if signature variation exceeds threshold (&gt;0.20).</a:t>
             </a:r>
           </a:p>
           <a:p>
             <a:pPr>
               <a:spcBef>
-                <a:spcPts val="500"/>
+                <a:spcPts val="800"/>
               </a:spcBef>
-              <a:defRPr sz="1200">
+              <a:defRPr sz="1400" b="1">
+                <a:solidFill>
+                  <a:srgbClr val="00FFAA"/>
+                </a:solidFill>
+                <a:latin typeface="Arial"/>
+              </a:defRPr>
+            </a:pPr>
+            <a:r>
+              <a:t>2. JPEG Compression Noise Defenses</a:t>
+            </a:r>
+          </a:p>
+          <a:p>
+            <a:pPr>
+              <a:spcAft>
+                <a:spcPts val="600"/>
+              </a:spcAft>
+              <a:defRPr sz="1100">
                 <a:solidFill>
                   <a:srgbClr val="F0F0F0"/>
                 </a:solidFill>
@@ -4777,81 +4623,35 @@
               </a:defRPr>
             </a:pPr>
             <a:r>
-              <a:t>Enhances classifier resilience against high-frequency adversarial texture attacks:</a:t>
+              <a:t>Filters high-frequency adversarial texture attacks:</a:t>
             </a:r>
             <a:br/>
             <a:r>
-              <a:t>• Implemented JPEG compression pre-processing directly into the face cropping stage.</a:t>
-            </a:r>
-            <a:br/>
-            <a:r>
-              <a:t>• Strategically filters out artificial spatial noise injected by digital mock spoofs or adversarial camera filters.</a:t>
-            </a:r>
-          </a:p>
-        </p:txBody>
-      </p:sp>
-      <p:sp>
-        <p:nvSpPr>
-          <p:cNvPr id="5" name="Rectangle 4"/>
-          <p:cNvSpPr/>
-          <p:nvPr/>
-        </p:nvSpPr>
-        <p:spPr>
-          <a:xfrm>
-            <a:off x="8183880" y="1645920"/>
-            <a:ext cx="3383280" cy="4206240"/>
-          </a:xfrm>
-          <a:prstGeom prst="rect">
-            <a:avLst/>
-          </a:prstGeom>
-          <a:solidFill>
-            <a:srgbClr val="1C202A"/>
-          </a:solidFill>
-          <a:ln w="19050">
-            <a:solidFill>
-              <a:srgbClr val="00FFAA"/>
-            </a:solidFill>
-          </a:ln>
-        </p:spPr>
-        <p:style>
-          <a:lnRef idx="1">
-            <a:schemeClr val="accent1"/>
-          </a:lnRef>
-          <a:fillRef idx="3">
-            <a:schemeClr val="accent1"/>
-          </a:fillRef>
-          <a:effectRef idx="2">
-            <a:schemeClr val="accent1"/>
-          </a:effectRef>
-          <a:fontRef idx="minor">
-            <a:schemeClr val="lt1"/>
-          </a:fontRef>
-        </p:style>
-        <p:txBody>
-          <a:bodyPr rtlCol="0" anchor="ctr" wrap="square" lIns="182880" tIns="182880" rIns="182880"/>
-          <a:lstStyle/>
-          <a:p>
-            <a:pPr algn="ctr">
-              <a:spcAft>
-                <a:spcPts val="1200"/>
-              </a:spcAft>
-              <a:defRPr sz="1500" b="1">
-                <a:solidFill>
-                  <a:srgbClr val="00D2FF"/>
-                </a:solidFill>
-                <a:latin typeface="Arial"/>
-              </a:defRPr>
-            </a:pPr>
-            <a:r>
-              <a:t>3. Multi-Constraint Grid Search Weight Optimizer</a:t>
+              <a:t>• Integrates compression filtering directly into the crop stages to wipe out artificial noise artifacts used by adversarial camera filters.</a:t>
             </a:r>
           </a:p>
           <a:p>
             <a:pPr>
               <a:spcBef>
-                <a:spcPts val="500"/>
+                <a:spcPts val="800"/>
               </a:spcBef>
-              <a:defRPr sz="1200">
+              <a:defRPr sz="1400" b="1">
+                <a:solidFill>
+                  <a:srgbClr val="00FFAA"/>
+                </a:solidFill>
+                <a:latin typeface="Arial"/>
+              </a:defRPr>
+            </a:pPr>
+            <a:r>
+              <a:t>3. Decision Fusion Engine Calibration</a:t>
+            </a:r>
+          </a:p>
+          <a:p>
+            <a:pPr>
+              <a:spcAft>
+                <a:spcPts val="600"/>
+              </a:spcAft>
+              <a:defRPr sz="1100">
                 <a:solidFill>
                   <a:srgbClr val="F0F0F0"/>
                 </a:solidFill>
@@ -4859,15 +4659,7 @@
               </a:defRPr>
             </a:pPr>
             <a:r>
-              <a:t>Calibrates decision fusion mathematically instead of using manual trial-and-error heuristics:</a:t>
-            </a:r>
-            <a:br/>
-            <a:r>
-              <a:t>• Developed a rigorous weight tuning algorithm verifying 1,771 separate parameter models.</a:t>
-            </a:r>
-            <a:br/>
-            <a:r>
-              <a:t>• Enforces a 10% minimum contribution check per sensor to eliminate sub-model silence.</a:t>
+              <a:t>• Optimized decision fusion weights (10% rPPG, 10% Blink, 15% Antispoof, and 65% Challenge) via multi-constraint grid search.</a:t>
             </a:r>
           </a:p>
         </p:txBody>
@@ -5117,7 +4909,7 @@
             </a:r>
             <a:br/>
             <a:r>
-              <a:t>2. Intercept Attack: We simulate printed photo attacks (rejected by rPPG and Texture sensors).</a:t>
+              <a:t>2. Intercept Attack: We simulate printed photo attacks (rejected by rPPG and Texture). </a:t>
             </a:r>
             <a:br/>
             <a:r>

</xml_diff>

<commit_message>
docs: Rewrite slides text and update colors to minimal industry-standard corporate slate blue
</commit_message>
<xml_diff>
--- a/reports/cdac_project_review.pptx
+++ b/reports/cdac_project_review.pptx
@@ -3126,7 +3126,7 @@
         <p:spPr>
           <a:xfrm>
             <a:off x="685800" y="731520"/>
-            <a:ext cx="5029200" cy="1645920"/>
+            <a:ext cx="5029200" cy="2011680"/>
           </a:xfrm>
           <a:prstGeom prst="rect">
             <a:avLst/>
@@ -3140,15 +3140,31 @@
           <a:lstStyle/>
           <a:p>
             <a:pPr>
-              <a:defRPr sz="4400" b="1">
-                <a:solidFill>
-                  <a:srgbClr val="00D2FF"/>
+              <a:defRPr sz="4600" b="1">
+                <a:solidFill>
+                  <a:srgbClr val="FFFFFF"/>
                 </a:solidFill>
                 <a:latin typeface="Arial"/>
               </a:defRPr>
             </a:pPr>
             <a:r>
               <a:t>SHIELD</a:t>
+            </a:r>
+          </a:p>
+          <a:p>
+            <a:pPr>
+              <a:spcBef>
+                <a:spcPts val="600"/>
+              </a:spcBef>
+              <a:defRPr sz="1800" b="1">
+                <a:solidFill>
+                  <a:srgbClr val="2979FF"/>
+                </a:solidFill>
+                <a:latin typeface="Arial"/>
+              </a:defRPr>
+            </a:pPr>
+            <a:r>
+              <a:t>Multimodal Real-Time Biometric Liveness &amp; Identity Verification System</a:t>
             </a:r>
           </a:p>
           <a:p>
@@ -3156,31 +3172,15 @@
               <a:spcBef>
                 <a:spcPts val="800"/>
               </a:spcBef>
-              <a:defRPr sz="2000" b="1">
-                <a:solidFill>
-                  <a:srgbClr val="F0F0F0"/>
+              <a:defRPr sz="1200">
+                <a:solidFill>
+                  <a:srgbClr val="8C96A5"/>
                 </a:solidFill>
                 <a:latin typeface="Arial"/>
               </a:defRPr>
             </a:pPr>
             <a:r>
-              <a:t>Secure Human Identity &amp; Liveness Evaluation Detection</a:t>
-            </a:r>
-          </a:p>
-          <a:p>
-            <a:pPr>
-              <a:spcBef>
-                <a:spcPts val="800"/>
-              </a:spcBef>
-              <a:defRPr sz="1300">
-                <a:solidFill>
-                  <a:srgbClr val="96A0AF"/>
-                </a:solidFill>
-                <a:latin typeface="Arial"/>
-              </a:defRPr>
-            </a:pPr>
-            <a:r>
-              <a:t>CDAC Project Review  |  Anti-Spoofing &amp; Biometrics</a:t>
+              <a:t>CDAC Project Review  |  Domain: Biometrics &amp; Computer Vision</a:t>
             </a:r>
           </a:p>
         </p:txBody>
@@ -3202,9 +3202,9 @@
           <a:solidFill>
             <a:srgbClr val="1C202A"/>
           </a:solidFill>
-          <a:ln w="19050">
+          <a:ln w="12700">
             <a:solidFill>
-              <a:srgbClr val="00D2FF"/>
+              <a:srgbClr val="37474F"/>
             </a:solidFill>
           </a:ln>
         </p:spPr>
@@ -3223,47 +3223,47 @@
           </a:fontRef>
         </p:style>
         <p:txBody>
-          <a:bodyPr rtlCol="0" anchor="ctr" wrap="square" lIns="182880" tIns="182880" rIns="182880" bIns="182880"/>
+          <a:bodyPr rtlCol="0" anchor="ctr" wrap="square" lIns="228600" tIns="228600" rIns="228600" bIns="228600"/>
           <a:lstStyle/>
           <a:p>
             <a:pPr algn="ctr">
-              <a:defRPr sz="1600" b="1">
-                <a:solidFill>
-                  <a:srgbClr val="00FFAA"/>
+              <a:defRPr sz="1500" b="1">
+                <a:solidFill>
+                  <a:srgbClr val="2979FF"/>
                 </a:solidFill>
                 <a:latin typeface="Arial"/>
               </a:defRPr>
             </a:pPr>
             <a:r>
-              <a:t>PROBLEM STATEMENT</a:t>
+              <a:t>PROBLEM FORMULATION</a:t>
             </a:r>
           </a:p>
           <a:p>
             <a:pPr>
               <a:spcBef>
-                <a:spcPts val="800"/>
+                <a:spcPts val="600"/>
               </a:spcBef>
-              <a:defRPr sz="1200">
-                <a:solidFill>
-                  <a:srgbClr val="F0F0F0"/>
+              <a:defRPr sz="1100">
+                <a:solidFill>
+                  <a:srgbClr val="D2D7DF"/>
                 </a:solidFill>
                 <a:latin typeface="Arial"/>
               </a:defRPr>
             </a:pPr>
             <a:r>
-              <a:t>Identity fraud compromises remote verification systems:</a:t>
+              <a:t>Remote biometric systems face vulnerabilities to spoofing:</a:t>
             </a:r>
             <a:br/>
             <a:r>
-              <a:t>• Spoof Attacks: Printed photos, screen video replays, and 3D silicone masks bypass typical biometrics.</a:t>
+              <a:t>• Presentation Attacks (PA): Static photo prints, video loop replays, and 3D masks deceive traditional facial recognition.</a:t>
             </a:r>
             <a:br/>
             <a:r>
-              <a:t>• Identity Swap Attacks: Users swap mid-session (tag-team attacks) during active sessions.</a:t>
+              <a:t>• Identity Swapping: User swaps mid-session (tag-team cheating) during active testing or authentication.</a:t>
             </a:r>
             <a:br/>
             <a:r>
-              <a:t>• Hardware Constraints: Existing defenses rely on costly 3D depth cameras, limiting massive deployments.</a:t>
+              <a:t>• Deployment Limits: Existing anti-spoofing methods require specialized depth hardware, rendering wide scale deployments impractical.</a:t>
             </a:r>
           </a:p>
         </p:txBody>
@@ -3317,9 +3317,9 @@
           <a:lstStyle/>
           <a:p>
             <a:pPr>
-              <a:defRPr sz="3600" b="1">
-                <a:solidFill>
-                  <a:srgbClr val="00D2FF"/>
+              <a:defRPr sz="3200" b="1">
+                <a:solidFill>
+                  <a:srgbClr val="2979FF"/>
                 </a:solidFill>
                 <a:latin typeface="Arial"/>
               </a:defRPr>
@@ -3356,9 +3356,9 @@
               <a:spcAft>
                 <a:spcPts val="1000"/>
               </a:spcAft>
-              <a:defRPr sz="2000" b="1">
-                <a:solidFill>
-                  <a:srgbClr val="00FFAA"/>
+              <a:defRPr sz="1800" b="1">
+                <a:solidFill>
+                  <a:srgbClr val="2979FF"/>
                 </a:solidFill>
                 <a:latin typeface="Arial"/>
               </a:defRPr>
@@ -3372,15 +3372,15 @@
               <a:spcAft>
                 <a:spcPts val="1200"/>
               </a:spcAft>
-              <a:defRPr sz="1400">
-                <a:solidFill>
-                  <a:srgbClr val="F0F0F0"/>
+              <a:defRPr sz="1300">
+                <a:solidFill>
+                  <a:srgbClr val="D2D7DF"/>
                 </a:solidFill>
                 <a:latin typeface="Arial"/>
               </a:defRPr>
             </a:pPr>
             <a:r>
-              <a:t>• Develop an end-to-end, ultra-low latency (&lt;100ms) multi-layered pipeline for biometric verification.</a:t>
+              <a:t>• Develop an end-to-end, real-time liveness pipeline processing multi-layered verification streams in &lt;100ms.</a:t>
             </a:r>
           </a:p>
           <a:p>
@@ -3388,15 +3388,15 @@
               <a:spcAft>
                 <a:spcPts val="1200"/>
               </a:spcAft>
-              <a:defRPr sz="1400">
-                <a:solidFill>
-                  <a:srgbClr val="F0F0F0"/>
+              <a:defRPr sz="1300">
+                <a:solidFill>
+                  <a:srgbClr val="D2D7DF"/>
                 </a:solidFill>
                 <a:latin typeface="Arial"/>
               </a:defRPr>
             </a:pPr>
             <a:r>
-              <a:t>• Implement non-intrusive biological checks (physiological heart-rate validation via rPPG) without dedicated sensors.</a:t>
+              <a:t>• Implement non-intrusive biological checks by extracting blood volume pulse (BVP) from standard RGB video feeds (rPPG).</a:t>
             </a:r>
           </a:p>
           <a:p>
@@ -3404,15 +3404,15 @@
               <a:spcAft>
                 <a:spcPts val="1200"/>
               </a:spcAft>
-              <a:defRPr sz="1400">
-                <a:solidFill>
-                  <a:srgbClr val="F0F0F0"/>
+              <a:defRPr sz="1300">
+                <a:solidFill>
+                  <a:srgbClr val="D2D7DF"/>
                 </a:solidFill>
                 <a:latin typeface="Arial"/>
               </a:defRPr>
             </a:pPr>
             <a:r>
-              <a:t>• Construct interactive active challenge-response tasks preventing pre-recorded synthetic deepfakes.</a:t>
+              <a:t>• Introduce randomized active challenge-response tasks combined with frame validation to counter pre-recorded replays.</a:t>
             </a:r>
           </a:p>
           <a:p>
@@ -3420,15 +3420,15 @@
               <a:spcAft>
                 <a:spcPts val="1200"/>
               </a:spcAft>
-              <a:defRPr sz="1400">
-                <a:solidFill>
-                  <a:srgbClr val="F0F0F0"/>
+              <a:defRPr sz="1300">
+                <a:solidFill>
+                  <a:srgbClr val="D2D7DF"/>
                 </a:solidFill>
                 <a:latin typeface="Arial"/>
               </a:defRPr>
             </a:pPr>
             <a:r>
-              <a:t>• Establish an explainable fusion architecture to provide forensic audit capability for each verification decision.</a:t>
+              <a:t>• Construct an explainable multi-modal decision fusion engine to facilitate detailed audit trails.</a:t>
             </a:r>
           </a:p>
         </p:txBody>
@@ -3459,111 +3459,111 @@
               <a:spcAft>
                 <a:spcPts val="1000"/>
               </a:spcAft>
-              <a:defRPr sz="2000" b="1">
-                <a:solidFill>
-                  <a:srgbClr val="00D2FF"/>
+              <a:defRPr sz="1800" b="1">
+                <a:solidFill>
+                  <a:srgbClr val="FFFFFF"/>
                 </a:solidFill>
                 <a:latin typeface="Arial"/>
               </a:defRPr>
             </a:pPr>
             <a:r>
-              <a:t>⚡ Engineering Target KPIs</a:t>
+              <a:t>⚙️ Engineering Targets &amp; KPIs</a:t>
             </a:r>
           </a:p>
           <a:p>
             <a:pPr>
               <a:spcBef>
-                <a:spcPts val="1000"/>
+                <a:spcPts val="800"/>
               </a:spcBef>
-              <a:defRPr sz="1600" b="1">
-                <a:solidFill>
-                  <a:srgbClr val="F0F0F0"/>
+              <a:defRPr sz="1400" b="1">
+                <a:solidFill>
+                  <a:srgbClr val="2979FF"/>
                 </a:solidFill>
                 <a:latin typeface="Arial"/>
               </a:defRPr>
             </a:pPr>
             <a:r>
-              <a:t>🔹 ISO/IEC 30107-3 Standard Compliance</a:t>
+              <a:t>▪️ ISO/IEC 30107-3 Standard Adherence</a:t>
             </a:r>
           </a:p>
           <a:p>
             <a:pPr>
               <a:spcAft>
-                <a:spcPts val="800"/>
+                <a:spcPts val="600"/>
               </a:spcAft>
-              <a:defRPr sz="1300">
-                <a:solidFill>
-                  <a:srgbClr val="96A0AF"/>
+              <a:defRPr sz="1200">
+                <a:solidFill>
+                  <a:srgbClr val="D2D7DF"/>
                 </a:solidFill>
                 <a:latin typeface="Arial"/>
               </a:defRPr>
             </a:pPr>
             <a:r>
-              <a:t>Targeting ACER (Average Classification Error Rate) below 1.5% to beat enterprise systems.</a:t>
+              <a:t>Deliver an ACER (Average Classification Error Rate) under 1.5% to verify enterprise-level security.</a:t>
             </a:r>
           </a:p>
           <a:p>
             <a:pPr>
               <a:spcBef>
-                <a:spcPts val="1000"/>
+                <a:spcPts val="800"/>
               </a:spcBef>
-              <a:defRPr sz="1600" b="1">
-                <a:solidFill>
-                  <a:srgbClr val="F0F0F0"/>
+              <a:defRPr sz="1400" b="1">
+                <a:solidFill>
+                  <a:srgbClr val="2979FF"/>
                 </a:solidFill>
                 <a:latin typeface="Arial"/>
               </a:defRPr>
             </a:pPr>
             <a:r>
-              <a:t>🔹 Edge-Compatible Latency Profiles</a:t>
+              <a:t>▪️ Edge-Deployable Performance</a:t>
             </a:r>
           </a:p>
           <a:p>
             <a:pPr>
               <a:spcAft>
-                <a:spcPts val="800"/>
+                <a:spcPts val="600"/>
               </a:spcAft>
-              <a:defRPr sz="1300">
-                <a:solidFill>
-                  <a:srgbClr val="96A0AF"/>
+              <a:defRPr sz="1200">
+                <a:solidFill>
+                  <a:srgbClr val="D2D7DF"/>
                 </a:solidFill>
                 <a:latin typeface="Arial"/>
               </a:defRPr>
             </a:pPr>
             <a:r>
-              <a:t>Ensure end-to-end processing (detection, crops, fusion, classification) runs in less than 100ms on CPU.</a:t>
+              <a:t>Optimize inference workloads to support execution in under 100ms on consumer-grade CPUs.</a:t>
             </a:r>
           </a:p>
           <a:p>
             <a:pPr>
               <a:spcBef>
-                <a:spcPts val="1000"/>
+                <a:spcPts val="800"/>
               </a:spcBef>
-              <a:defRPr sz="1600" b="1">
-                <a:solidFill>
-                  <a:srgbClr val="F0F0F0"/>
+              <a:defRPr sz="1400" b="1">
+                <a:solidFill>
+                  <a:srgbClr val="2979FF"/>
                 </a:solidFill>
                 <a:latin typeface="Arial"/>
               </a:defRPr>
             </a:pPr>
             <a:r>
-              <a:t>🔹 Zero-Dependency Webcam Deployment</a:t>
+              <a:t>▪️ Zero-Dependency RGB Deployment</a:t>
             </a:r>
           </a:p>
           <a:p>
             <a:pPr>
               <a:spcAft>
-                <a:spcPts val="800"/>
+                <a:spcPts val="600"/>
               </a:spcAft>
-              <a:defRPr sz="1300">
-                <a:solidFill>
-                  <a:srgbClr val="96A0AF"/>
+              <a:defRPr sz="1200">
+                <a:solidFill>
+                  <a:srgbClr val="D2D7DF"/>
                 </a:solidFill>
                 <a:latin typeface="Arial"/>
               </a:defRPr>
             </a:pPr>
             <a:r>
-              <a:t>Operate smoothly over normal RGB standard 2D webcams, eliminating hardware friction.</a:t>
+              <a:t>Perform biological, texture, and active checks using simple 2D webcams without dedicated sensors.</a:t>
             </a:r>
           </a:p>
         </p:txBody>
@@ -3617,15 +3617,15 @@
           <a:lstStyle/>
           <a:p>
             <a:pPr>
-              <a:defRPr sz="3600" b="1">
-                <a:solidFill>
-                  <a:srgbClr val="00D2FF"/>
+              <a:defRPr sz="3200" b="1">
+                <a:solidFill>
+                  <a:srgbClr val="2979FF"/>
                 </a:solidFill>
                 <a:latin typeface="Arial"/>
               </a:defRPr>
             </a:pPr>
             <a:r>
-              <a:t>System Architecture &amp; Methodology</a:t>
+              <a:t>System Architecture &amp; Flow</a:t>
             </a:r>
           </a:p>
         </p:txBody>
@@ -3655,20 +3655,20 @@
             <a:pPr algn="ctr">
               <a:defRPr sz="1500" b="1">
                 <a:solidFill>
-                  <a:srgbClr val="00D2FF"/>
+                  <a:srgbClr val="2979FF"/>
                 </a:solidFill>
                 <a:latin typeface="Arial"/>
               </a:defRPr>
             </a:pPr>
             <a:r>
-              <a:t>Camera Capture  ➡️  YOLOv8 Face Detection  ➡️  Signal Quality Gate  ➡️  Multimodal Inference  ➡️  Decision Fusion</a:t>
-            </a:r>
-          </a:p>
-        </p:txBody>
-      </p:sp>
-      <p:sp>
-        <p:nvSpPr>
-          <p:cNvPr id="4" name="Rounded Rectangle 3"/>
+              <a:t>Video Capture  ➔  YOLOv8 Face Detection  ➔  Quality telemetry  ➔  Multimodal Inference  ➔  Decision Fusion</a:t>
+            </a:r>
+          </a:p>
+        </p:txBody>
+      </p:sp>
+      <p:sp>
+        <p:nvSpPr>
+          <p:cNvPr id="4" name="Rectangle 3"/>
           <p:cNvSpPr/>
           <p:nvPr/>
         </p:nvSpPr>
@@ -3677,15 +3677,15 @@
             <a:off x="685800" y="2286000"/>
             <a:ext cx="2468880" cy="3840480"/>
           </a:xfrm>
-          <a:prstGeom prst="roundRect">
+          <a:prstGeom prst="rect">
             <a:avLst/>
           </a:prstGeom>
           <a:solidFill>
             <a:srgbClr val="1C202A"/>
           </a:solidFill>
-          <a:ln w="19050">
+          <a:ln w="12700">
             <a:solidFill>
-              <a:srgbClr val="00D2FF"/>
+              <a:srgbClr val="37474F"/>
             </a:solidFill>
           </a:ln>
         </p:spPr>
@@ -3708,9 +3708,9 @@
           <a:lstStyle/>
           <a:p>
             <a:pPr algn="ctr">
-              <a:defRPr sz="1600" b="1">
-                <a:solidFill>
-                  <a:srgbClr val="00FFAA"/>
+              <a:defRPr sz="1500" b="1">
+                <a:solidFill>
+                  <a:srgbClr val="FFFFFF"/>
                 </a:solidFill>
                 <a:latin typeface="Arial"/>
               </a:defRPr>
@@ -3724,15 +3724,15 @@
               <a:spcAft>
                 <a:spcPts val="1000"/>
               </a:spcAft>
-              <a:defRPr sz="1000" b="1">
-                <a:solidFill>
-                  <a:srgbClr val="96A0AF"/>
+              <a:defRPr sz="900" b="1">
+                <a:solidFill>
+                  <a:srgbClr val="2979FF"/>
                 </a:solidFill>
                 <a:latin typeface="Arial"/>
               </a:defRPr>
             </a:pPr>
             <a:r>
-              <a:t>CNN INFERENCE</a:t>
+              <a:t>SPATIAL TEXTURES</a:t>
             </a:r>
           </a:p>
           <a:p>
@@ -3740,22 +3740,22 @@
               <a:spcBef>
                 <a:spcPts val="500"/>
               </a:spcBef>
-              <a:defRPr sz="1200">
-                <a:solidFill>
-                  <a:srgbClr val="F0F0F0"/>
+              <a:defRPr sz="1150">
+                <a:solidFill>
+                  <a:srgbClr val="D2D7DF"/>
                 </a:solidFill>
                 <a:latin typeface="Arial"/>
               </a:defRPr>
             </a:pPr>
             <a:r>
-              <a:t>MiniFASNet CNN analyzing high-frequency texture cues to distinguish human skin from printed papers or screen pixels.</a:t>
-            </a:r>
-          </a:p>
-        </p:txBody>
-      </p:sp>
-      <p:sp>
-        <p:nvSpPr>
-          <p:cNvPr id="5" name="Rounded Rectangle 4"/>
+              <a:t>MiniFASNet CNN classification parsing high-frequency surface patterns to detect print paper/screen structures.</a:t>
+            </a:r>
+          </a:p>
+        </p:txBody>
+      </p:sp>
+      <p:sp>
+        <p:nvSpPr>
+          <p:cNvPr id="5" name="Rectangle 4"/>
           <p:cNvSpPr/>
           <p:nvPr/>
         </p:nvSpPr>
@@ -3764,15 +3764,15 @@
             <a:off x="3429000" y="2286000"/>
             <a:ext cx="2468880" cy="3840480"/>
           </a:xfrm>
-          <a:prstGeom prst="roundRect">
+          <a:prstGeom prst="rect">
             <a:avLst/>
           </a:prstGeom>
           <a:solidFill>
             <a:srgbClr val="1C202A"/>
           </a:solidFill>
-          <a:ln w="19050">
+          <a:ln w="12700">
             <a:solidFill>
-              <a:srgbClr val="00D2FF"/>
+              <a:srgbClr val="37474F"/>
             </a:solidFill>
           </a:ln>
         </p:spPr>
@@ -3795,9 +3795,9 @@
           <a:lstStyle/>
           <a:p>
             <a:pPr algn="ctr">
-              <a:defRPr sz="1600" b="1">
-                <a:solidFill>
-                  <a:srgbClr val="00FFAA"/>
+              <a:defRPr sz="1500" b="1">
+                <a:solidFill>
+                  <a:srgbClr val="FFFFFF"/>
                 </a:solidFill>
                 <a:latin typeface="Arial"/>
               </a:defRPr>
@@ -3811,15 +3811,15 @@
               <a:spcAft>
                 <a:spcPts val="1000"/>
               </a:spcAft>
-              <a:defRPr sz="1000" b="1">
-                <a:solidFill>
-                  <a:srgbClr val="96A0AF"/>
+              <a:defRPr sz="900" b="1">
+                <a:solidFill>
+                  <a:srgbClr val="2979FF"/>
                 </a:solidFill>
                 <a:latin typeface="Arial"/>
               </a:defRPr>
             </a:pPr>
             <a:r>
-              <a:t>BIOLOGICAL PULSE</a:t>
+              <a:t>HEART RATE PULSE</a:t>
             </a:r>
           </a:p>
           <a:p>
@@ -3827,22 +3827,22 @@
               <a:spcBef>
                 <a:spcPts val="500"/>
               </a:spcBef>
-              <a:defRPr sz="1200">
-                <a:solidFill>
-                  <a:srgbClr val="F0F0F0"/>
+              <a:defRPr sz="1150">
+                <a:solidFill>
+                  <a:srgbClr val="D2D7DF"/>
                 </a:solidFill>
                 <a:latin typeface="Arial"/>
               </a:defRPr>
             </a:pPr>
             <a:r>
-              <a:t>3D Spatio-Temporal CNN extracting blood volume pulse (BVP) from blood flow micro-fluctuations in skin.</a:t>
-            </a:r>
-          </a:p>
-        </p:txBody>
-      </p:sp>
-      <p:sp>
-        <p:nvSpPr>
-          <p:cNvPr id="6" name="Rounded Rectangle 5"/>
+              <a:t>3D spatio-temporal CNN extracting cardiac micro-signals from skin color shifts to verify living tissue.</a:t>
+            </a:r>
+          </a:p>
+        </p:txBody>
+      </p:sp>
+      <p:sp>
+        <p:nvSpPr>
+          <p:cNvPr id="6" name="Rectangle 5"/>
           <p:cNvSpPr/>
           <p:nvPr/>
         </p:nvSpPr>
@@ -3851,15 +3851,15 @@
             <a:off x="6172200" y="2286000"/>
             <a:ext cx="2468880" cy="3840480"/>
           </a:xfrm>
-          <a:prstGeom prst="roundRect">
+          <a:prstGeom prst="rect">
             <a:avLst/>
           </a:prstGeom>
           <a:solidFill>
             <a:srgbClr val="1C202A"/>
           </a:solidFill>
-          <a:ln w="19050">
+          <a:ln w="12700">
             <a:solidFill>
-              <a:srgbClr val="00D2FF"/>
+              <a:srgbClr val="37474F"/>
             </a:solidFill>
           </a:ln>
         </p:spPr>
@@ -3882,9 +3882,9 @@
           <a:lstStyle/>
           <a:p>
             <a:pPr algn="ctr">
-              <a:defRPr sz="1600" b="1">
-                <a:solidFill>
-                  <a:srgbClr val="00FFAA"/>
+              <a:defRPr sz="1500" b="1">
+                <a:solidFill>
+                  <a:srgbClr val="FFFFFF"/>
                 </a:solidFill>
                 <a:latin typeface="Arial"/>
               </a:defRPr>
@@ -3898,15 +3898,15 @@
               <a:spcAft>
                 <a:spcPts val="1000"/>
               </a:spcAft>
-              <a:defRPr sz="1000" b="1">
-                <a:solidFill>
-                  <a:srgbClr val="96A0AF"/>
+              <a:defRPr sz="900" b="1">
+                <a:solidFill>
+                  <a:srgbClr val="2979FF"/>
                 </a:solidFill>
                 <a:latin typeface="Arial"/>
               </a:defRPr>
             </a:pPr>
             <a:r>
-              <a:t>CHALLENGE-RESPONSE</a:t>
+              <a:t>CHALLENGE ACTIONS</a:t>
             </a:r>
           </a:p>
           <a:p>
@@ -3914,22 +3914,22 @@
               <a:spcBef>
                 <a:spcPts val="500"/>
               </a:spcBef>
-              <a:defRPr sz="1200">
-                <a:solidFill>
-                  <a:srgbClr val="F0F0F0"/>
+              <a:defRPr sz="1150">
+                <a:solidFill>
+                  <a:srgbClr val="D2D7DF"/>
                 </a:solidFill>
                 <a:latin typeface="Arial"/>
               </a:defRPr>
             </a:pPr>
             <a:r>
-              <a:t>Randomized directives (Smile, Blink, Turn) generated by ChallengeEngine to ensure presence.</a:t>
-            </a:r>
-          </a:p>
-        </p:txBody>
-      </p:sp>
-      <p:sp>
-        <p:nvSpPr>
-          <p:cNvPr id="7" name="Rounded Rectangle 6"/>
+              <a:t>Randomized directives (Blink, Turn, Smile) validated dynamically to establish immediate user cooperation.</a:t>
+            </a:r>
+          </a:p>
+        </p:txBody>
+      </p:sp>
+      <p:sp>
+        <p:nvSpPr>
+          <p:cNvPr id="7" name="Rectangle 6"/>
           <p:cNvSpPr/>
           <p:nvPr/>
         </p:nvSpPr>
@@ -3938,15 +3938,15 @@
             <a:off x="8915400" y="2286000"/>
             <a:ext cx="2468880" cy="3840480"/>
           </a:xfrm>
-          <a:prstGeom prst="roundRect">
+          <a:prstGeom prst="rect">
             <a:avLst/>
           </a:prstGeom>
           <a:solidFill>
             <a:srgbClr val="1C202A"/>
           </a:solidFill>
-          <a:ln w="19050">
+          <a:ln w="12700">
             <a:solidFill>
-              <a:srgbClr val="00D2FF"/>
+              <a:srgbClr val="37474F"/>
             </a:solidFill>
           </a:ln>
         </p:spPr>
@@ -3969,15 +3969,15 @@
           <a:lstStyle/>
           <a:p>
             <a:pPr algn="ctr">
-              <a:defRPr sz="1600" b="1">
-                <a:solidFill>
-                  <a:srgbClr val="00FFAA"/>
+              <a:defRPr sz="1500" b="1">
+                <a:solidFill>
+                  <a:srgbClr val="FFFFFF"/>
                 </a:solidFill>
                 <a:latin typeface="Arial"/>
               </a:defRPr>
             </a:pPr>
             <a:r>
-              <a:t>4. Temporal Audit</a:t>
+              <a:t>4. Temporal Validator</a:t>
             </a:r>
           </a:p>
           <a:p>
@@ -3985,15 +3985,15 @@
               <a:spcAft>
                 <a:spcPts val="1000"/>
               </a:spcAft>
-              <a:defRPr sz="1000" b="1">
-                <a:solidFill>
-                  <a:srgbClr val="96A0AF"/>
+              <a:defRPr sz="900" b="1">
+                <a:solidFill>
+                  <a:srgbClr val="2979FF"/>
                 </a:solidFill>
                 <a:latin typeface="Arial"/>
               </a:defRPr>
             </a:pPr>
             <a:r>
-              <a:t>JUMP-CUT CHECK</a:t>
+              <a:t>TEMPORAL CUTS</a:t>
             </a:r>
           </a:p>
           <a:p>
@@ -4001,15 +4001,15 @@
               <a:spcBef>
                 <a:spcPts val="500"/>
               </a:spcBef>
-              <a:defRPr sz="1200">
-                <a:solidFill>
-                  <a:srgbClr val="F0F0F0"/>
+              <a:defRPr sz="1150">
+                <a:solidFill>
+                  <a:srgbClr val="D2D7DF"/>
                 </a:solidFill>
                 <a:latin typeface="Arial"/>
               </a:defRPr>
             </a:pPr>
             <a:r>
-              <a:t>TemporalValidator matching challenge execution times and checking for jump-cut manipulations.</a:t>
+              <a:t>Time-series integrity checking to trace jump-cuts and confirm time sync between challenge events.</a:t>
             </a:r>
           </a:p>
         </p:txBody>
@@ -4079,9 +4079,9 @@
           <a:lstStyle/>
           <a:p>
             <a:pPr>
-              <a:defRPr sz="3600" b="1">
-                <a:solidFill>
-                  <a:srgbClr val="00D2FF"/>
+              <a:defRPr sz="3200" b="1">
+                <a:solidFill>
+                  <a:srgbClr val="FFFFFF"/>
                 </a:solidFill>
                 <a:latin typeface="Arial"/>
               </a:defRPr>
@@ -4123,13 +4123,13 @@
                       <a:pPr algn="ctr">
                         <a:defRPr sz="1300" b="1">
                           <a:solidFill>
-                            <a:srgbClr val="00D2FF"/>
+                            <a:srgbClr val="2979FF"/>
                           </a:solidFill>
                           <a:latin typeface="Arial"/>
                         </a:defRPr>
                       </a:pPr>
                       <a:r>
-                        <a:t>Metric Name</a:t>
+                        <a:t>Metric Parameter</a:t>
                       </a:r>
                     </a:p>
                   </a:txBody>
@@ -4147,7 +4147,7 @@
                       <a:pPr algn="ctr">
                         <a:defRPr sz="1300" b="1">
                           <a:solidFill>
-                            <a:srgbClr val="00D2FF"/>
+                            <a:srgbClr val="2979FF"/>
                           </a:solidFill>
                           <a:latin typeface="Arial"/>
                         </a:defRPr>
@@ -4173,13 +4173,13 @@
                       <a:pPr algn="ctr">
                         <a:defRPr sz="1100">
                           <a:solidFill>
-                            <a:srgbClr val="F0F0F0"/>
+                            <a:srgbClr val="D2D7DF"/>
                           </a:solidFill>
                           <a:latin typeface="Arial"/>
                         </a:defRPr>
                       </a:pPr>
                       <a:r>
-                        <a:t>APCER (Attack Error)</a:t>
+                        <a:t>APCER (Attack Error Rate)</a:t>
                       </a:r>
                     </a:p>
                   </a:txBody>
@@ -4197,7 +4197,7 @@
                       <a:pPr algn="ctr">
                         <a:defRPr sz="1100" b="1">
                           <a:solidFill>
-                            <a:srgbClr val="00FFAA"/>
+                            <a:srgbClr val="FFFFFF"/>
                           </a:solidFill>
                           <a:latin typeface="Arial"/>
                         </a:defRPr>
@@ -4223,13 +4223,13 @@
                       <a:pPr algn="ctr">
                         <a:defRPr sz="1100">
                           <a:solidFill>
-                            <a:srgbClr val="F0F0F0"/>
+                            <a:srgbClr val="D2D7DF"/>
                           </a:solidFill>
                           <a:latin typeface="Arial"/>
                         </a:defRPr>
                       </a:pPr>
                       <a:r>
-                        <a:t>BPCER (Bona Fide Error)</a:t>
+                        <a:t>BPCER (Bona Fide Error Rate)</a:t>
                       </a:r>
                     </a:p>
                   </a:txBody>
@@ -4247,7 +4247,7 @@
                       <a:pPr algn="ctr">
                         <a:defRPr sz="1100" b="1">
                           <a:solidFill>
-                            <a:srgbClr val="00FFAA"/>
+                            <a:srgbClr val="FFFFFF"/>
                           </a:solidFill>
                           <a:latin typeface="Arial"/>
                         </a:defRPr>
@@ -4273,13 +4273,13 @@
                       <a:pPr algn="ctr">
                         <a:defRPr sz="1100">
                           <a:solidFill>
-                            <a:srgbClr val="F0F0F0"/>
+                            <a:srgbClr val="D2D7DF"/>
                           </a:solidFill>
                           <a:latin typeface="Arial"/>
                         </a:defRPr>
                       </a:pPr>
                       <a:r>
-                        <a:t>ACER (Average Error)</a:t>
+                        <a:t>ACER (Average Error Rate)</a:t>
                       </a:r>
                     </a:p>
                   </a:txBody>
@@ -4297,7 +4297,7 @@
                       <a:pPr algn="ctr">
                         <a:defRPr sz="1100" b="1">
                           <a:solidFill>
-                            <a:srgbClr val="00FFAA"/>
+                            <a:srgbClr val="FFFFFF"/>
                           </a:solidFill>
                           <a:latin typeface="Arial"/>
                         </a:defRPr>
@@ -4323,13 +4323,13 @@
                       <a:pPr algn="ctr">
                         <a:defRPr sz="1100">
                           <a:solidFill>
-                            <a:srgbClr val="F0F0F0"/>
+                            <a:srgbClr val="D2D7DF"/>
                           </a:solidFill>
                           <a:latin typeface="Arial"/>
                         </a:defRPr>
                       </a:pPr>
                       <a:r>
-                        <a:t>Inference Latency</a:t>
+                        <a:t>End-to-End Inference Latency</a:t>
                       </a:r>
                     </a:p>
                   </a:txBody>
@@ -4347,7 +4347,7 @@
                       <a:pPr algn="ctr">
                         <a:defRPr sz="1100" b="1">
                           <a:solidFill>
-                            <a:srgbClr val="00FFAA"/>
+                            <a:srgbClr val="FFFFFF"/>
                           </a:solidFill>
                           <a:latin typeface="Arial"/>
                         </a:defRPr>
@@ -4396,13 +4396,13 @@
               </a:spcAft>
               <a:defRPr sz="1600" b="1">
                 <a:solidFill>
-                  <a:srgbClr val="00FFAA"/>
+                  <a:srgbClr val="2979FF"/>
                 </a:solidFill>
                 <a:latin typeface="Arial"/>
               </a:defRPr>
             </a:pPr>
             <a:r>
-              <a:t>📊 Dataset &amp; Optimization Results</a:t>
+              <a:t>📊 Experimental Evaluation Setup</a:t>
             </a:r>
           </a:p>
           <a:p>
@@ -4412,13 +4412,13 @@
               </a:spcAft>
               <a:defRPr sz="1100">
                 <a:solidFill>
-                  <a:srgbClr val="F0F0F0"/>
+                  <a:srgbClr val="D2D7DF"/>
                 </a:solidFill>
                 <a:latin typeface="Arial"/>
               </a:defRPr>
             </a:pPr>
             <a:r>
-              <a:t>• Tested on unified sets of CASIA-FASD and CelebA-Spoof datasets, comprising over 10,000 frames.</a:t>
+              <a:t>▪️ Benchmarked against unified subsets of CASIA-FASD and CelebA-Spoof, containing over 10,000 frames under diverse ambient variables.</a:t>
             </a:r>
           </a:p>
           <a:p>
@@ -4428,13 +4428,13 @@
               </a:spcAft>
               <a:defRPr sz="1100">
                 <a:solidFill>
-                  <a:srgbClr val="F0F0F0"/>
+                  <a:srgbClr val="D2D7DF"/>
                 </a:solidFill>
                 <a:latin typeface="Arial"/>
               </a:defRPr>
             </a:pPr>
             <a:r>
-              <a:t>• Real-Time evaluation verified WebSockets frame streaming rate above 30 FPS.</a:t>
+              <a:t>▪️ Verified streaming processing speed exceeding 30 FPS.</a:t>
             </a:r>
           </a:p>
           <a:p>
@@ -4444,13 +4444,13 @@
               </a:spcAft>
               <a:defRPr sz="1100">
                 <a:solidFill>
-                  <a:srgbClr val="F0F0F0"/>
+                  <a:srgbClr val="D2D7DF"/>
                 </a:solidFill>
                 <a:latin typeface="Arial"/>
               </a:defRPr>
             </a:pPr>
             <a:r>
-              <a:t>• Weighted Decision Fusion: Calibrated dynamically using grid search over 1,771 separate sensor weight parameter combinations.</a:t>
+              <a:t>▪️ Optimized fusion weight configuration (10% rPPG, 10% Blink, 15% Antispoof, 65% Challenge) via programmatic grid-search.</a:t>
             </a:r>
           </a:p>
         </p:txBody>
@@ -4520,15 +4520,15 @@
           <a:lstStyle/>
           <a:p>
             <a:pPr>
-              <a:defRPr sz="3600" b="1">
-                <a:solidFill>
-                  <a:srgbClr val="00D2FF"/>
+              <a:defRPr sz="3200" b="1">
+                <a:solidFill>
+                  <a:srgbClr val="FFFFFF"/>
                 </a:solidFill>
                 <a:latin typeface="Arial"/>
               </a:defRPr>
             </a:pPr>
             <a:r>
-              <a:t>Novelty &amp; Key Contributions</a:t>
+              <a:t>Novelty &amp; Custom Contributions</a:t>
             </a:r>
           </a:p>
         </p:txBody>
@@ -4561,7 +4561,7 @@
               </a:spcBef>
               <a:defRPr sz="1400" b="1">
                 <a:solidFill>
-                  <a:srgbClr val="00FFAA"/>
+                  <a:srgbClr val="2979FF"/>
                 </a:solidFill>
                 <a:latin typeface="Arial"/>
               </a:defRPr>
@@ -4577,21 +4577,21 @@
               </a:spcAft>
               <a:defRPr sz="1100">
                 <a:solidFill>
-                  <a:srgbClr val="F0F0F0"/>
+                  <a:srgbClr val="D2D7DF"/>
                 </a:solidFill>
                 <a:latin typeface="Arial"/>
               </a:defRPr>
             </a:pPr>
             <a:r>
-              <a:t>Defeats mid-session user swaps (tag-team candidate swaps):</a:t>
+              <a:t>Defeats mid-session candidate swapping (tag-team fraud):</a:t>
             </a:r>
             <a:br/>
             <a:r>
-              <a:t>• Computes scale-invariant 4D signature ratios (nose, eyes, chin, lip corners) via MediaPipe FaceMesh geometry.</a:t>
+              <a:t>• Computes scale-invariant 4D geometric signature ratios (nose, eyes, chin, lip corners) using MediaPipe FaceMesh landmarks.</a:t>
             </a:r>
             <a:br/>
             <a:r>
-              <a:t>• Distance is tracked frame-by-frame. Connection immediately killed and flagged if signature variation exceeds threshold (&gt;0.20).</a:t>
+              <a:t>• Signature distance is verified frame-by-frame. Websocket is killed immediately if signature drift exceeds threshold (&gt;0.20).</a:t>
             </a:r>
           </a:p>
           <a:p>
@@ -4601,13 +4601,13 @@
               </a:spcBef>
               <a:defRPr sz="1400" b="1">
                 <a:solidFill>
-                  <a:srgbClr val="00FFAA"/>
+                  <a:srgbClr val="2979FF"/>
                 </a:solidFill>
                 <a:latin typeface="Arial"/>
               </a:defRPr>
             </a:pPr>
             <a:r>
-              <a:t>2. JPEG Compression Noise Defenses</a:t>
+              <a:t>2. JPEG Compression Defenses</a:t>
             </a:r>
           </a:p>
           <a:p>
@@ -4617,17 +4617,17 @@
               </a:spcAft>
               <a:defRPr sz="1100">
                 <a:solidFill>
-                  <a:srgbClr val="F0F0F0"/>
+                  <a:srgbClr val="D2D7DF"/>
                 </a:solidFill>
                 <a:latin typeface="Arial"/>
               </a:defRPr>
             </a:pPr>
             <a:r>
-              <a:t>Filters high-frequency adversarial texture attacks:</a:t>
+              <a:t>Enhances resilience against adversarial spatial noise attacks:</a:t>
             </a:r>
             <a:br/>
             <a:r>
-              <a:t>• Integrates compression filtering directly into the crop stages to wipe out artificial noise artifacts used by adversarial camera filters.</a:t>
+              <a:t>• Integrates compression filters into the face crop step to cancel out artificial noise patterns generated by digital camera overlays.</a:t>
             </a:r>
           </a:p>
           <a:p>
@@ -4637,13 +4637,13 @@
               </a:spcBef>
               <a:defRPr sz="1400" b="1">
                 <a:solidFill>
-                  <a:srgbClr val="00FFAA"/>
+                  <a:srgbClr val="2979FF"/>
                 </a:solidFill>
                 <a:latin typeface="Arial"/>
               </a:defRPr>
             </a:pPr>
             <a:r>
-              <a:t>3. Decision Fusion Engine Calibration</a:t>
+              <a:t>3. Systematic Grid Search Optimization</a:t>
             </a:r>
           </a:p>
           <a:p>
@@ -4653,13 +4653,13 @@
               </a:spcAft>
               <a:defRPr sz="1100">
                 <a:solidFill>
-                  <a:srgbClr val="F0F0F0"/>
+                  <a:srgbClr val="D2D7DF"/>
                 </a:solidFill>
                 <a:latin typeface="Arial"/>
               </a:defRPr>
             </a:pPr>
             <a:r>
-              <a:t>• Optimized decision fusion weights (10% rPPG, 10% Blink, 15% Antispoof, and 65% Challenge) via multi-constraint grid search.</a:t>
+              <a:t>• Evaluated 1,771 separate sensor weight parameter combinations mathematically to eliminate sub-model silence.</a:t>
             </a:r>
           </a:p>
         </p:txBody>
@@ -4713,9 +4713,9 @@
           <a:lstStyle/>
           <a:p>
             <a:pPr>
-              <a:defRPr sz="3600" b="1">
-                <a:solidFill>
-                  <a:srgbClr val="00D2FF"/>
+              <a:defRPr sz="3200" b="1">
+                <a:solidFill>
+                  <a:srgbClr val="2979FF"/>
                 </a:solidFill>
                 <a:latin typeface="Arial"/>
               </a:defRPr>
@@ -4728,7 +4728,7 @@
       </p:sp>
       <p:sp>
         <p:nvSpPr>
-          <p:cNvPr id="3" name="Rounded Rectangle 2"/>
+          <p:cNvPr id="3" name="Rectangle 2"/>
           <p:cNvSpPr/>
           <p:nvPr/>
         </p:nvSpPr>
@@ -4737,15 +4737,15 @@
             <a:off x="685800" y="1645920"/>
             <a:ext cx="5120640" cy="4114800"/>
           </a:xfrm>
-          <a:prstGeom prst="roundRect">
+          <a:prstGeom prst="rect">
             <a:avLst/>
           </a:prstGeom>
           <a:solidFill>
             <a:srgbClr val="1C202A"/>
           </a:solidFill>
-          <a:ln w="19050">
+          <a:ln w="12700">
             <a:solidFill>
-              <a:srgbClr val="00D2FF"/>
+              <a:srgbClr val="37474F"/>
             </a:solidFill>
           </a:ln>
         </p:spPr>
@@ -4773,13 +4773,13 @@
               </a:spcAft>
               <a:defRPr sz="1800" b="1">
                 <a:solidFill>
-                  <a:srgbClr val="00FFAA"/>
+                  <a:srgbClr val="FFFFFF"/>
                 </a:solidFill>
                 <a:latin typeface="Arial"/>
               </a:defRPr>
             </a:pPr>
             <a:r>
-              <a:t>📱 Immersive Flutter Telemetry Panel</a:t>
+              <a:t>📱 Interactive Flutter Telemetry Dashboard</a:t>
             </a:r>
           </a:p>
           <a:p>
@@ -4789,13 +4789,13 @@
               </a:spcAft>
               <a:defRPr sz="1300">
                 <a:solidFill>
-                  <a:srgbClr val="F0F0F0"/>
+                  <a:srgbClr val="D2D7DF"/>
                 </a:solidFill>
                 <a:latin typeface="Arial"/>
               </a:defRPr>
             </a:pPr>
             <a:r>
-              <a:t>• Real-Time Guidance Frame: An interactive oval boundary changing colors based on quality metrics (Red: Pose mismatch, Blue: Poor lighting, Green: Perfect).</a:t>
+              <a:t>• Quality Telemetry Guide: Interactive oval frame changing colors dynamically based on real-time quality parameters (Blur, Exposure, Pose).</a:t>
             </a:r>
           </a:p>
           <a:p>
@@ -4805,13 +4805,13 @@
               </a:spcAft>
               <a:defRPr sz="1300">
                 <a:solidFill>
-                  <a:srgbClr val="F0F0F0"/>
+                  <a:srgbClr val="D2D7DF"/>
                 </a:solidFill>
                 <a:latin typeface="Arial"/>
               </a:defRPr>
             </a:pPr>
             <a:r>
-              <a:t>• Explainable Verdicts: Integrates real-time live telemetry cards showing dynamic confidence ratings for each modal sensor (texture, physiology, challenges).</a:t>
+              <a:t>• Explainable Biometrics: Displays clear confidence breakdowns for texture, biological rPPG, and active challenge scores in real-time.</a:t>
             </a:r>
           </a:p>
           <a:p>
@@ -4821,20 +4821,20 @@
               </a:spcAft>
               <a:defRPr sz="1300">
                 <a:solidFill>
-                  <a:srgbClr val="F0F0F0"/>
+                  <a:srgbClr val="D2D7DF"/>
                 </a:solidFill>
                 <a:latin typeface="Arial"/>
               </a:defRPr>
             </a:pPr>
             <a:r>
-              <a:t>• Pre-verification Gateway: Users are trained with tips and guidelines prior to starting high-stakes interview challenge verification sessions.</a:t>
-            </a:r>
-          </a:p>
-        </p:txBody>
-      </p:sp>
-      <p:sp>
-        <p:nvSpPr>
-          <p:cNvPr id="4" name="Rounded Rectangle 3"/>
+              <a:t>• Secure Ingestion Gateway: Informs user of capture instructions prior to starting high-stakes verification flows.</a:t>
+            </a:r>
+          </a:p>
+        </p:txBody>
+      </p:sp>
+      <p:sp>
+        <p:nvSpPr>
+          <p:cNvPr id="4" name="Rectangle 3"/>
           <p:cNvSpPr/>
           <p:nvPr/>
         </p:nvSpPr>
@@ -4843,15 +4843,15 @@
             <a:off x="6217920" y="1645920"/>
             <a:ext cx="5212080" cy="4114800"/>
           </a:xfrm>
-          <a:prstGeom prst="roundRect">
+          <a:prstGeom prst="rect">
             <a:avLst/>
           </a:prstGeom>
           <a:solidFill>
             <a:srgbClr val="1C202A"/>
           </a:solidFill>
-          <a:ln w="19050">
+          <a:ln w="12700">
             <a:solidFill>
-              <a:srgbClr val="00D2FF"/>
+              <a:srgbClr val="37474F"/>
             </a:solidFill>
           </a:ln>
         </p:spPr>
@@ -4879,13 +4879,13 @@
               </a:spcAft>
               <a:defRPr sz="1800" b="1">
                 <a:solidFill>
-                  <a:srgbClr val="00D2FF"/>
+                  <a:srgbClr val="2979FF"/>
                 </a:solidFill>
                 <a:latin typeface="Arial"/>
               </a:defRPr>
             </a:pPr>
             <a:r>
-              <a:t>🎥 Interactive Live Demonstration</a:t>
+              <a:t>🎥 Live Demonstration Protocol</a:t>
             </a:r>
           </a:p>
           <a:p>
@@ -4895,34 +4895,34 @@
               </a:spcBef>
               <a:defRPr sz="1200">
                 <a:solidFill>
-                  <a:srgbClr val="F0F0F0"/>
+                  <a:srgbClr val="D2D7DF"/>
                 </a:solidFill>
                 <a:latin typeface="Arial"/>
               </a:defRPr>
             </a:pPr>
             <a:r>
-              <a:t>Our validation pipeline streams video frames from a Flutter client webcam to our FastAPI server over WebSockets:</a:t>
+              <a:t>Websocket-based real-time capture and verification pipeline:</a:t>
             </a:r>
             <a:br/>
             <a:r>
-              <a:t>1. Start verification: A target challenge is selected randomly (e.g., blink task).</a:t>
+              <a:t>1. Active Verification: Core session starts, requesting random user movements.</a:t>
             </a:r>
             <a:br/>
             <a:r>
-              <a:t>2. Intercept Attack: We simulate printed photo attacks (rejected by rPPG and Texture). </a:t>
+              <a:t>2. Print Spoof Defense: User presents photo print, system immediately blocks frame based on texture and heart-rate checks.</a:t>
             </a:r>
             <a:br/>
             <a:r>
-              <a:t>3. Intercept Replay: We play digital replay loop (rejected by Active Challenge &amp; Temporal validation).</a:t>
+              <a:t>3. Replay Loop Defense: Dynamic challenge mismatch catches loop playbacks.</a:t>
             </a:r>
             <a:br/>
             <a:r>
-              <a:t>4. Intercept Swap: A second user swaps with candidate mid-session (rejected by scale-invariant landmarks check).</a:t>
+              <a:t>4. Identity Swap Defense: Mid-session candidate swap triggers geometric landmark signature mismatch, killing the connection instantly.</a:t>
             </a:r>
             <a:br/>
             <a:br/>
             <a:r>
-              <a:t>The complete system workflow and testing suites are fully verified in the live code repository.</a:t>
+              <a:t>Execution logs and test coverage verify the robust integration.</a:t>
             </a:r>
           </a:p>
         </p:txBody>

</xml_diff>

<commit_message>
docs: Add partners/guide info and configure rounded corners for all card shapes
</commit_message>
<xml_diff>
--- a/reports/cdac_project_review.pptx
+++ b/reports/cdac_project_review.pptx
@@ -3125,8 +3125,8 @@
         </p:nvSpPr>
         <p:spPr>
           <a:xfrm>
-            <a:off x="685800" y="731520"/>
-            <a:ext cx="5029200" cy="2011680"/>
+            <a:off x="685800" y="365760"/>
+            <a:ext cx="5029200" cy="1463040"/>
           </a:xfrm>
           <a:prstGeom prst="rect">
             <a:avLst/>
@@ -3134,13 +3134,13 @@
           <a:noFill/>
         </p:spPr>
         <p:txBody>
-          <a:bodyPr wrap="square">
+          <a:bodyPr wrap="square" lIns="0" tIns="0" rIns="0" bIns="0">
             <a:spAutoFit/>
           </a:bodyPr>
           <a:lstStyle/>
           <a:p>
             <a:pPr>
-              <a:defRPr sz="4600" b="1">
+              <a:defRPr sz="4200" b="1">
                 <a:solidFill>
                   <a:srgbClr val="FFFFFF"/>
                 </a:solidFill>
@@ -3156,7 +3156,7 @@
               <a:spcBef>
                 <a:spcPts val="600"/>
               </a:spcBef>
-              <a:defRPr sz="1800" b="1">
+              <a:defRPr sz="1500" b="1">
                 <a:solidFill>
                   <a:srgbClr val="2979FF"/>
                 </a:solidFill>
@@ -3165,14 +3165,66 @@
             </a:pPr>
             <a:r>
               <a:t>Multimodal Real-Time Biometric Liveness &amp; Identity Verification System</a:t>
+            </a:r>
+          </a:p>
+        </p:txBody>
+      </p:sp>
+      <p:sp>
+        <p:nvSpPr>
+          <p:cNvPr id="4" name="TextBox 3"/>
+          <p:cNvSpPr txBox="1"/>
+          <p:nvPr/>
+        </p:nvSpPr>
+        <p:spPr>
+          <a:xfrm>
+            <a:off x="685800" y="1920240"/>
+            <a:ext cx="5029200" cy="1005840"/>
+          </a:xfrm>
+          <a:prstGeom prst="rect">
+            <a:avLst/>
+          </a:prstGeom>
+          <a:noFill/>
+        </p:spPr>
+        <p:txBody>
+          <a:bodyPr wrap="square" lIns="0" tIns="0" rIns="0" bIns="0">
+            <a:spAutoFit/>
+          </a:bodyPr>
+          <a:lstStyle/>
+          <a:p>
+            <a:pPr>
+              <a:defRPr sz="1150" b="1">
+                <a:solidFill>
+                  <a:srgbClr val="D2D7DF"/>
+                </a:solidFill>
+                <a:latin typeface="Arial"/>
+              </a:defRPr>
+            </a:pPr>
+            <a:r>
+              <a:t>Project Partners: Sthavir Sunil Punwatkar, [Project Partner 2]</a:t>
             </a:r>
           </a:p>
           <a:p>
             <a:pPr>
               <a:spcBef>
-                <a:spcPts val="800"/>
+                <a:spcPts val="300"/>
               </a:spcBef>
-              <a:defRPr sz="1200">
+              <a:defRPr sz="1150" b="1">
+                <a:solidFill>
+                  <a:srgbClr val="D2D7DF"/>
+                </a:solidFill>
+                <a:latin typeface="Arial"/>
+              </a:defRPr>
+            </a:pPr>
+            <a:r>
+              <a:t>Project Guide: [Project Guide Name]</a:t>
+            </a:r>
+          </a:p>
+          <a:p>
+            <a:pPr>
+              <a:spcBef>
+                <a:spcPts val="500"/>
+              </a:spcBef>
+              <a:defRPr sz="1150">
                 <a:solidFill>
                   <a:srgbClr val="8C96A5"/>
                 </a:solidFill>
@@ -3187,16 +3239,16 @@
       </p:sp>
       <p:sp>
         <p:nvSpPr>
-          <p:cNvPr id="4" name="Rectangle 3"/>
+          <p:cNvPr id="5" name="Rounded Rectangle 4"/>
           <p:cNvSpPr/>
           <p:nvPr/>
         </p:nvSpPr>
         <p:spPr>
           <a:xfrm>
-            <a:off x="685800" y="2926080"/>
-            <a:ext cx="5029200" cy="3200400"/>
+            <a:off x="685800" y="3017520"/>
+            <a:ext cx="5029200" cy="3291840"/>
           </a:xfrm>
-          <a:prstGeom prst="rect">
+          <a:prstGeom prst="roundRect">
             <a:avLst/>
           </a:prstGeom>
           <a:solidFill>
@@ -3668,7 +3720,7 @@
       </p:sp>
       <p:sp>
         <p:nvSpPr>
-          <p:cNvPr id="4" name="Rectangle 3"/>
+          <p:cNvPr id="4" name="Rounded Rectangle 3"/>
           <p:cNvSpPr/>
           <p:nvPr/>
         </p:nvSpPr>
@@ -3677,7 +3729,7 @@
             <a:off x="685800" y="2286000"/>
             <a:ext cx="2468880" cy="3840480"/>
           </a:xfrm>
-          <a:prstGeom prst="rect">
+          <a:prstGeom prst="roundRect">
             <a:avLst/>
           </a:prstGeom>
           <a:solidFill>
@@ -3755,7 +3807,7 @@
       </p:sp>
       <p:sp>
         <p:nvSpPr>
-          <p:cNvPr id="5" name="Rectangle 4"/>
+          <p:cNvPr id="5" name="Rounded Rectangle 4"/>
           <p:cNvSpPr/>
           <p:nvPr/>
         </p:nvSpPr>
@@ -3764,7 +3816,7 @@
             <a:off x="3429000" y="2286000"/>
             <a:ext cx="2468880" cy="3840480"/>
           </a:xfrm>
-          <a:prstGeom prst="rect">
+          <a:prstGeom prst="roundRect">
             <a:avLst/>
           </a:prstGeom>
           <a:solidFill>
@@ -3842,7 +3894,7 @@
       </p:sp>
       <p:sp>
         <p:nvSpPr>
-          <p:cNvPr id="6" name="Rectangle 5"/>
+          <p:cNvPr id="6" name="Rounded Rectangle 5"/>
           <p:cNvSpPr/>
           <p:nvPr/>
         </p:nvSpPr>
@@ -3851,7 +3903,7 @@
             <a:off x="6172200" y="2286000"/>
             <a:ext cx="2468880" cy="3840480"/>
           </a:xfrm>
-          <a:prstGeom prst="rect">
+          <a:prstGeom prst="roundRect">
             <a:avLst/>
           </a:prstGeom>
           <a:solidFill>
@@ -3929,7 +3981,7 @@
       </p:sp>
       <p:sp>
         <p:nvSpPr>
-          <p:cNvPr id="7" name="Rectangle 6"/>
+          <p:cNvPr id="7" name="Rounded Rectangle 6"/>
           <p:cNvSpPr/>
           <p:nvPr/>
         </p:nvSpPr>
@@ -3938,7 +3990,7 @@
             <a:off x="8915400" y="2286000"/>
             <a:ext cx="2468880" cy="3840480"/>
           </a:xfrm>
-          <a:prstGeom prst="rect">
+          <a:prstGeom prst="roundRect">
             <a:avLst/>
           </a:prstGeom>
           <a:solidFill>
@@ -4728,7 +4780,7 @@
       </p:sp>
       <p:sp>
         <p:nvSpPr>
-          <p:cNvPr id="3" name="Rectangle 2"/>
+          <p:cNvPr id="3" name="Rounded Rectangle 2"/>
           <p:cNvSpPr/>
           <p:nvPr/>
         </p:nvSpPr>
@@ -4737,7 +4789,7 @@
             <a:off x="685800" y="1645920"/>
             <a:ext cx="5120640" cy="4114800"/>
           </a:xfrm>
-          <a:prstGeom prst="rect">
+          <a:prstGeom prst="roundRect">
             <a:avLst/>
           </a:prstGeom>
           <a:solidFill>
@@ -4834,7 +4886,7 @@
       </p:sp>
       <p:sp>
         <p:nvSpPr>
-          <p:cNvPr id="4" name="Rectangle 3"/>
+          <p:cNvPr id="4" name="Rounded Rectangle 3"/>
           <p:cNvSpPr/>
           <p:nvPr/>
         </p:nvSpPr>
@@ -4843,7 +4895,7 @@
             <a:off x="6217920" y="1645920"/>
             <a:ext cx="5212080" cy="4114800"/>
           </a:xfrm>
-          <a:prstGeom prst="rect">
+          <a:prstGeom prst="roundRect">
             <a:avLst/>
           </a:prstGeom>
           <a:solidFill>

</xml_diff>

<commit_message>
docs: Split methodology into architecture flowchart and pillars, and add detailed ISO metrics explanation
</commit_message>
<xml_diff>
--- a/reports/cdac_project_review.pptx
+++ b/reports/cdac_project_review.pptx
@@ -11,6 +11,7 @@
     <p:sldId id="259" r:id="rId10"/>
     <p:sldId id="260" r:id="rId11"/>
     <p:sldId id="261" r:id="rId12"/>
+    <p:sldId id="262" r:id="rId13"/>
   </p:sldIdLst>
   <p:sldSz cx="12191695" cy="6858000" type="screen4x3"/>
   <p:notesSz cx="6858000" cy="9144000"/>
@@ -3354,7 +3355,7 @@
         </p:nvSpPr>
         <p:spPr>
           <a:xfrm>
-            <a:off x="685800" y="457200"/>
+            <a:off x="685800" y="365760"/>
             <a:ext cx="10817352" cy="731520"/>
           </a:xfrm>
           <a:prstGeom prst="rect">
@@ -3363,13 +3364,13 @@
           <a:noFill/>
         </p:spPr>
         <p:txBody>
-          <a:bodyPr wrap="square">
+          <a:bodyPr wrap="square" lIns="0" tIns="0">
             <a:spAutoFit/>
           </a:bodyPr>
           <a:lstStyle/>
           <a:p>
             <a:pPr>
-              <a:defRPr sz="3200" b="1">
+              <a:defRPr sz="3000" b="1">
                 <a:solidFill>
                   <a:srgbClr val="2979FF"/>
                 </a:solidFill>
@@ -3654,7 +3655,7 @@
         </p:nvSpPr>
         <p:spPr>
           <a:xfrm>
-            <a:off x="685800" y="457200"/>
+            <a:off x="685800" y="365760"/>
             <a:ext cx="10817352" cy="731520"/>
           </a:xfrm>
           <a:prstGeom prst="rect">
@@ -3663,13 +3664,13 @@
           <a:noFill/>
         </p:spPr>
         <p:txBody>
-          <a:bodyPr wrap="square">
+          <a:bodyPr wrap="square" lIns="0" tIns="0">
             <a:spAutoFit/>
           </a:bodyPr>
           <a:lstStyle/>
           <a:p>
             <a:pPr>
-              <a:defRPr sz="3200" b="1">
+              <a:defRPr sz="3000" b="1">
                 <a:solidFill>
                   <a:srgbClr val="2979FF"/>
                 </a:solidFill>
@@ -3677,57 +3678,21 @@
               </a:defRPr>
             </a:pPr>
             <a:r>
-              <a:t>System Architecture &amp; Flow</a:t>
-            </a:r>
-          </a:p>
-        </p:txBody>
-      </p:sp>
-      <p:sp>
-        <p:nvSpPr>
-          <p:cNvPr id="3" name="TextBox 2"/>
-          <p:cNvSpPr txBox="1"/>
+              <a:t>System Architecture &amp; Data Flow</a:t>
+            </a:r>
+          </a:p>
+        </p:txBody>
+      </p:sp>
+      <p:sp>
+        <p:nvSpPr>
+          <p:cNvPr id="3" name="Rounded Rectangle 2"/>
+          <p:cNvSpPr/>
           <p:nvPr/>
         </p:nvSpPr>
         <p:spPr>
           <a:xfrm>
-            <a:off x="685800" y="1371600"/>
-            <a:ext cx="10817352" cy="731520"/>
-          </a:xfrm>
-          <a:prstGeom prst="rect">
-            <a:avLst/>
-          </a:prstGeom>
-          <a:noFill/>
-        </p:spPr>
-        <p:txBody>
-          <a:bodyPr wrap="none">
-            <a:spAutoFit/>
-          </a:bodyPr>
-          <a:lstStyle/>
-          <a:p>
-            <a:pPr algn="ctr">
-              <a:defRPr sz="1500" b="1">
-                <a:solidFill>
-                  <a:srgbClr val="2979FF"/>
-                </a:solidFill>
-                <a:latin typeface="Arial"/>
-              </a:defRPr>
-            </a:pPr>
-            <a:r>
-              <a:t>Video Capture  ➔  YOLOv8 Face Detection  ➔  Quality telemetry  ➔  Multimodal Inference  ➔  Decision Fusion</a:t>
-            </a:r>
-          </a:p>
-        </p:txBody>
-      </p:sp>
-      <p:sp>
-        <p:nvSpPr>
-          <p:cNvPr id="4" name="Rounded Rectangle 3"/>
-          <p:cNvSpPr/>
-          <p:nvPr/>
-        </p:nvSpPr>
-        <p:spPr>
-          <a:xfrm>
-            <a:off x="685800" y="2286000"/>
-            <a:ext cx="2468880" cy="3840480"/>
+            <a:off x="685800" y="1188720"/>
+            <a:ext cx="10817352" cy="4937760"/>
           </a:xfrm>
           <a:prstGeom prst="roundRect">
             <a:avLst/>
@@ -3756,65 +3721,206 @@
           </a:fontRef>
         </p:style>
         <p:txBody>
-          <a:bodyPr rtlCol="0" anchor="ctr" wrap="square" lIns="182880" tIns="182880" rIns="182880"/>
+          <a:bodyPr rtlCol="0" anchor="ctr" wrap="square" lIns="365760" tIns="274320" rIns="365760"/>
           <a:lstStyle/>
           <a:p>
             <a:pPr algn="ctr">
-              <a:defRPr sz="1500" b="1">
-                <a:solidFill>
-                  <a:srgbClr val="FFFFFF"/>
+              <a:spcAft>
+                <a:spcPts val="1400"/>
+              </a:spcAft>
+              <a:defRPr sz="1600" b="1">
+                <a:solidFill>
+                  <a:srgbClr val="2979FF"/>
                 </a:solidFill>
                 <a:latin typeface="Arial"/>
               </a:defRPr>
             </a:pPr>
             <a:r>
-              <a:t>1. Passive Texture</a:t>
-            </a:r>
-          </a:p>
-          <a:p>
-            <a:pPr>
-              <a:spcAft>
-                <a:spcPts val="1000"/>
-              </a:spcAft>
-              <a:defRPr sz="900" b="1">
-                <a:solidFill>
-                  <a:srgbClr val="2979FF"/>
-                </a:solidFill>
-                <a:latin typeface="Arial"/>
-              </a:defRPr>
-            </a:pPr>
-            <a:r>
-              <a:t>SPATIAL TEXTURES</a:t>
+              <a:t>⚙️ PIPELINE EXECUTION FLOW</a:t>
             </a:r>
           </a:p>
           <a:p>
             <a:pPr>
               <a:spcBef>
-                <a:spcPts val="500"/>
+                <a:spcPts val="400"/>
               </a:spcBef>
-              <a:defRPr sz="1150">
+              <a:defRPr sz="1100" b="1">
                 <a:solidFill>
                   <a:srgbClr val="D2D7DF"/>
                 </a:solidFill>
+                <a:latin typeface="Courier New"/>
+              </a:defRPr>
+            </a:pPr>
+            <a:r>
+              <a:t>                    [ STANDARD 2D WEBCAM VIDEO STREAM ]</a:t>
+            </a:r>
+            <a:br/>
+            <a:r>
+              <a:t>                                     │</a:t>
+            </a:r>
+            <a:br/>
+            <a:r>
+              <a:t>                                     ▼</a:t>
+            </a:r>
+            <a:br/>
+            <a:r>
+              <a:t>                  [ YOLOv8-FACE DETECTION ENGINE (ONNX) ] ➔ (No Face ➔ Abort)</a:t>
+            </a:r>
+            <a:br/>
+            <a:r>
+              <a:t>                                     │</a:t>
+            </a:r>
+            <a:br/>
+            <a:r>
+              <a:t>                                     ▼</a:t>
+            </a:r>
+            <a:br/>
+            <a:r>
+              <a:t>                 [ REAL-TIME IMAGE QUALITY FILTERING GATE ]</a:t>
+            </a:r>
+            <a:br/>
+            <a:r>
+              <a:t>                  (Rejects Blurry, Low Light, or Occluded frames)</a:t>
+            </a:r>
+            <a:br/>
+            <a:r>
+              <a:t>                                     │</a:t>
+            </a:r>
+            <a:br/>
+            <a:r>
+              <a:t>                                     ▼</a:t>
+            </a:r>
+            <a:br/>
+            <a:r>
+              <a:t>               ┌─────────────────────┼─────────────────────┐</a:t>
+            </a:r>
+            <a:br/>
+            <a:r>
+              <a:t>               ▼                     ▼                     ▼</a:t>
+            </a:r>
+            <a:br/>
+            <a:r>
+              <a:t>       [PASSIVE TEXTURE]      [PHYSIOLOGY CHECK]     [ACTIVE CHALLENGE]</a:t>
+            </a:r>
+            <a:br/>
+            <a:r>
+              <a:t>         (MiniFASNet)           (Remote rPPG)        (Blink, Smile, Turn)</a:t>
+            </a:r>
+            <a:br/>
+            <a:r>
+              <a:t>               │                     │                     │</a:t>
+            </a:r>
+            <a:br/>
+            <a:r>
+              <a:t>               └─────────────────────┼─────────────────────┘</a:t>
+            </a:r>
+            <a:br/>
+            <a:r>
+              <a:t>                                     │</a:t>
+            </a:r>
+            <a:br/>
+            <a:r>
+              <a:t>                                     ▼</a:t>
+            </a:r>
+            <a:br/>
+            <a:r>
+              <a:t>                  [ EXPLAINABLE WEIGHTED DECISION FUSION ]</a:t>
+            </a:r>
+            <a:br/>
+            <a:r>
+              <a:t>                 (Dynamic weight computation for live parameters)</a:t>
+            </a:r>
+            <a:br/>
+            <a:r>
+              <a:t>                                     │</a:t>
+            </a:r>
+            <a:br/>
+            <a:r>
+              <a:t>                                     ▼</a:t>
+            </a:r>
+            <a:br/>
+            <a:r>
+              <a:t>                         [ SECURE FUSION VERDICT ]</a:t>
+            </a:r>
+            <a:br/>
+            <a:r>
+              <a:t>                         (Bona Fide Live / Spoof Rejection)</a:t>
+            </a:r>
+          </a:p>
+        </p:txBody>
+      </p:sp>
+    </p:spTree>
+  </p:cSld>
+  <p:clrMapOvr>
+    <a:masterClrMapping/>
+  </p:clrMapOvr>
+</p:sld>
+</file>
+
+<file path=ppt/slides/slide4.xml><?xml version="1.0" encoding="utf-8"?>
+<p:sld xmlns:a="http://schemas.openxmlformats.org/drawingml/2006/main" xmlns:p="http://schemas.openxmlformats.org/presentationml/2006/main" xmlns:r="http://schemas.openxmlformats.org/officeDocument/2006/relationships">
+  <p:cSld>
+    <p:bg>
+      <p:bgPr>
+        <a:solidFill>
+          <a:srgbClr val="12141A"/>
+        </a:solidFill>
+        <a:effectLst/>
+      </p:bgPr>
+    </p:bg>
+    <p:spTree>
+      <p:nvGrpSpPr>
+        <p:cNvPr id="1" name=""/>
+        <p:cNvGrpSpPr/>
+        <p:nvPr/>
+      </p:nvGrpSpPr>
+      <p:grpSpPr/>
+      <p:sp>
+        <p:nvSpPr>
+          <p:cNvPr id="2" name="TextBox 1"/>
+          <p:cNvSpPr txBox="1"/>
+          <p:nvPr/>
+        </p:nvSpPr>
+        <p:spPr>
+          <a:xfrm>
+            <a:off x="685800" y="365760"/>
+            <a:ext cx="10817352" cy="731520"/>
+          </a:xfrm>
+          <a:prstGeom prst="rect">
+            <a:avLst/>
+          </a:prstGeom>
+          <a:noFill/>
+        </p:spPr>
+        <p:txBody>
+          <a:bodyPr wrap="square" lIns="0" tIns="0">
+            <a:spAutoFit/>
+          </a:bodyPr>
+          <a:lstStyle/>
+          <a:p>
+            <a:pPr>
+              <a:defRPr sz="3000" b="1">
+                <a:solidFill>
+                  <a:srgbClr val="2979FF"/>
+                </a:solidFill>
                 <a:latin typeface="Arial"/>
               </a:defRPr>
             </a:pPr>
             <a:r>
-              <a:t>MiniFASNet CNN classification parsing high-frequency surface patterns to detect print paper/screen structures.</a:t>
-            </a:r>
-          </a:p>
-        </p:txBody>
-      </p:sp>
-      <p:sp>
-        <p:nvSpPr>
-          <p:cNvPr id="5" name="Rounded Rectangle 4"/>
+              <a:t>Multimodal Verification Pillars</a:t>
+            </a:r>
+          </a:p>
+        </p:txBody>
+      </p:sp>
+      <p:sp>
+        <p:nvSpPr>
+          <p:cNvPr id="3" name="Rounded Rectangle 2"/>
           <p:cNvSpPr/>
           <p:nvPr/>
         </p:nvSpPr>
         <p:spPr>
           <a:xfrm>
-            <a:off x="3429000" y="2286000"/>
-            <a:ext cx="2468880" cy="3840480"/>
+            <a:off x="685800" y="1645920"/>
+            <a:ext cx="2468880" cy="4114800"/>
           </a:xfrm>
           <a:prstGeom prst="roundRect">
             <a:avLst/>
@@ -3843,7 +3949,7 @@
           </a:fontRef>
         </p:style>
         <p:txBody>
-          <a:bodyPr rtlCol="0" anchor="ctr" wrap="square" lIns="182880" tIns="182880" rIns="182880"/>
+          <a:bodyPr rtlCol="0" anchor="ctr" wrap="square" lIns="182880" tIns="228600" rIns="182880"/>
           <a:lstStyle/>
           <a:p>
             <a:pPr algn="ctr">
@@ -3855,13 +3961,13 @@
               </a:defRPr>
             </a:pPr>
             <a:r>
-              <a:t>2. Physiological rPPG</a:t>
+              <a:t>1. Passive Texture</a:t>
             </a:r>
           </a:p>
           <a:p>
             <a:pPr>
               <a:spcAft>
-                <a:spcPts val="1000"/>
+                <a:spcPts val="1200"/>
               </a:spcAft>
               <a:defRPr sz="900" b="1">
                 <a:solidFill>
@@ -3871,7 +3977,7 @@
               </a:defRPr>
             </a:pPr>
             <a:r>
-              <a:t>HEART RATE PULSE</a:t>
+              <a:t>SPATIAL TEXTURES</a:t>
             </a:r>
           </a:p>
           <a:p>
@@ -3887,21 +3993,21 @@
               </a:defRPr>
             </a:pPr>
             <a:r>
-              <a:t>3D spatio-temporal CNN extracting cardiac micro-signals from skin color shifts to verify living tissue.</a:t>
-            </a:r>
-          </a:p>
-        </p:txBody>
-      </p:sp>
-      <p:sp>
-        <p:nvSpPr>
-          <p:cNvPr id="6" name="Rounded Rectangle 5"/>
+              <a:t>MiniFASNet CNN classification parsing high-frequency surface patterns to detect print paper/screen structures.</a:t>
+            </a:r>
+          </a:p>
+        </p:txBody>
+      </p:sp>
+      <p:sp>
+        <p:nvSpPr>
+          <p:cNvPr id="4" name="Rounded Rectangle 3"/>
           <p:cNvSpPr/>
           <p:nvPr/>
         </p:nvSpPr>
         <p:spPr>
           <a:xfrm>
-            <a:off x="6172200" y="2286000"/>
-            <a:ext cx="2468880" cy="3840480"/>
+            <a:off x="3429000" y="1645920"/>
+            <a:ext cx="2468880" cy="4114800"/>
           </a:xfrm>
           <a:prstGeom prst="roundRect">
             <a:avLst/>
@@ -3930,7 +4036,7 @@
           </a:fontRef>
         </p:style>
         <p:txBody>
-          <a:bodyPr rtlCol="0" anchor="ctr" wrap="square" lIns="182880" tIns="182880" rIns="182880"/>
+          <a:bodyPr rtlCol="0" anchor="ctr" wrap="square" lIns="182880" tIns="228600" rIns="182880"/>
           <a:lstStyle/>
           <a:p>
             <a:pPr algn="ctr">
@@ -3942,13 +4048,13 @@
               </a:defRPr>
             </a:pPr>
             <a:r>
-              <a:t>3. Active Challenges</a:t>
+              <a:t>2. Physiological rPPG</a:t>
             </a:r>
           </a:p>
           <a:p>
             <a:pPr>
               <a:spcAft>
-                <a:spcPts val="1000"/>
+                <a:spcPts val="1200"/>
               </a:spcAft>
               <a:defRPr sz="900" b="1">
                 <a:solidFill>
@@ -3958,7 +4064,7 @@
               </a:defRPr>
             </a:pPr>
             <a:r>
-              <a:t>CHALLENGE ACTIONS</a:t>
+              <a:t>HEART RATE PULSE</a:t>
             </a:r>
           </a:p>
           <a:p>
@@ -3974,21 +4080,21 @@
               </a:defRPr>
             </a:pPr>
             <a:r>
-              <a:t>Randomized directives (Blink, Turn, Smile) validated dynamically to establish immediate user cooperation.</a:t>
-            </a:r>
-          </a:p>
-        </p:txBody>
-      </p:sp>
-      <p:sp>
-        <p:nvSpPr>
-          <p:cNvPr id="7" name="Rounded Rectangle 6"/>
+              <a:t>3D spatio-temporal CNN extracting cardiac micro-signals from skin color shifts to verify living tissue.</a:t>
+            </a:r>
+          </a:p>
+        </p:txBody>
+      </p:sp>
+      <p:sp>
+        <p:nvSpPr>
+          <p:cNvPr id="5" name="Rounded Rectangle 4"/>
           <p:cNvSpPr/>
           <p:nvPr/>
         </p:nvSpPr>
         <p:spPr>
           <a:xfrm>
-            <a:off x="8915400" y="2286000"/>
-            <a:ext cx="2468880" cy="3840480"/>
+            <a:off x="6172200" y="1645920"/>
+            <a:ext cx="2468880" cy="4114800"/>
           </a:xfrm>
           <a:prstGeom prst="roundRect">
             <a:avLst/>
@@ -4017,7 +4123,7 @@
           </a:fontRef>
         </p:style>
         <p:txBody>
-          <a:bodyPr rtlCol="0" anchor="ctr" wrap="square" lIns="182880" tIns="182880" rIns="182880"/>
+          <a:bodyPr rtlCol="0" anchor="ctr" wrap="square" lIns="182880" tIns="228600" rIns="182880"/>
           <a:lstStyle/>
           <a:p>
             <a:pPr algn="ctr">
@@ -4029,13 +4135,100 @@
               </a:defRPr>
             </a:pPr>
             <a:r>
-              <a:t>4. Temporal Validator</a:t>
+              <a:t>3. Active Challenges</a:t>
             </a:r>
           </a:p>
           <a:p>
             <a:pPr>
               <a:spcAft>
-                <a:spcPts val="1000"/>
+                <a:spcPts val="1200"/>
+              </a:spcAft>
+              <a:defRPr sz="900" b="1">
+                <a:solidFill>
+                  <a:srgbClr val="2979FF"/>
+                </a:solidFill>
+                <a:latin typeface="Arial"/>
+              </a:defRPr>
+            </a:pPr>
+            <a:r>
+              <a:t>CHALLENGE ACTIONS</a:t>
+            </a:r>
+          </a:p>
+          <a:p>
+            <a:pPr>
+              <a:spcBef>
+                <a:spcPts val="500"/>
+              </a:spcBef>
+              <a:defRPr sz="1150">
+                <a:solidFill>
+                  <a:srgbClr val="D2D7DF"/>
+                </a:solidFill>
+                <a:latin typeface="Arial"/>
+              </a:defRPr>
+            </a:pPr>
+            <a:r>
+              <a:t>Randomized directives (Blink, Turn, Smile) validated dynamically to establish immediate user cooperation.</a:t>
+            </a:r>
+          </a:p>
+        </p:txBody>
+      </p:sp>
+      <p:sp>
+        <p:nvSpPr>
+          <p:cNvPr id="6" name="Rounded Rectangle 5"/>
+          <p:cNvSpPr/>
+          <p:nvPr/>
+        </p:nvSpPr>
+        <p:spPr>
+          <a:xfrm>
+            <a:off x="8915400" y="1645920"/>
+            <a:ext cx="2468880" cy="4114800"/>
+          </a:xfrm>
+          <a:prstGeom prst="roundRect">
+            <a:avLst/>
+          </a:prstGeom>
+          <a:solidFill>
+            <a:srgbClr val="1C202A"/>
+          </a:solidFill>
+          <a:ln w="12700">
+            <a:solidFill>
+              <a:srgbClr val="37474F"/>
+            </a:solidFill>
+          </a:ln>
+        </p:spPr>
+        <p:style>
+          <a:lnRef idx="1">
+            <a:schemeClr val="accent1"/>
+          </a:lnRef>
+          <a:fillRef idx="3">
+            <a:schemeClr val="accent1"/>
+          </a:fillRef>
+          <a:effectRef idx="2">
+            <a:schemeClr val="accent1"/>
+          </a:effectRef>
+          <a:fontRef idx="minor">
+            <a:schemeClr val="lt1"/>
+          </a:fontRef>
+        </p:style>
+        <p:txBody>
+          <a:bodyPr rtlCol="0" anchor="ctr" wrap="square" lIns="182880" tIns="228600" rIns="182880"/>
+          <a:lstStyle/>
+          <a:p>
+            <a:pPr algn="ctr">
+              <a:defRPr sz="1500" b="1">
+                <a:solidFill>
+                  <a:srgbClr val="FFFFFF"/>
+                </a:solidFill>
+                <a:latin typeface="Arial"/>
+              </a:defRPr>
+            </a:pPr>
+            <a:r>
+              <a:t>4. Temporal Validator</a:t>
+            </a:r>
+          </a:p>
+          <a:p>
+            <a:pPr>
+              <a:spcAft>
+                <a:spcPts val="1200"/>
               </a:spcAft>
               <a:defRPr sz="900" b="1">
                 <a:solidFill>
@@ -4074,7 +4267,7 @@
 </p:sld>
 </file>
 
-<file path=ppt/slides/slide4.xml><?xml version="1.0" encoding="utf-8"?>
+<file path=ppt/slides/slide5.xml><?xml version="1.0" encoding="utf-8"?>
 <p:sld xmlns:a="http://schemas.openxmlformats.org/drawingml/2006/main" xmlns:p="http://schemas.openxmlformats.org/presentationml/2006/main" xmlns:r="http://schemas.openxmlformats.org/officeDocument/2006/relationships">
   <p:cSld>
     <p:spTree>
@@ -4125,13 +4318,13 @@
           <a:noFill/>
         </p:spPr>
         <p:txBody>
-          <a:bodyPr wrap="square">
+          <a:bodyPr wrap="square" lIns="0" tIns="0">
             <a:spAutoFit/>
           </a:bodyPr>
           <a:lstStyle/>
           <a:p>
             <a:pPr>
-              <a:defRPr sz="3200" b="1">
+              <a:defRPr sz="3000" b="1">
                 <a:solidFill>
                   <a:srgbClr val="FFFFFF"/>
                 </a:solidFill>
@@ -4446,7 +4639,7 @@
               <a:spcAft>
                 <a:spcPts val="600"/>
               </a:spcAft>
-              <a:defRPr sz="1600" b="1">
+              <a:defRPr sz="1500" b="1">
                 <a:solidFill>
                   <a:srgbClr val="2979FF"/>
                 </a:solidFill>
@@ -4454,15 +4647,15 @@
               </a:defRPr>
             </a:pPr>
             <a:r>
-              <a:t>📊 Experimental Evaluation Setup</a:t>
+              <a:t>📊 ISO/IEC 30107-3 Standard Metrics</a:t>
             </a:r>
           </a:p>
           <a:p>
             <a:pPr>
               <a:spcAft>
-                <a:spcPts val="600"/>
+                <a:spcPts val="400"/>
               </a:spcAft>
-              <a:defRPr sz="1100">
+              <a:defRPr sz="1050">
                 <a:solidFill>
                   <a:srgbClr val="D2D7DF"/>
                 </a:solidFill>
@@ -4470,15 +4663,15 @@
               </a:defRPr>
             </a:pPr>
             <a:r>
-              <a:t>▪️ Benchmarked against unified subsets of CASIA-FASD and CelebA-Spoof, containing over 10,000 frames under diverse ambient variables.</a:t>
+              <a:t>• APCER: Attack Presentation Classification Error Rate. Measures the % of spoof attacks incorrectly classified as live.</a:t>
             </a:r>
           </a:p>
           <a:p>
             <a:pPr>
               <a:spcAft>
-                <a:spcPts val="600"/>
+                <a:spcPts val="400"/>
               </a:spcAft>
-              <a:defRPr sz="1100">
+              <a:defRPr sz="1050">
                 <a:solidFill>
                   <a:srgbClr val="D2D7DF"/>
                 </a:solidFill>
@@ -4486,15 +4679,15 @@
               </a:defRPr>
             </a:pPr>
             <a:r>
-              <a:t>▪️ Verified streaming processing speed exceeding 30 FPS.</a:t>
+              <a:t>• BPCER: Bona Fide Presentation Classification Error Rate. Measures the % of genuine live users incorrectly flagged as spoofs.</a:t>
             </a:r>
           </a:p>
           <a:p>
             <a:pPr>
               <a:spcAft>
-                <a:spcPts val="600"/>
+                <a:spcPts val="400"/>
               </a:spcAft>
-              <a:defRPr sz="1100">
+              <a:defRPr sz="1050">
                 <a:solidFill>
                   <a:srgbClr val="D2D7DF"/>
                 </a:solidFill>
@@ -4502,7 +4695,23 @@
               </a:defRPr>
             </a:pPr>
             <a:r>
-              <a:t>▪️ Optimized fusion weight configuration (10% rPPG, 10% Blink, 15% Antispoof, 65% Challenge) via programmatic grid-search.</a:t>
+              <a:t>• ACER: Average Classification Error Rate. Calculated as the average of APCER and BPCER: ACER = (APCER + BPCER) / 2.</a:t>
+            </a:r>
+          </a:p>
+          <a:p>
+            <a:pPr>
+              <a:spcAft>
+                <a:spcPts val="400"/>
+              </a:spcAft>
+              <a:defRPr sz="1050">
+                <a:solidFill>
+                  <a:srgbClr val="D2D7DF"/>
+                </a:solidFill>
+                <a:latin typeface="Arial"/>
+              </a:defRPr>
+            </a:pPr>
+            <a:r>
+              <a:t>• Empirical Calibration: System weights tuned via 1,771 test combinations under min_weight=0.10 constraint to achieve 1.0% ACER.</a:t>
             </a:r>
           </a:p>
         </p:txBody>
@@ -4515,7 +4724,7 @@
 </p:sld>
 </file>
 
-<file path=ppt/slides/slide5.xml><?xml version="1.0" encoding="utf-8"?>
+<file path=ppt/slides/slide6.xml><?xml version="1.0" encoding="utf-8"?>
 <p:sld xmlns:a="http://schemas.openxmlformats.org/drawingml/2006/main" xmlns:p="http://schemas.openxmlformats.org/presentationml/2006/main" xmlns:r="http://schemas.openxmlformats.org/officeDocument/2006/relationships">
   <p:cSld>
     <p:spTree>
@@ -4566,13 +4775,13 @@
           <a:noFill/>
         </p:spPr>
         <p:txBody>
-          <a:bodyPr wrap="square">
+          <a:bodyPr wrap="square" lIns="0" tIns="0">
             <a:spAutoFit/>
           </a:bodyPr>
           <a:lstStyle/>
           <a:p>
             <a:pPr>
-              <a:defRPr sz="3200" b="1">
+              <a:defRPr sz="3000" b="1">
                 <a:solidFill>
                   <a:srgbClr val="FFFFFF"/>
                 </a:solidFill>
@@ -4724,7 +4933,7 @@
 </p:sld>
 </file>
 
-<file path=ppt/slides/slide6.xml><?xml version="1.0" encoding="utf-8"?>
+<file path=ppt/slides/slide7.xml><?xml version="1.0" encoding="utf-8"?>
 <p:sld xmlns:a="http://schemas.openxmlformats.org/drawingml/2006/main" xmlns:p="http://schemas.openxmlformats.org/presentationml/2006/main" xmlns:r="http://schemas.openxmlformats.org/officeDocument/2006/relationships">
   <p:cSld>
     <p:bg>
@@ -4750,7 +4959,7 @@
         </p:nvSpPr>
         <p:spPr>
           <a:xfrm>
-            <a:off x="685800" y="457200"/>
+            <a:off x="685800" y="365760"/>
             <a:ext cx="10817352" cy="731520"/>
           </a:xfrm>
           <a:prstGeom prst="rect">
@@ -4759,13 +4968,13 @@
           <a:noFill/>
         </p:spPr>
         <p:txBody>
-          <a:bodyPr wrap="square">
+          <a:bodyPr wrap="square" lIns="0" tIns="0">
             <a:spAutoFit/>
           </a:bodyPr>
           <a:lstStyle/>
           <a:p>
             <a:pPr>
-              <a:defRPr sz="3200" b="1">
+              <a:defRPr sz="3000" b="1">
                 <a:solidFill>
                   <a:srgbClr val="2979FF"/>
                 </a:solidFill>

</xml_diff>

<commit_message>
docs: Style slides to matching dark purple theme, and build native shape flowchart on Slide 3
</commit_message>
<xml_diff>
--- a/reports/cdac_project_review.pptx
+++ b/reports/cdac_project_review.pptx
@@ -3159,7 +3159,7 @@
               </a:spcBef>
               <a:defRPr sz="1500" b="1">
                 <a:solidFill>
-                  <a:srgbClr val="2979FF"/>
+                  <a:srgbClr val="8A2BE2"/>
                 </a:solidFill>
                 <a:latin typeface="Arial"/>
               </a:defRPr>
@@ -3195,7 +3195,7 @@
             <a:pPr>
               <a:defRPr sz="1150" b="1">
                 <a:solidFill>
-                  <a:srgbClr val="D2D7DF"/>
+                  <a:srgbClr val="C8C8DC"/>
                 </a:solidFill>
                 <a:latin typeface="Arial"/>
               </a:defRPr>
@@ -3211,7 +3211,7 @@
               </a:spcBef>
               <a:defRPr sz="1150" b="1">
                 <a:solidFill>
-                  <a:srgbClr val="D2D7DF"/>
+                  <a:srgbClr val="C8C8DC"/>
                 </a:solidFill>
                 <a:latin typeface="Arial"/>
               </a:defRPr>
@@ -3227,7 +3227,7 @@
               </a:spcBef>
               <a:defRPr sz="1150">
                 <a:solidFill>
-                  <a:srgbClr val="8C96A5"/>
+                  <a:srgbClr val="827896"/>
                 </a:solidFill>
                 <a:latin typeface="Arial"/>
               </a:defRPr>
@@ -3253,11 +3253,11 @@
             <a:avLst/>
           </a:prstGeom>
           <a:solidFill>
-            <a:srgbClr val="1C202A"/>
+            <a:srgbClr val="181622"/>
           </a:solidFill>
           <a:ln w="12700">
             <a:solidFill>
-              <a:srgbClr val="37474F"/>
+              <a:srgbClr val="3C325A"/>
             </a:solidFill>
           </a:ln>
         </p:spPr>
@@ -3282,7 +3282,7 @@
             <a:pPr algn="ctr">
               <a:defRPr sz="1500" b="1">
                 <a:solidFill>
-                  <a:srgbClr val="2979FF"/>
+                  <a:srgbClr val="8A2BE2"/>
                 </a:solidFill>
                 <a:latin typeface="Arial"/>
               </a:defRPr>
@@ -3298,7 +3298,7 @@
               </a:spcBef>
               <a:defRPr sz="1100">
                 <a:solidFill>
-                  <a:srgbClr val="D2D7DF"/>
+                  <a:srgbClr val="C8C8DC"/>
                 </a:solidFill>
                 <a:latin typeface="Arial"/>
               </a:defRPr>
@@ -3335,7 +3335,7 @@
     <p:bg>
       <p:bgPr>
         <a:solidFill>
-          <a:srgbClr val="12141A"/>
+          <a:srgbClr val="0A0A10"/>
         </a:solidFill>
         <a:effectLst/>
       </p:bgPr>
@@ -3372,7 +3372,7 @@
             <a:pPr>
               <a:defRPr sz="3000" b="1">
                 <a:solidFill>
-                  <a:srgbClr val="2979FF"/>
+                  <a:srgbClr val="8A2BE2"/>
                 </a:solidFill>
                 <a:latin typeface="Arial"/>
               </a:defRPr>
@@ -3411,7 +3411,7 @@
               </a:spcAft>
               <a:defRPr sz="1800" b="1">
                 <a:solidFill>
-                  <a:srgbClr val="2979FF"/>
+                  <a:srgbClr val="8A2BE2"/>
                 </a:solidFill>
                 <a:latin typeface="Arial"/>
               </a:defRPr>
@@ -3427,7 +3427,7 @@
               </a:spcAft>
               <a:defRPr sz="1300">
                 <a:solidFill>
-                  <a:srgbClr val="D2D7DF"/>
+                  <a:srgbClr val="C8C8DC"/>
                 </a:solidFill>
                 <a:latin typeface="Arial"/>
               </a:defRPr>
@@ -3443,7 +3443,7 @@
               </a:spcAft>
               <a:defRPr sz="1300">
                 <a:solidFill>
-                  <a:srgbClr val="D2D7DF"/>
+                  <a:srgbClr val="C8C8DC"/>
                 </a:solidFill>
                 <a:latin typeface="Arial"/>
               </a:defRPr>
@@ -3459,7 +3459,7 @@
               </a:spcAft>
               <a:defRPr sz="1300">
                 <a:solidFill>
-                  <a:srgbClr val="D2D7DF"/>
+                  <a:srgbClr val="C8C8DC"/>
                 </a:solidFill>
                 <a:latin typeface="Arial"/>
               </a:defRPr>
@@ -3475,7 +3475,7 @@
               </a:spcAft>
               <a:defRPr sz="1300">
                 <a:solidFill>
-                  <a:srgbClr val="D2D7DF"/>
+                  <a:srgbClr val="C8C8DC"/>
                 </a:solidFill>
                 <a:latin typeface="Arial"/>
               </a:defRPr>
@@ -3530,7 +3530,7 @@
               </a:spcBef>
               <a:defRPr sz="1400" b="1">
                 <a:solidFill>
-                  <a:srgbClr val="2979FF"/>
+                  <a:srgbClr val="8A2BE2"/>
                 </a:solidFill>
                 <a:latin typeface="Arial"/>
               </a:defRPr>
@@ -3546,7 +3546,7 @@
               </a:spcAft>
               <a:defRPr sz="1200">
                 <a:solidFill>
-                  <a:srgbClr val="D2D7DF"/>
+                  <a:srgbClr val="C8C8DC"/>
                 </a:solidFill>
                 <a:latin typeface="Arial"/>
               </a:defRPr>
@@ -3562,7 +3562,7 @@
               </a:spcBef>
               <a:defRPr sz="1400" b="1">
                 <a:solidFill>
-                  <a:srgbClr val="2979FF"/>
+                  <a:srgbClr val="8A2BE2"/>
                 </a:solidFill>
                 <a:latin typeface="Arial"/>
               </a:defRPr>
@@ -3578,7 +3578,7 @@
               </a:spcAft>
               <a:defRPr sz="1200">
                 <a:solidFill>
-                  <a:srgbClr val="D2D7DF"/>
+                  <a:srgbClr val="C8C8DC"/>
                 </a:solidFill>
                 <a:latin typeface="Arial"/>
               </a:defRPr>
@@ -3594,7 +3594,7 @@
               </a:spcBef>
               <a:defRPr sz="1400" b="1">
                 <a:solidFill>
-                  <a:srgbClr val="2979FF"/>
+                  <a:srgbClr val="8A2BE2"/>
                 </a:solidFill>
                 <a:latin typeface="Arial"/>
               </a:defRPr>
@@ -3610,7 +3610,7 @@
               </a:spcAft>
               <a:defRPr sz="1200">
                 <a:solidFill>
-                  <a:srgbClr val="D2D7DF"/>
+                  <a:srgbClr val="C8C8DC"/>
                 </a:solidFill>
                 <a:latin typeface="Arial"/>
               </a:defRPr>
@@ -3635,7 +3635,7 @@
     <p:bg>
       <p:bgPr>
         <a:solidFill>
-          <a:srgbClr val="12141A"/>
+          <a:srgbClr val="0A0A10"/>
         </a:solidFill>
         <a:effectLst/>
       </p:bgPr>
@@ -3672,37 +3672,140 @@
             <a:pPr>
               <a:defRPr sz="3000" b="1">
                 <a:solidFill>
-                  <a:srgbClr val="2979FF"/>
-                </a:solidFill>
-                <a:latin typeface="Arial"/>
-              </a:defRPr>
-            </a:pPr>
-            <a:r>
-              <a:t>System Architecture &amp; Data Flow</a:t>
-            </a:r>
-          </a:p>
-        </p:txBody>
-      </p:sp>
-      <p:sp>
-        <p:nvSpPr>
-          <p:cNvPr id="3" name="Rounded Rectangle 2"/>
+                  <a:srgbClr val="8A2BE2"/>
+                </a:solidFill>
+                <a:latin typeface="Arial"/>
+              </a:defRPr>
+            </a:pPr>
+            <a:r>
+              <a:t>System Architecture Pipeline</a:t>
+            </a:r>
+          </a:p>
+        </p:txBody>
+      </p:sp>
+      <p:sp>
+        <p:nvSpPr>
+          <p:cNvPr id="3" name="TextBox 2"/>
+          <p:cNvSpPr txBox="1"/>
+          <p:nvPr/>
+        </p:nvSpPr>
+        <p:spPr>
+          <a:xfrm>
+            <a:off x="685800" y="1371600"/>
+            <a:ext cx="3840480" cy="4572000"/>
+          </a:xfrm>
+          <a:prstGeom prst="rect">
+            <a:avLst/>
+          </a:prstGeom>
+          <a:noFill/>
+        </p:spPr>
+        <p:txBody>
+          <a:bodyPr wrap="square">
+            <a:spAutoFit/>
+          </a:bodyPr>
+          <a:lstStyle/>
+          <a:p>
+            <a:pPr>
+              <a:spcAft>
+                <a:spcPts val="1200"/>
+              </a:spcAft>
+              <a:defRPr sz="1800" b="1">
+                <a:solidFill>
+                  <a:srgbClr val="8A2BE2"/>
+                </a:solidFill>
+                <a:latin typeface="Arial"/>
+              </a:defRPr>
+            </a:pPr>
+            <a:r>
+              <a:t>⚙️ Modular Data Pipeline</a:t>
+            </a:r>
+          </a:p>
+          <a:p>
+            <a:pPr>
+              <a:spcAft>
+                <a:spcPts val="1000"/>
+              </a:spcAft>
+              <a:defRPr sz="1200">
+                <a:solidFill>
+                  <a:srgbClr val="C8C8DC"/>
+                </a:solidFill>
+                <a:latin typeface="Arial"/>
+              </a:defRPr>
+            </a:pPr>
+            <a:r>
+              <a:t>• A modular layer architecture styled after high-performance neural blocks (like Transformer stacks).</a:t>
+            </a:r>
+          </a:p>
+          <a:p>
+            <a:pPr>
+              <a:spcAft>
+                <a:spcPts val="1000"/>
+              </a:spcAft>
+              <a:defRPr sz="1200">
+                <a:solidFill>
+                  <a:srgbClr val="C8C8DC"/>
+                </a:solidFill>
+                <a:latin typeface="Arial"/>
+              </a:defRPr>
+            </a:pPr>
+            <a:r>
+              <a:t>• Frames pass sequentially through detection, validation, and quality gates before running parallel inferences.</a:t>
+            </a:r>
+          </a:p>
+          <a:p>
+            <a:pPr>
+              <a:spcAft>
+                <a:spcPts val="1000"/>
+              </a:spcAft>
+              <a:defRPr sz="1200">
+                <a:solidFill>
+                  <a:srgbClr val="C8C8DC"/>
+                </a:solidFill>
+                <a:latin typeface="Arial"/>
+              </a:defRPr>
+            </a:pPr>
+            <a:r>
+              <a:t>• Texture (Spatial), Physiology (Biological BVP), and Challenge (Temporal Actions) operate as distinct pipelines.</a:t>
+            </a:r>
+          </a:p>
+          <a:p>
+            <a:pPr>
+              <a:spcAft>
+                <a:spcPts val="1000"/>
+              </a:spcAft>
+              <a:defRPr sz="1200">
+                <a:solidFill>
+                  <a:srgbClr val="C8C8DC"/>
+                </a:solidFill>
+                <a:latin typeface="Arial"/>
+              </a:defRPr>
+            </a:pPr>
+            <a:r>
+              <a:t>• Decision Fusion acts as the linear convergence layer to calculate output probabilities.</a:t>
+            </a:r>
+          </a:p>
+        </p:txBody>
+      </p:sp>
+      <p:sp>
+        <p:nvSpPr>
+          <p:cNvPr id="4" name="Rounded Rectangle 3"/>
           <p:cNvSpPr/>
           <p:nvPr/>
         </p:nvSpPr>
         <p:spPr>
           <a:xfrm>
-            <a:off x="685800" y="1188720"/>
-            <a:ext cx="10817352" cy="4937760"/>
+            <a:off x="6766560" y="1005840"/>
+            <a:ext cx="2011680" cy="365760"/>
           </a:xfrm>
           <a:prstGeom prst="roundRect">
             <a:avLst/>
           </a:prstGeom>
           <a:solidFill>
-            <a:srgbClr val="1C202A"/>
+            <a:srgbClr val="F8BBD0"/>
           </a:solidFill>
           <a:ln w="12700">
             <a:solidFill>
-              <a:srgbClr val="37474F"/>
+              <a:srgbClr val="3C325A"/>
             </a:solidFill>
           </a:ln>
         </p:spPr>
@@ -3721,130 +3824,853 @@
           </a:fontRef>
         </p:style>
         <p:txBody>
-          <a:bodyPr rtlCol="0" anchor="ctr" wrap="square" lIns="365760" tIns="274320" rIns="365760"/>
+          <a:bodyPr rtlCol="0" anchor="ctr" wrap="square" lIns="18288" rIns="18288" tIns="18288" bIns="18288"/>
           <a:lstStyle/>
           <a:p>
             <a:pPr algn="ctr">
-              <a:spcAft>
-                <a:spcPts val="1400"/>
-              </a:spcAft>
-              <a:defRPr sz="1600" b="1">
-                <a:solidFill>
-                  <a:srgbClr val="2979FF"/>
-                </a:solidFill>
-                <a:latin typeface="Arial"/>
-              </a:defRPr>
-            </a:pPr>
-            <a:r>
-              <a:t>⚙️ PIPELINE EXECUTION FLOW</a:t>
-            </a:r>
-          </a:p>
+              <a:defRPr sz="950" b="1">
+                <a:solidFill>
+                  <a:srgbClr val="282828"/>
+                </a:solidFill>
+                <a:latin typeface="Arial"/>
+              </a:defRPr>
+            </a:pPr>
+            <a:r>
+              <a:t>Video Frames (BGR stream)</a:t>
+            </a:r>
+          </a:p>
+        </p:txBody>
+      </p:sp>
+      <p:cxnSp>
+        <p:nvCxnSpPr>
+          <p:cNvPr id="5" name="Connector 4"/>
+          <p:cNvCxnSpPr/>
+          <p:nvPr/>
+        </p:nvCxnSpPr>
+        <p:spPr>
+          <a:xfrm>
+            <a:off x="7772400" y="1371600"/>
+            <a:ext cx="0" cy="182880"/>
+          </a:xfrm>
+          <a:prstGeom prst="line">
+            <a:avLst/>
+          </a:prstGeom>
+          <a:ln w="15240">
+            <a:solidFill>
+              <a:srgbClr val="3C325A"/>
+            </a:solidFill>
+          </a:ln>
+        </p:spPr>
+        <p:style>
+          <a:lnRef idx="2">
+            <a:schemeClr val="accent1"/>
+          </a:lnRef>
+          <a:fillRef idx="0">
+            <a:schemeClr val="accent1"/>
+          </a:fillRef>
+          <a:effectRef idx="1">
+            <a:schemeClr val="accent1"/>
+          </a:effectRef>
+          <a:fontRef idx="minor">
+            <a:schemeClr val="tx1"/>
+          </a:fontRef>
+        </p:style>
+      </p:cxnSp>
+      <p:sp>
+        <p:nvSpPr>
+          <p:cNvPr id="6" name="Rounded Rectangle 5"/>
+          <p:cNvSpPr/>
+          <p:nvPr/>
+        </p:nvSpPr>
+        <p:spPr>
+          <a:xfrm>
+            <a:off x="6766560" y="1554480"/>
+            <a:ext cx="2011680" cy="365760"/>
+          </a:xfrm>
+          <a:prstGeom prst="roundRect">
+            <a:avLst/>
+          </a:prstGeom>
+          <a:solidFill>
+            <a:srgbClr val="FFE0B2"/>
+          </a:solidFill>
+          <a:ln w="12700">
+            <a:solidFill>
+              <a:srgbClr val="3C325A"/>
+            </a:solidFill>
+          </a:ln>
+        </p:spPr>
+        <p:style>
+          <a:lnRef idx="1">
+            <a:schemeClr val="accent1"/>
+          </a:lnRef>
+          <a:fillRef idx="3">
+            <a:schemeClr val="accent1"/>
+          </a:fillRef>
+          <a:effectRef idx="2">
+            <a:schemeClr val="accent1"/>
+          </a:effectRef>
+          <a:fontRef idx="minor">
+            <a:schemeClr val="lt1"/>
+          </a:fontRef>
+        </p:style>
+        <p:txBody>
+          <a:bodyPr rtlCol="0" anchor="ctr" wrap="square" lIns="18288" rIns="18288" tIns="18288" bIns="18288"/>
+          <a:lstStyle/>
+          <a:p>
+            <a:pPr algn="ctr">
+              <a:defRPr sz="950" b="1">
+                <a:solidFill>
+                  <a:srgbClr val="282828"/>
+                </a:solidFill>
+                <a:latin typeface="Arial"/>
+              </a:defRPr>
+            </a:pPr>
+            <a:r>
+              <a:t>YOLOv8-Face Detection</a:t>
+            </a:r>
+          </a:p>
+        </p:txBody>
+      </p:sp>
+      <p:cxnSp>
+        <p:nvCxnSpPr>
+          <p:cNvPr id="7" name="Connector 6"/>
+          <p:cNvCxnSpPr/>
+          <p:nvPr/>
+        </p:nvCxnSpPr>
+        <p:spPr>
+          <a:xfrm>
+            <a:off x="7772400" y="1920240"/>
+            <a:ext cx="0" cy="182880"/>
+          </a:xfrm>
+          <a:prstGeom prst="line">
+            <a:avLst/>
+          </a:prstGeom>
+          <a:ln w="15240">
+            <a:solidFill>
+              <a:srgbClr val="3C325A"/>
+            </a:solidFill>
+          </a:ln>
+        </p:spPr>
+        <p:style>
+          <a:lnRef idx="2">
+            <a:schemeClr val="accent1"/>
+          </a:lnRef>
+          <a:fillRef idx="0">
+            <a:schemeClr val="accent1"/>
+          </a:fillRef>
+          <a:effectRef idx="1">
+            <a:schemeClr val="accent1"/>
+          </a:effectRef>
+          <a:fontRef idx="minor">
+            <a:schemeClr val="tx1"/>
+          </a:fontRef>
+        </p:style>
+      </p:cxnSp>
+      <p:sp>
+        <p:nvSpPr>
+          <p:cNvPr id="8" name="Rounded Rectangle 7"/>
+          <p:cNvSpPr/>
+          <p:nvPr/>
+        </p:nvSpPr>
+        <p:spPr>
+          <a:xfrm>
+            <a:off x="6766560" y="2103120"/>
+            <a:ext cx="2011680" cy="365760"/>
+          </a:xfrm>
+          <a:prstGeom prst="roundRect">
+            <a:avLst/>
+          </a:prstGeom>
+          <a:solidFill>
+            <a:srgbClr val="FFF9C4"/>
+          </a:solidFill>
+          <a:ln w="12700">
+            <a:solidFill>
+              <a:srgbClr val="3C325A"/>
+            </a:solidFill>
+          </a:ln>
+        </p:spPr>
+        <p:style>
+          <a:lnRef idx="1">
+            <a:schemeClr val="accent1"/>
+          </a:lnRef>
+          <a:fillRef idx="3">
+            <a:schemeClr val="accent1"/>
+          </a:fillRef>
+          <a:effectRef idx="2">
+            <a:schemeClr val="accent1"/>
+          </a:effectRef>
+          <a:fontRef idx="minor">
+            <a:schemeClr val="lt1"/>
+          </a:fontRef>
+        </p:style>
+        <p:txBody>
+          <a:bodyPr rtlCol="0" anchor="ctr" wrap="square" lIns="18288" rIns="18288" tIns="18288" bIns="18288"/>
+          <a:lstStyle/>
+          <a:p>
+            <a:pPr algn="ctr">
+              <a:defRPr sz="950" b="1">
+                <a:solidFill>
+                  <a:srgbClr val="282828"/>
+                </a:solidFill>
+                <a:latin typeface="Arial"/>
+              </a:defRPr>
+            </a:pPr>
+            <a:r>
+              <a:t>Signal Quality Filter Gate</a:t>
+            </a:r>
+          </a:p>
+        </p:txBody>
+      </p:sp>
+      <p:sp>
+        <p:nvSpPr>
+          <p:cNvPr id="9" name="Rounded Rectangle 8"/>
+          <p:cNvSpPr/>
+          <p:nvPr/>
+        </p:nvSpPr>
+        <p:spPr>
+          <a:xfrm>
+            <a:off x="4663440" y="2651760"/>
+            <a:ext cx="6217920" cy="1645920"/>
+          </a:xfrm>
+          <a:prstGeom prst="roundRect">
+            <a:avLst/>
+          </a:prstGeom>
+          <a:noFill/>
+          <a:ln w="19050">
+            <a:solidFill>
+              <a:srgbClr val="3C325A"/>
+            </a:solidFill>
+          </a:ln>
+        </p:spPr>
+        <p:style>
+          <a:lnRef idx="1">
+            <a:schemeClr val="accent1"/>
+          </a:lnRef>
+          <a:fillRef idx="3">
+            <a:schemeClr val="accent1"/>
+          </a:fillRef>
+          <a:effectRef idx="2">
+            <a:schemeClr val="accent1"/>
+          </a:effectRef>
+          <a:fontRef idx="minor">
+            <a:schemeClr val="lt1"/>
+          </a:fontRef>
+        </p:style>
+        <p:txBody>
+          <a:bodyPr rtlCol="0" anchor="ctr"/>
+          <a:lstStyle/>
+          <a:p>
+            <a:pPr algn="ctr"/>
+          </a:p>
+        </p:txBody>
+      </p:sp>
+      <p:sp>
+        <p:nvSpPr>
+          <p:cNvPr id="10" name="TextBox 9"/>
+          <p:cNvSpPr txBox="1"/>
+          <p:nvPr/>
+        </p:nvSpPr>
+        <p:spPr>
+          <a:xfrm>
+            <a:off x="10378440" y="3200400"/>
+            <a:ext cx="457200" cy="365760"/>
+          </a:xfrm>
+          <a:prstGeom prst="rect">
+            <a:avLst/>
+          </a:prstGeom>
+          <a:noFill/>
+        </p:spPr>
+        <p:txBody>
+          <a:bodyPr wrap="none">
+            <a:spAutoFit/>
+          </a:bodyPr>
+          <a:lstStyle/>
           <a:p>
             <a:pPr>
-              <a:spcBef>
-                <a:spcPts val="400"/>
-              </a:spcBef>
-              <a:defRPr sz="1100" b="1">
-                <a:solidFill>
-                  <a:srgbClr val="D2D7DF"/>
-                </a:solidFill>
-                <a:latin typeface="Courier New"/>
-              </a:defRPr>
-            </a:pPr>
-            <a:r>
-              <a:t>                    [ STANDARD 2D WEBCAM VIDEO STREAM ]</a:t>
-            </a:r>
-            <a:br/>
-            <a:r>
-              <a:t>                                     │</a:t>
-            </a:r>
-            <a:br/>
-            <a:r>
-              <a:t>                                     ▼</a:t>
-            </a:r>
-            <a:br/>
-            <a:r>
-              <a:t>                  [ YOLOv8-FACE DETECTION ENGINE (ONNX) ] ➔ (No Face ➔ Abort)</a:t>
-            </a:r>
-            <a:br/>
-            <a:r>
-              <a:t>                                     │</a:t>
-            </a:r>
-            <a:br/>
-            <a:r>
-              <a:t>                                     ▼</a:t>
-            </a:r>
-            <a:br/>
-            <a:r>
-              <a:t>                 [ REAL-TIME IMAGE QUALITY FILTERING GATE ]</a:t>
-            </a:r>
-            <a:br/>
-            <a:r>
-              <a:t>                  (Rejects Blurry, Low Light, or Occluded frames)</a:t>
-            </a:r>
-            <a:br/>
-            <a:r>
-              <a:t>                                     │</a:t>
-            </a:r>
-            <a:br/>
-            <a:r>
-              <a:t>                                     ▼</a:t>
-            </a:r>
-            <a:br/>
-            <a:r>
-              <a:t>               ┌─────────────────────┼─────────────────────┐</a:t>
-            </a:r>
-            <a:br/>
-            <a:r>
-              <a:t>               ▼                     ▼                     ▼</a:t>
-            </a:r>
-            <a:br/>
-            <a:r>
-              <a:t>       [PASSIVE TEXTURE]      [PHYSIOLOGY CHECK]     [ACTIVE CHALLENGE]</a:t>
-            </a:r>
-            <a:br/>
-            <a:r>
-              <a:t>         (MiniFASNet)           (Remote rPPG)        (Blink, Smile, Turn)</a:t>
-            </a:r>
-            <a:br/>
-            <a:r>
-              <a:t>               │                     │                     │</a:t>
-            </a:r>
-            <a:br/>
-            <a:r>
-              <a:t>               └─────────────────────┼─────────────────────┘</a:t>
-            </a:r>
-            <a:br/>
-            <a:r>
-              <a:t>                                     │</a:t>
-            </a:r>
-            <a:br/>
-            <a:r>
-              <a:t>                                     ▼</a:t>
-            </a:r>
-            <a:br/>
-            <a:r>
-              <a:t>                  [ EXPLAINABLE WEIGHTED DECISION FUSION ]</a:t>
-            </a:r>
-            <a:br/>
-            <a:r>
-              <a:t>                 (Dynamic weight computation for live parameters)</a:t>
-            </a:r>
-            <a:br/>
-            <a:r>
-              <a:t>                                     │</a:t>
-            </a:r>
-            <a:br/>
-            <a:r>
-              <a:t>                                     ▼</a:t>
-            </a:r>
-            <a:br/>
-            <a:r>
-              <a:t>                         [ SECURE FUSION VERDICT ]</a:t>
-            </a:r>
-            <a:br/>
-            <a:r>
-              <a:t>                         (Bona Fide Live / Spoof Rejection)</a:t>
+              <a:defRPr sz="1400" b="1">
+                <a:solidFill>
+                  <a:srgbClr val="8A2BE2"/>
+                </a:solidFill>
+                <a:latin typeface="Arial"/>
+              </a:defRPr>
+            </a:pPr>
+            <a:r>
+              <a:t>3x</a:t>
+            </a:r>
+          </a:p>
+        </p:txBody>
+      </p:sp>
+      <p:sp>
+        <p:nvSpPr>
+          <p:cNvPr id="11" name="Rounded Rectangle 10"/>
+          <p:cNvSpPr/>
+          <p:nvPr/>
+        </p:nvSpPr>
+        <p:spPr>
+          <a:xfrm>
+            <a:off x="4937760" y="2834640"/>
+            <a:ext cx="1645920" cy="1097280"/>
+          </a:xfrm>
+          <a:prstGeom prst="roundRect">
+            <a:avLst/>
+          </a:prstGeom>
+          <a:solidFill>
+            <a:srgbClr val="E0F2F1"/>
+          </a:solidFill>
+          <a:ln w="12700">
+            <a:solidFill>
+              <a:srgbClr val="3C325A"/>
+            </a:solidFill>
+          </a:ln>
+        </p:spPr>
+        <p:style>
+          <a:lnRef idx="1">
+            <a:schemeClr val="accent1"/>
+          </a:lnRef>
+          <a:fillRef idx="3">
+            <a:schemeClr val="accent1"/>
+          </a:fillRef>
+          <a:effectRef idx="2">
+            <a:schemeClr val="accent1"/>
+          </a:effectRef>
+          <a:fontRef idx="minor">
+            <a:schemeClr val="lt1"/>
+          </a:fontRef>
+        </p:style>
+        <p:txBody>
+          <a:bodyPr rtlCol="0" anchor="ctr" wrap="square" lIns="18288" rIns="18288" tIns="18288" bIns="18288"/>
+          <a:lstStyle/>
+          <a:p>
+            <a:pPr algn="ctr">
+              <a:defRPr sz="950" b="1">
+                <a:solidFill>
+                  <a:srgbClr val="282828"/>
+                </a:solidFill>
+                <a:latin typeface="Arial"/>
+              </a:defRPr>
+            </a:pPr>
+            <a:r>
+              <a:t>Passive Texture CNN</a:t>
+            </a:r>
+          </a:p>
+        </p:txBody>
+      </p:sp>
+      <p:sp>
+        <p:nvSpPr>
+          <p:cNvPr id="12" name="Rounded Rectangle 11"/>
+          <p:cNvSpPr/>
+          <p:nvPr/>
+        </p:nvSpPr>
+        <p:spPr>
+          <a:xfrm>
+            <a:off x="6949440" y="2834640"/>
+            <a:ext cx="1645920" cy="1097280"/>
+          </a:xfrm>
+          <a:prstGeom prst="roundRect">
+            <a:avLst/>
+          </a:prstGeom>
+          <a:solidFill>
+            <a:srgbClr val="E0F2F1"/>
+          </a:solidFill>
+          <a:ln w="12700">
+            <a:solidFill>
+              <a:srgbClr val="3C325A"/>
+            </a:solidFill>
+          </a:ln>
+        </p:spPr>
+        <p:style>
+          <a:lnRef idx="1">
+            <a:schemeClr val="accent1"/>
+          </a:lnRef>
+          <a:fillRef idx="3">
+            <a:schemeClr val="accent1"/>
+          </a:fillRef>
+          <a:effectRef idx="2">
+            <a:schemeClr val="accent1"/>
+          </a:effectRef>
+          <a:fontRef idx="minor">
+            <a:schemeClr val="lt1"/>
+          </a:fontRef>
+        </p:style>
+        <p:txBody>
+          <a:bodyPr rtlCol="0" anchor="ctr" wrap="square" lIns="18288" rIns="18288" tIns="18288" bIns="18288"/>
+          <a:lstStyle/>
+          <a:p>
+            <a:pPr algn="ctr">
+              <a:defRPr sz="950" b="1">
+                <a:solidFill>
+                  <a:srgbClr val="282828"/>
+                </a:solidFill>
+                <a:latin typeface="Arial"/>
+              </a:defRPr>
+            </a:pPr>
+            <a:r>
+              <a:t>Physiological rPPG</a:t>
+            </a:r>
+          </a:p>
+        </p:txBody>
+      </p:sp>
+      <p:sp>
+        <p:nvSpPr>
+          <p:cNvPr id="13" name="Rounded Rectangle 12"/>
+          <p:cNvSpPr/>
+          <p:nvPr/>
+        </p:nvSpPr>
+        <p:spPr>
+          <a:xfrm>
+            <a:off x="8961120" y="2834640"/>
+            <a:ext cx="1645920" cy="1097280"/>
+          </a:xfrm>
+          <a:prstGeom prst="roundRect">
+            <a:avLst/>
+          </a:prstGeom>
+          <a:solidFill>
+            <a:srgbClr val="E0F2F1"/>
+          </a:solidFill>
+          <a:ln w="12700">
+            <a:solidFill>
+              <a:srgbClr val="3C325A"/>
+            </a:solidFill>
+          </a:ln>
+        </p:spPr>
+        <p:style>
+          <a:lnRef idx="1">
+            <a:schemeClr val="accent1"/>
+          </a:lnRef>
+          <a:fillRef idx="3">
+            <a:schemeClr val="accent1"/>
+          </a:fillRef>
+          <a:effectRef idx="2">
+            <a:schemeClr val="accent1"/>
+          </a:effectRef>
+          <a:fontRef idx="minor">
+            <a:schemeClr val="lt1"/>
+          </a:fontRef>
+        </p:style>
+        <p:txBody>
+          <a:bodyPr rtlCol="0" anchor="ctr" wrap="square" lIns="18288" rIns="18288" tIns="18288" bIns="18288"/>
+          <a:lstStyle/>
+          <a:p>
+            <a:pPr algn="ctr">
+              <a:defRPr sz="950" b="1">
+                <a:solidFill>
+                  <a:srgbClr val="282828"/>
+                </a:solidFill>
+                <a:latin typeface="Arial"/>
+              </a:defRPr>
+            </a:pPr>
+            <a:r>
+              <a:t>Active Challenges</a:t>
+            </a:r>
+          </a:p>
+        </p:txBody>
+      </p:sp>
+      <p:cxnSp>
+        <p:nvCxnSpPr>
+          <p:cNvPr id="14" name="Connector 13"/>
+          <p:cNvCxnSpPr/>
+          <p:nvPr/>
+        </p:nvCxnSpPr>
+        <p:spPr>
+          <a:xfrm>
+            <a:off x="7772400" y="2468880"/>
+            <a:ext cx="0" cy="365760"/>
+          </a:xfrm>
+          <a:prstGeom prst="line">
+            <a:avLst/>
+          </a:prstGeom>
+          <a:ln w="15240">
+            <a:solidFill>
+              <a:srgbClr val="3C325A"/>
+            </a:solidFill>
+          </a:ln>
+        </p:spPr>
+        <p:style>
+          <a:lnRef idx="2">
+            <a:schemeClr val="accent1"/>
+          </a:lnRef>
+          <a:fillRef idx="0">
+            <a:schemeClr val="accent1"/>
+          </a:fillRef>
+          <a:effectRef idx="1">
+            <a:schemeClr val="accent1"/>
+          </a:effectRef>
+          <a:fontRef idx="minor">
+            <a:schemeClr val="tx1"/>
+          </a:fontRef>
+        </p:style>
+      </p:cxnSp>
+      <p:cxnSp>
+        <p:nvCxnSpPr>
+          <p:cNvPr id="15" name="Connector 14"/>
+          <p:cNvCxnSpPr/>
+          <p:nvPr/>
+        </p:nvCxnSpPr>
+        <p:spPr>
+          <a:xfrm flipH="1">
+            <a:off x="5760720" y="2468880"/>
+            <a:ext cx="2011680" cy="365760"/>
+          </a:xfrm>
+          <a:prstGeom prst="bentConnector3">
+            <a:avLst/>
+          </a:prstGeom>
+          <a:ln w="15240">
+            <a:solidFill>
+              <a:srgbClr val="3C325A"/>
+            </a:solidFill>
+          </a:ln>
+        </p:spPr>
+        <p:style>
+          <a:lnRef idx="2">
+            <a:schemeClr val="accent1"/>
+          </a:lnRef>
+          <a:fillRef idx="0">
+            <a:schemeClr val="accent1"/>
+          </a:fillRef>
+          <a:effectRef idx="1">
+            <a:schemeClr val="accent1"/>
+          </a:effectRef>
+          <a:fontRef idx="minor">
+            <a:schemeClr val="tx1"/>
+          </a:fontRef>
+        </p:style>
+      </p:cxnSp>
+      <p:cxnSp>
+        <p:nvCxnSpPr>
+          <p:cNvPr id="16" name="Connector 15"/>
+          <p:cNvCxnSpPr/>
+          <p:nvPr/>
+        </p:nvCxnSpPr>
+        <p:spPr>
+          <a:xfrm>
+            <a:off x="7772400" y="2468880"/>
+            <a:ext cx="2011680" cy="365760"/>
+          </a:xfrm>
+          <a:prstGeom prst="bentConnector3">
+            <a:avLst/>
+          </a:prstGeom>
+          <a:ln w="15240">
+            <a:solidFill>
+              <a:srgbClr val="3C325A"/>
+            </a:solidFill>
+          </a:ln>
+        </p:spPr>
+        <p:style>
+          <a:lnRef idx="2">
+            <a:schemeClr val="accent1"/>
+          </a:lnRef>
+          <a:fillRef idx="0">
+            <a:schemeClr val="accent1"/>
+          </a:fillRef>
+          <a:effectRef idx="1">
+            <a:schemeClr val="accent1"/>
+          </a:effectRef>
+          <a:fontRef idx="minor">
+            <a:schemeClr val="tx1"/>
+          </a:fontRef>
+        </p:style>
+      </p:cxnSp>
+      <p:sp>
+        <p:nvSpPr>
+          <p:cNvPr id="17" name="Rounded Rectangle 16"/>
+          <p:cNvSpPr/>
+          <p:nvPr/>
+        </p:nvSpPr>
+        <p:spPr>
+          <a:xfrm>
+            <a:off x="6766560" y="4480560"/>
+            <a:ext cx="2011680" cy="365760"/>
+          </a:xfrm>
+          <a:prstGeom prst="roundRect">
+            <a:avLst/>
+          </a:prstGeom>
+          <a:solidFill>
+            <a:srgbClr val="FFF9C4"/>
+          </a:solidFill>
+          <a:ln w="12700">
+            <a:solidFill>
+              <a:srgbClr val="3C325A"/>
+            </a:solidFill>
+          </a:ln>
+        </p:spPr>
+        <p:style>
+          <a:lnRef idx="1">
+            <a:schemeClr val="accent1"/>
+          </a:lnRef>
+          <a:fillRef idx="3">
+            <a:schemeClr val="accent1"/>
+          </a:fillRef>
+          <a:effectRef idx="2">
+            <a:schemeClr val="accent1"/>
+          </a:effectRef>
+          <a:fontRef idx="minor">
+            <a:schemeClr val="lt1"/>
+          </a:fontRef>
+        </p:style>
+        <p:txBody>
+          <a:bodyPr rtlCol="0" anchor="ctr" wrap="square" lIns="18288" rIns="18288" tIns="18288" bIns="18288"/>
+          <a:lstStyle/>
+          <a:p>
+            <a:pPr algn="ctr">
+              <a:defRPr sz="950" b="1">
+                <a:solidFill>
+                  <a:srgbClr val="282828"/>
+                </a:solidFill>
+                <a:latin typeface="Arial"/>
+              </a:defRPr>
+            </a:pPr>
+            <a:r>
+              <a:t>Weighted Decision Fusion</a:t>
+            </a:r>
+          </a:p>
+        </p:txBody>
+      </p:sp>
+      <p:cxnSp>
+        <p:nvCxnSpPr>
+          <p:cNvPr id="18" name="Connector 17"/>
+          <p:cNvCxnSpPr/>
+          <p:nvPr/>
+        </p:nvCxnSpPr>
+        <p:spPr>
+          <a:xfrm>
+            <a:off x="5760720" y="3931920"/>
+            <a:ext cx="2011680" cy="548640"/>
+          </a:xfrm>
+          <a:prstGeom prst="bentConnector3">
+            <a:avLst/>
+          </a:prstGeom>
+          <a:ln w="15240">
+            <a:solidFill>
+              <a:srgbClr val="3C325A"/>
+            </a:solidFill>
+          </a:ln>
+        </p:spPr>
+        <p:style>
+          <a:lnRef idx="2">
+            <a:schemeClr val="accent1"/>
+          </a:lnRef>
+          <a:fillRef idx="0">
+            <a:schemeClr val="accent1"/>
+          </a:fillRef>
+          <a:effectRef idx="1">
+            <a:schemeClr val="accent1"/>
+          </a:effectRef>
+          <a:fontRef idx="minor">
+            <a:schemeClr val="tx1"/>
+          </a:fontRef>
+        </p:style>
+      </p:cxnSp>
+      <p:cxnSp>
+        <p:nvCxnSpPr>
+          <p:cNvPr id="19" name="Connector 18"/>
+          <p:cNvCxnSpPr/>
+          <p:nvPr/>
+        </p:nvCxnSpPr>
+        <p:spPr>
+          <a:xfrm>
+            <a:off x="7772400" y="3931920"/>
+            <a:ext cx="0" cy="548640"/>
+          </a:xfrm>
+          <a:prstGeom prst="line">
+            <a:avLst/>
+          </a:prstGeom>
+          <a:ln w="15240">
+            <a:solidFill>
+              <a:srgbClr val="3C325A"/>
+            </a:solidFill>
+          </a:ln>
+        </p:spPr>
+        <p:style>
+          <a:lnRef idx="2">
+            <a:schemeClr val="accent1"/>
+          </a:lnRef>
+          <a:fillRef idx="0">
+            <a:schemeClr val="accent1"/>
+          </a:fillRef>
+          <a:effectRef idx="1">
+            <a:schemeClr val="accent1"/>
+          </a:effectRef>
+          <a:fontRef idx="minor">
+            <a:schemeClr val="tx1"/>
+          </a:fontRef>
+        </p:style>
+      </p:cxnSp>
+      <p:cxnSp>
+        <p:nvCxnSpPr>
+          <p:cNvPr id="20" name="Connector 19"/>
+          <p:cNvCxnSpPr/>
+          <p:nvPr/>
+        </p:nvCxnSpPr>
+        <p:spPr>
+          <a:xfrm flipH="1">
+            <a:off x="7772400" y="3931920"/>
+            <a:ext cx="2011680" cy="548640"/>
+          </a:xfrm>
+          <a:prstGeom prst="bentConnector3">
+            <a:avLst/>
+          </a:prstGeom>
+          <a:ln w="15240">
+            <a:solidFill>
+              <a:srgbClr val="3C325A"/>
+            </a:solidFill>
+          </a:ln>
+        </p:spPr>
+        <p:style>
+          <a:lnRef idx="2">
+            <a:schemeClr val="accent1"/>
+          </a:lnRef>
+          <a:fillRef idx="0">
+            <a:schemeClr val="accent1"/>
+          </a:fillRef>
+          <a:effectRef idx="1">
+            <a:schemeClr val="accent1"/>
+          </a:effectRef>
+          <a:fontRef idx="minor">
+            <a:schemeClr val="tx1"/>
+          </a:fontRef>
+        </p:style>
+      </p:cxnSp>
+      <p:sp>
+        <p:nvSpPr>
+          <p:cNvPr id="21" name="Rounded Rectangle 20"/>
+          <p:cNvSpPr/>
+          <p:nvPr/>
+        </p:nvSpPr>
+        <p:spPr>
+          <a:xfrm>
+            <a:off x="6766560" y="5029200"/>
+            <a:ext cx="2011680" cy="365760"/>
+          </a:xfrm>
+          <a:prstGeom prst="roundRect">
+            <a:avLst/>
+          </a:prstGeom>
+          <a:solidFill>
+            <a:srgbClr val="E1BEE7"/>
+          </a:solidFill>
+          <a:ln w="12700">
+            <a:solidFill>
+              <a:srgbClr val="3C325A"/>
+            </a:solidFill>
+          </a:ln>
+        </p:spPr>
+        <p:style>
+          <a:lnRef idx="1">
+            <a:schemeClr val="accent1"/>
+          </a:lnRef>
+          <a:fillRef idx="3">
+            <a:schemeClr val="accent1"/>
+          </a:fillRef>
+          <a:effectRef idx="2">
+            <a:schemeClr val="accent1"/>
+          </a:effectRef>
+          <a:fontRef idx="minor">
+            <a:schemeClr val="lt1"/>
+          </a:fontRef>
+        </p:style>
+        <p:txBody>
+          <a:bodyPr rtlCol="0" anchor="ctr" wrap="square" lIns="18288" rIns="18288" tIns="18288" bIns="18288"/>
+          <a:lstStyle/>
+          <a:p>
+            <a:pPr algn="ctr">
+              <a:defRPr sz="950" b="1">
+                <a:solidFill>
+                  <a:srgbClr val="282828"/>
+                </a:solidFill>
+                <a:latin typeface="Arial"/>
+              </a:defRPr>
+            </a:pPr>
+            <a:r>
+              <a:t>Linear Decision Threshold</a:t>
+            </a:r>
+          </a:p>
+        </p:txBody>
+      </p:sp>
+      <p:cxnSp>
+        <p:nvCxnSpPr>
+          <p:cNvPr id="22" name="Connector 21"/>
+          <p:cNvCxnSpPr/>
+          <p:nvPr/>
+        </p:nvCxnSpPr>
+        <p:spPr>
+          <a:xfrm>
+            <a:off x="7772400" y="5394960"/>
+            <a:ext cx="0" cy="182880"/>
+          </a:xfrm>
+          <a:prstGeom prst="line">
+            <a:avLst/>
+          </a:prstGeom>
+          <a:ln w="15240">
+            <a:solidFill>
+              <a:srgbClr val="3C325A"/>
+            </a:solidFill>
+          </a:ln>
+        </p:spPr>
+        <p:style>
+          <a:lnRef idx="2">
+            <a:schemeClr val="accent1"/>
+          </a:lnRef>
+          <a:fillRef idx="0">
+            <a:schemeClr val="accent1"/>
+          </a:fillRef>
+          <a:effectRef idx="1">
+            <a:schemeClr val="accent1"/>
+          </a:effectRef>
+          <a:fontRef idx="minor">
+            <a:schemeClr val="tx1"/>
+          </a:fontRef>
+        </p:style>
+      </p:cxnSp>
+      <p:sp>
+        <p:nvSpPr>
+          <p:cNvPr id="23" name="Rounded Rectangle 22"/>
+          <p:cNvSpPr/>
+          <p:nvPr/>
+        </p:nvSpPr>
+        <p:spPr>
+          <a:xfrm>
+            <a:off x="6766560" y="5577840"/>
+            <a:ext cx="2011680" cy="365760"/>
+          </a:xfrm>
+          <a:prstGeom prst="roundRect">
+            <a:avLst/>
+          </a:prstGeom>
+          <a:solidFill>
+            <a:srgbClr val="C8E6C9"/>
+          </a:solidFill>
+          <a:ln w="12700">
+            <a:solidFill>
+              <a:srgbClr val="3C325A"/>
+            </a:solidFill>
+          </a:ln>
+        </p:spPr>
+        <p:style>
+          <a:lnRef idx="1">
+            <a:schemeClr val="accent1"/>
+          </a:lnRef>
+          <a:fillRef idx="3">
+            <a:schemeClr val="accent1"/>
+          </a:fillRef>
+          <a:effectRef idx="2">
+            <a:schemeClr val="accent1"/>
+          </a:effectRef>
+          <a:fontRef idx="minor">
+            <a:schemeClr val="lt1"/>
+          </a:fontRef>
+        </p:style>
+        <p:txBody>
+          <a:bodyPr rtlCol="0" anchor="ctr" wrap="square" lIns="18288" rIns="18288" tIns="18288" bIns="18288"/>
+          <a:lstStyle/>
+          <a:p>
+            <a:pPr algn="ctr">
+              <a:defRPr sz="950" b="1">
+                <a:solidFill>
+                  <a:srgbClr val="282828"/>
+                </a:solidFill>
+                <a:latin typeface="Arial"/>
+              </a:defRPr>
+            </a:pPr>
+            <a:r>
+              <a:t>Output Verdict (Live/Spoof)</a:t>
             </a:r>
           </a:p>
         </p:txBody>
@@ -3863,7 +4689,7 @@
     <p:bg>
       <p:bgPr>
         <a:solidFill>
-          <a:srgbClr val="12141A"/>
+          <a:srgbClr val="0A0A10"/>
         </a:solidFill>
         <a:effectLst/>
       </p:bgPr>
@@ -3900,7 +4726,7 @@
             <a:pPr>
               <a:defRPr sz="3000" b="1">
                 <a:solidFill>
-                  <a:srgbClr val="2979FF"/>
+                  <a:srgbClr val="8A2BE2"/>
                 </a:solidFill>
                 <a:latin typeface="Arial"/>
               </a:defRPr>
@@ -3926,11 +4752,11 @@
             <a:avLst/>
           </a:prstGeom>
           <a:solidFill>
-            <a:srgbClr val="1C202A"/>
+            <a:srgbClr val="181622"/>
           </a:solidFill>
           <a:ln w="12700">
             <a:solidFill>
-              <a:srgbClr val="37474F"/>
+              <a:srgbClr val="3C325A"/>
             </a:solidFill>
           </a:ln>
         </p:spPr>
@@ -3971,7 +4797,7 @@
               </a:spcAft>
               <a:defRPr sz="900" b="1">
                 <a:solidFill>
-                  <a:srgbClr val="2979FF"/>
+                  <a:srgbClr val="8A2BE2"/>
                 </a:solidFill>
                 <a:latin typeface="Arial"/>
               </a:defRPr>
@@ -3987,7 +4813,7 @@
               </a:spcBef>
               <a:defRPr sz="1150">
                 <a:solidFill>
-                  <a:srgbClr val="D2D7DF"/>
+                  <a:srgbClr val="C8C8DC"/>
                 </a:solidFill>
                 <a:latin typeface="Arial"/>
               </a:defRPr>
@@ -4013,11 +4839,11 @@
             <a:avLst/>
           </a:prstGeom>
           <a:solidFill>
-            <a:srgbClr val="1C202A"/>
+            <a:srgbClr val="181622"/>
           </a:solidFill>
           <a:ln w="12700">
             <a:solidFill>
-              <a:srgbClr val="37474F"/>
+              <a:srgbClr val="3C325A"/>
             </a:solidFill>
           </a:ln>
         </p:spPr>
@@ -4058,7 +4884,7 @@
               </a:spcAft>
               <a:defRPr sz="900" b="1">
                 <a:solidFill>
-                  <a:srgbClr val="2979FF"/>
+                  <a:srgbClr val="8A2BE2"/>
                 </a:solidFill>
                 <a:latin typeface="Arial"/>
               </a:defRPr>
@@ -4074,7 +4900,7 @@
               </a:spcBef>
               <a:defRPr sz="1150">
                 <a:solidFill>
-                  <a:srgbClr val="D2D7DF"/>
+                  <a:srgbClr val="C8C8DC"/>
                 </a:solidFill>
                 <a:latin typeface="Arial"/>
               </a:defRPr>
@@ -4100,11 +4926,11 @@
             <a:avLst/>
           </a:prstGeom>
           <a:solidFill>
-            <a:srgbClr val="1C202A"/>
+            <a:srgbClr val="181622"/>
           </a:solidFill>
           <a:ln w="12700">
             <a:solidFill>
-              <a:srgbClr val="37474F"/>
+              <a:srgbClr val="3C325A"/>
             </a:solidFill>
           </a:ln>
         </p:spPr>
@@ -4145,7 +4971,7 @@
               </a:spcAft>
               <a:defRPr sz="900" b="1">
                 <a:solidFill>
-                  <a:srgbClr val="2979FF"/>
+                  <a:srgbClr val="8A2BE2"/>
                 </a:solidFill>
                 <a:latin typeface="Arial"/>
               </a:defRPr>
@@ -4161,7 +4987,7 @@
               </a:spcBef>
               <a:defRPr sz="1150">
                 <a:solidFill>
-                  <a:srgbClr val="D2D7DF"/>
+                  <a:srgbClr val="C8C8DC"/>
                 </a:solidFill>
                 <a:latin typeface="Arial"/>
               </a:defRPr>
@@ -4187,11 +5013,11 @@
             <a:avLst/>
           </a:prstGeom>
           <a:solidFill>
-            <a:srgbClr val="1C202A"/>
+            <a:srgbClr val="181622"/>
           </a:solidFill>
           <a:ln w="12700">
             <a:solidFill>
-              <a:srgbClr val="37474F"/>
+              <a:srgbClr val="3C325A"/>
             </a:solidFill>
           </a:ln>
         </p:spPr>
@@ -4232,7 +5058,7 @@
               </a:spcAft>
               <a:defRPr sz="900" b="1">
                 <a:solidFill>
-                  <a:srgbClr val="2979FF"/>
+                  <a:srgbClr val="8A2BE2"/>
                 </a:solidFill>
                 <a:latin typeface="Arial"/>
               </a:defRPr>
@@ -4248,7 +5074,7 @@
               </a:spcBef>
               <a:defRPr sz="1150">
                 <a:solidFill>
-                  <a:srgbClr val="D2D7DF"/>
+                  <a:srgbClr val="C8C8DC"/>
                 </a:solidFill>
                 <a:latin typeface="Arial"/>
               </a:defRPr>
@@ -4368,7 +5194,7 @@
                       <a:pPr algn="ctr">
                         <a:defRPr sz="1300" b="1">
                           <a:solidFill>
-                            <a:srgbClr val="2979FF"/>
+                            <a:srgbClr val="8A2BE2"/>
                           </a:solidFill>
                           <a:latin typeface="Arial"/>
                         </a:defRPr>
@@ -4380,7 +5206,7 @@
                   </a:txBody>
                   <a:tcPr>
                     <a:solidFill>
-                      <a:srgbClr val="1C202A"/>
+                      <a:srgbClr val="181622"/>
                     </a:solidFill>
                   </a:tcPr>
                 </a:tc>
@@ -4392,7 +5218,7 @@
                       <a:pPr algn="ctr">
                         <a:defRPr sz="1300" b="1">
                           <a:solidFill>
-                            <a:srgbClr val="2979FF"/>
+                            <a:srgbClr val="8A2BE2"/>
                           </a:solidFill>
                           <a:latin typeface="Arial"/>
                         </a:defRPr>
@@ -4404,7 +5230,7 @@
                   </a:txBody>
                   <a:tcPr>
                     <a:solidFill>
-                      <a:srgbClr val="1C202A"/>
+                      <a:srgbClr val="181622"/>
                     </a:solidFill>
                   </a:tcPr>
                 </a:tc>
@@ -4418,7 +5244,7 @@
                       <a:pPr algn="ctr">
                         <a:defRPr sz="1100">
                           <a:solidFill>
-                            <a:srgbClr val="D2D7DF"/>
+                            <a:srgbClr val="C8C8DC"/>
                           </a:solidFill>
                           <a:latin typeface="Arial"/>
                         </a:defRPr>
@@ -4430,7 +5256,7 @@
                   </a:txBody>
                   <a:tcPr>
                     <a:solidFill>
-                      <a:srgbClr val="12141A"/>
+                      <a:srgbClr val="0A0A10"/>
                     </a:solidFill>
                   </a:tcPr>
                 </a:tc>
@@ -4454,7 +5280,7 @@
                   </a:txBody>
                   <a:tcPr>
                     <a:solidFill>
-                      <a:srgbClr val="12141A"/>
+                      <a:srgbClr val="0A0A10"/>
                     </a:solidFill>
                   </a:tcPr>
                 </a:tc>
@@ -4468,7 +5294,7 @@
                       <a:pPr algn="ctr">
                         <a:defRPr sz="1100">
                           <a:solidFill>
-                            <a:srgbClr val="D2D7DF"/>
+                            <a:srgbClr val="C8C8DC"/>
                           </a:solidFill>
                           <a:latin typeface="Arial"/>
                         </a:defRPr>
@@ -4480,7 +5306,7 @@
                   </a:txBody>
                   <a:tcPr>
                     <a:solidFill>
-                      <a:srgbClr val="12141A"/>
+                      <a:srgbClr val="0A0A10"/>
                     </a:solidFill>
                   </a:tcPr>
                 </a:tc>
@@ -4504,7 +5330,7 @@
                   </a:txBody>
                   <a:tcPr>
                     <a:solidFill>
-                      <a:srgbClr val="12141A"/>
+                      <a:srgbClr val="0A0A10"/>
                     </a:solidFill>
                   </a:tcPr>
                 </a:tc>
@@ -4518,7 +5344,7 @@
                       <a:pPr algn="ctr">
                         <a:defRPr sz="1100">
                           <a:solidFill>
-                            <a:srgbClr val="D2D7DF"/>
+                            <a:srgbClr val="C8C8DC"/>
                           </a:solidFill>
                           <a:latin typeface="Arial"/>
                         </a:defRPr>
@@ -4530,7 +5356,7 @@
                   </a:txBody>
                   <a:tcPr>
                     <a:solidFill>
-                      <a:srgbClr val="12141A"/>
+                      <a:srgbClr val="0A0A10"/>
                     </a:solidFill>
                   </a:tcPr>
                 </a:tc>
@@ -4554,7 +5380,7 @@
                   </a:txBody>
                   <a:tcPr>
                     <a:solidFill>
-                      <a:srgbClr val="12141A"/>
+                      <a:srgbClr val="0A0A10"/>
                     </a:solidFill>
                   </a:tcPr>
                 </a:tc>
@@ -4568,7 +5394,7 @@
                       <a:pPr algn="ctr">
                         <a:defRPr sz="1100">
                           <a:solidFill>
-                            <a:srgbClr val="D2D7DF"/>
+                            <a:srgbClr val="C8C8DC"/>
                           </a:solidFill>
                           <a:latin typeface="Arial"/>
                         </a:defRPr>
@@ -4580,7 +5406,7 @@
                   </a:txBody>
                   <a:tcPr>
                     <a:solidFill>
-                      <a:srgbClr val="12141A"/>
+                      <a:srgbClr val="0A0A10"/>
                     </a:solidFill>
                   </a:tcPr>
                 </a:tc>
@@ -4604,7 +5430,7 @@
                   </a:txBody>
                   <a:tcPr>
                     <a:solidFill>
-                      <a:srgbClr val="12141A"/>
+                      <a:srgbClr val="0A0A10"/>
                     </a:solidFill>
                   </a:tcPr>
                 </a:tc>
@@ -4641,7 +5467,7 @@
               </a:spcAft>
               <a:defRPr sz="1500" b="1">
                 <a:solidFill>
-                  <a:srgbClr val="2979FF"/>
+                  <a:srgbClr val="8A2BE2"/>
                 </a:solidFill>
                 <a:latin typeface="Arial"/>
               </a:defRPr>
@@ -4657,7 +5483,7 @@
               </a:spcAft>
               <a:defRPr sz="1050">
                 <a:solidFill>
-                  <a:srgbClr val="D2D7DF"/>
+                  <a:srgbClr val="C8C8DC"/>
                 </a:solidFill>
                 <a:latin typeface="Arial"/>
               </a:defRPr>
@@ -4673,7 +5499,7 @@
               </a:spcAft>
               <a:defRPr sz="1050">
                 <a:solidFill>
-                  <a:srgbClr val="D2D7DF"/>
+                  <a:srgbClr val="C8C8DC"/>
                 </a:solidFill>
                 <a:latin typeface="Arial"/>
               </a:defRPr>
@@ -4689,7 +5515,7 @@
               </a:spcAft>
               <a:defRPr sz="1050">
                 <a:solidFill>
-                  <a:srgbClr val="D2D7DF"/>
+                  <a:srgbClr val="C8C8DC"/>
                 </a:solidFill>
                 <a:latin typeface="Arial"/>
               </a:defRPr>
@@ -4705,7 +5531,7 @@
               </a:spcAft>
               <a:defRPr sz="1050">
                 <a:solidFill>
-                  <a:srgbClr val="D2D7DF"/>
+                  <a:srgbClr val="C8C8DC"/>
                 </a:solidFill>
                 <a:latin typeface="Arial"/>
               </a:defRPr>
@@ -4822,7 +5648,7 @@
               </a:spcBef>
               <a:defRPr sz="1400" b="1">
                 <a:solidFill>
-                  <a:srgbClr val="2979FF"/>
+                  <a:srgbClr val="8A2BE2"/>
                 </a:solidFill>
                 <a:latin typeface="Arial"/>
               </a:defRPr>
@@ -4838,7 +5664,7 @@
               </a:spcAft>
               <a:defRPr sz="1100">
                 <a:solidFill>
-                  <a:srgbClr val="D2D7DF"/>
+                  <a:srgbClr val="C8C8DC"/>
                 </a:solidFill>
                 <a:latin typeface="Arial"/>
               </a:defRPr>
@@ -4862,7 +5688,7 @@
               </a:spcBef>
               <a:defRPr sz="1400" b="1">
                 <a:solidFill>
-                  <a:srgbClr val="2979FF"/>
+                  <a:srgbClr val="8A2BE2"/>
                 </a:solidFill>
                 <a:latin typeface="Arial"/>
               </a:defRPr>
@@ -4878,7 +5704,7 @@
               </a:spcAft>
               <a:defRPr sz="1100">
                 <a:solidFill>
-                  <a:srgbClr val="D2D7DF"/>
+                  <a:srgbClr val="C8C8DC"/>
                 </a:solidFill>
                 <a:latin typeface="Arial"/>
               </a:defRPr>
@@ -4898,7 +5724,7 @@
               </a:spcBef>
               <a:defRPr sz="1400" b="1">
                 <a:solidFill>
-                  <a:srgbClr val="2979FF"/>
+                  <a:srgbClr val="8A2BE2"/>
                 </a:solidFill>
                 <a:latin typeface="Arial"/>
               </a:defRPr>
@@ -4914,7 +5740,7 @@
               </a:spcAft>
               <a:defRPr sz="1100">
                 <a:solidFill>
-                  <a:srgbClr val="D2D7DF"/>
+                  <a:srgbClr val="C8C8DC"/>
                 </a:solidFill>
                 <a:latin typeface="Arial"/>
               </a:defRPr>
@@ -4939,7 +5765,7 @@
     <p:bg>
       <p:bgPr>
         <a:solidFill>
-          <a:srgbClr val="12141A"/>
+          <a:srgbClr val="0A0A10"/>
         </a:solidFill>
         <a:effectLst/>
       </p:bgPr>
@@ -4976,7 +5802,7 @@
             <a:pPr>
               <a:defRPr sz="3000" b="1">
                 <a:solidFill>
-                  <a:srgbClr val="2979FF"/>
+                  <a:srgbClr val="8A2BE2"/>
                 </a:solidFill>
                 <a:latin typeface="Arial"/>
               </a:defRPr>
@@ -5002,11 +5828,11 @@
             <a:avLst/>
           </a:prstGeom>
           <a:solidFill>
-            <a:srgbClr val="1C202A"/>
+            <a:srgbClr val="181622"/>
           </a:solidFill>
           <a:ln w="12700">
             <a:solidFill>
-              <a:srgbClr val="37474F"/>
+              <a:srgbClr val="3C325A"/>
             </a:solidFill>
           </a:ln>
         </p:spPr>
@@ -5050,7 +5876,7 @@
               </a:spcAft>
               <a:defRPr sz="1300">
                 <a:solidFill>
-                  <a:srgbClr val="D2D7DF"/>
+                  <a:srgbClr val="C8C8DC"/>
                 </a:solidFill>
                 <a:latin typeface="Arial"/>
               </a:defRPr>
@@ -5066,7 +5892,7 @@
               </a:spcAft>
               <a:defRPr sz="1300">
                 <a:solidFill>
-                  <a:srgbClr val="D2D7DF"/>
+                  <a:srgbClr val="C8C8DC"/>
                 </a:solidFill>
                 <a:latin typeface="Arial"/>
               </a:defRPr>
@@ -5082,7 +5908,7 @@
               </a:spcAft>
               <a:defRPr sz="1300">
                 <a:solidFill>
-                  <a:srgbClr val="D2D7DF"/>
+                  <a:srgbClr val="C8C8DC"/>
                 </a:solidFill>
                 <a:latin typeface="Arial"/>
               </a:defRPr>
@@ -5108,11 +5934,11 @@
             <a:avLst/>
           </a:prstGeom>
           <a:solidFill>
-            <a:srgbClr val="1C202A"/>
+            <a:srgbClr val="181622"/>
           </a:solidFill>
           <a:ln w="12700">
             <a:solidFill>
-              <a:srgbClr val="37474F"/>
+              <a:srgbClr val="3C325A"/>
             </a:solidFill>
           </a:ln>
         </p:spPr>
@@ -5140,7 +5966,7 @@
               </a:spcAft>
               <a:defRPr sz="1800" b="1">
                 <a:solidFill>
-                  <a:srgbClr val="2979FF"/>
+                  <a:srgbClr val="8A2BE2"/>
                 </a:solidFill>
                 <a:latin typeface="Arial"/>
               </a:defRPr>
@@ -5156,7 +5982,7 @@
               </a:spcBef>
               <a:defRPr sz="1200">
                 <a:solidFill>
-                  <a:srgbClr val="D2D7DF"/>
+                  <a:srgbClr val="C8C8DC"/>
                 </a:solidFill>
                 <a:latin typeface="Arial"/>
               </a:defRPr>

</xml_diff>

<commit_message>
docs: Change presentation theme to minimal office white, adding bounded pictures on the right side
</commit_message>
<xml_diff>
--- a/reports/cdac_project_review.pptx
+++ b/reports/cdac_project_review.pptx
@@ -3087,6 +3087,14 @@
 <file path=ppt/slides/slide1.xml><?xml version="1.0" encoding="utf-8"?>
 <p:sld xmlns:a="http://schemas.openxmlformats.org/drawingml/2006/main" xmlns:p="http://schemas.openxmlformats.org/presentationml/2006/main" xmlns:r="http://schemas.openxmlformats.org/officeDocument/2006/relationships">
   <p:cSld>
+    <p:bg>
+      <p:bgPr>
+        <a:solidFill>
+          <a:srgbClr val="FFFFFF"/>
+        </a:solidFill>
+        <a:effectLst/>
+      </p:bgPr>
+    </p:bg>
     <p:spTree>
       <p:nvGrpSpPr>
         <p:cNvPr id="1" name=""/>
@@ -3110,8 +3118,8 @@
         </p:blipFill>
         <p:spPr>
           <a:xfrm>
-            <a:off x="0" y="0"/>
-            <a:ext cx="12191695" cy="6858000"/>
+            <a:off x="6217920" y="731520"/>
+            <a:ext cx="5212080" cy="5303520"/>
           </a:xfrm>
           <a:prstGeom prst="rect">
             <a:avLst/>
@@ -3143,7 +3151,7 @@
             <a:pPr>
               <a:defRPr sz="4200" b="1">
                 <a:solidFill>
-                  <a:srgbClr val="FFFFFF"/>
+                  <a:srgbClr val="141821"/>
                 </a:solidFill>
                 <a:latin typeface="Arial"/>
               </a:defRPr>
@@ -3159,7 +3167,7 @@
               </a:spcBef>
               <a:defRPr sz="1500" b="1">
                 <a:solidFill>
-                  <a:srgbClr val="8A2BE2"/>
+                  <a:srgbClr val="0066CC"/>
                 </a:solidFill>
                 <a:latin typeface="Arial"/>
               </a:defRPr>
@@ -3195,7 +3203,7 @@
             <a:pPr>
               <a:defRPr sz="1150" b="1">
                 <a:solidFill>
-                  <a:srgbClr val="C8C8DC"/>
+                  <a:srgbClr val="3C404B"/>
                 </a:solidFill>
                 <a:latin typeface="Arial"/>
               </a:defRPr>
@@ -3211,7 +3219,7 @@
               </a:spcBef>
               <a:defRPr sz="1150" b="1">
                 <a:solidFill>
-                  <a:srgbClr val="C8C8DC"/>
+                  <a:srgbClr val="3C404B"/>
                 </a:solidFill>
                 <a:latin typeface="Arial"/>
               </a:defRPr>
@@ -3227,7 +3235,7 @@
               </a:spcBef>
               <a:defRPr sz="1150">
                 <a:solidFill>
-                  <a:srgbClr val="827896"/>
+                  <a:srgbClr val="6E737D"/>
                 </a:solidFill>
                 <a:latin typeface="Arial"/>
               </a:defRPr>
@@ -3253,11 +3261,11 @@
             <a:avLst/>
           </a:prstGeom>
           <a:solidFill>
-            <a:srgbClr val="181622"/>
+            <a:srgbClr val="F5F6F8"/>
           </a:solidFill>
           <a:ln w="12700">
             <a:solidFill>
-              <a:srgbClr val="3C325A"/>
+              <a:srgbClr val="C8CDD7"/>
             </a:solidFill>
           </a:ln>
         </p:spPr>
@@ -3282,7 +3290,7 @@
             <a:pPr algn="ctr">
               <a:defRPr sz="1500" b="1">
                 <a:solidFill>
-                  <a:srgbClr val="8A2BE2"/>
+                  <a:srgbClr val="0066CC"/>
                 </a:solidFill>
                 <a:latin typeface="Arial"/>
               </a:defRPr>
@@ -3298,7 +3306,7 @@
               </a:spcBef>
               <a:defRPr sz="1100">
                 <a:solidFill>
-                  <a:srgbClr val="C8C8DC"/>
+                  <a:srgbClr val="3C404B"/>
                 </a:solidFill>
                 <a:latin typeface="Arial"/>
               </a:defRPr>
@@ -3335,7 +3343,7 @@
     <p:bg>
       <p:bgPr>
         <a:solidFill>
-          <a:srgbClr val="0A0A10"/>
+          <a:srgbClr val="FFFFFF"/>
         </a:solidFill>
         <a:effectLst/>
       </p:bgPr>
@@ -3372,7 +3380,7 @@
             <a:pPr>
               <a:defRPr sz="3000" b="1">
                 <a:solidFill>
-                  <a:srgbClr val="8A2BE2"/>
+                  <a:srgbClr val="141821"/>
                 </a:solidFill>
                 <a:latin typeface="Arial"/>
               </a:defRPr>
@@ -3411,7 +3419,7 @@
               </a:spcAft>
               <a:defRPr sz="1800" b="1">
                 <a:solidFill>
-                  <a:srgbClr val="8A2BE2"/>
+                  <a:srgbClr val="0066CC"/>
                 </a:solidFill>
                 <a:latin typeface="Arial"/>
               </a:defRPr>
@@ -3427,7 +3435,7 @@
               </a:spcAft>
               <a:defRPr sz="1300">
                 <a:solidFill>
-                  <a:srgbClr val="C8C8DC"/>
+                  <a:srgbClr val="3C404B"/>
                 </a:solidFill>
                 <a:latin typeface="Arial"/>
               </a:defRPr>
@@ -3443,7 +3451,7 @@
               </a:spcAft>
               <a:defRPr sz="1300">
                 <a:solidFill>
-                  <a:srgbClr val="C8C8DC"/>
+                  <a:srgbClr val="3C404B"/>
                 </a:solidFill>
                 <a:latin typeface="Arial"/>
               </a:defRPr>
@@ -3459,7 +3467,7 @@
               </a:spcAft>
               <a:defRPr sz="1300">
                 <a:solidFill>
-                  <a:srgbClr val="C8C8DC"/>
+                  <a:srgbClr val="3C404B"/>
                 </a:solidFill>
                 <a:latin typeface="Arial"/>
               </a:defRPr>
@@ -3475,7 +3483,7 @@
               </a:spcAft>
               <a:defRPr sz="1300">
                 <a:solidFill>
-                  <a:srgbClr val="C8C8DC"/>
+                  <a:srgbClr val="3C404B"/>
                 </a:solidFill>
                 <a:latin typeface="Arial"/>
               </a:defRPr>
@@ -3514,7 +3522,7 @@
               </a:spcAft>
               <a:defRPr sz="1800" b="1">
                 <a:solidFill>
-                  <a:srgbClr val="FFFFFF"/>
+                  <a:srgbClr val="141821"/>
                 </a:solidFill>
                 <a:latin typeface="Arial"/>
               </a:defRPr>
@@ -3530,7 +3538,7 @@
               </a:spcBef>
               <a:defRPr sz="1400" b="1">
                 <a:solidFill>
-                  <a:srgbClr val="8A2BE2"/>
+                  <a:srgbClr val="0066CC"/>
                 </a:solidFill>
                 <a:latin typeface="Arial"/>
               </a:defRPr>
@@ -3546,7 +3554,7 @@
               </a:spcAft>
               <a:defRPr sz="1200">
                 <a:solidFill>
-                  <a:srgbClr val="C8C8DC"/>
+                  <a:srgbClr val="3C404B"/>
                 </a:solidFill>
                 <a:latin typeface="Arial"/>
               </a:defRPr>
@@ -3562,7 +3570,7 @@
               </a:spcBef>
               <a:defRPr sz="1400" b="1">
                 <a:solidFill>
-                  <a:srgbClr val="8A2BE2"/>
+                  <a:srgbClr val="0066CC"/>
                 </a:solidFill>
                 <a:latin typeface="Arial"/>
               </a:defRPr>
@@ -3578,7 +3586,7 @@
               </a:spcAft>
               <a:defRPr sz="1200">
                 <a:solidFill>
-                  <a:srgbClr val="C8C8DC"/>
+                  <a:srgbClr val="3C404B"/>
                 </a:solidFill>
                 <a:latin typeface="Arial"/>
               </a:defRPr>
@@ -3594,7 +3602,7 @@
               </a:spcBef>
               <a:defRPr sz="1400" b="1">
                 <a:solidFill>
-                  <a:srgbClr val="8A2BE2"/>
+                  <a:srgbClr val="0066CC"/>
                 </a:solidFill>
                 <a:latin typeface="Arial"/>
               </a:defRPr>
@@ -3610,7 +3618,7 @@
               </a:spcAft>
               <a:defRPr sz="1200">
                 <a:solidFill>
-                  <a:srgbClr val="C8C8DC"/>
+                  <a:srgbClr val="3C404B"/>
                 </a:solidFill>
                 <a:latin typeface="Arial"/>
               </a:defRPr>
@@ -3635,7 +3643,7 @@
     <p:bg>
       <p:bgPr>
         <a:solidFill>
-          <a:srgbClr val="0A0A10"/>
+          <a:srgbClr val="FFFFFF"/>
         </a:solidFill>
         <a:effectLst/>
       </p:bgPr>
@@ -3672,7 +3680,7 @@
             <a:pPr>
               <a:defRPr sz="3000" b="1">
                 <a:solidFill>
-                  <a:srgbClr val="8A2BE2"/>
+                  <a:srgbClr val="141821"/>
                 </a:solidFill>
                 <a:latin typeface="Arial"/>
               </a:defRPr>
@@ -3711,7 +3719,7 @@
               </a:spcAft>
               <a:defRPr sz="1800" b="1">
                 <a:solidFill>
-                  <a:srgbClr val="8A2BE2"/>
+                  <a:srgbClr val="0066CC"/>
                 </a:solidFill>
                 <a:latin typeface="Arial"/>
               </a:defRPr>
@@ -3727,7 +3735,7 @@
               </a:spcAft>
               <a:defRPr sz="1200">
                 <a:solidFill>
-                  <a:srgbClr val="C8C8DC"/>
+                  <a:srgbClr val="3C404B"/>
                 </a:solidFill>
                 <a:latin typeface="Arial"/>
               </a:defRPr>
@@ -3743,7 +3751,7 @@
               </a:spcAft>
               <a:defRPr sz="1200">
                 <a:solidFill>
-                  <a:srgbClr val="C8C8DC"/>
+                  <a:srgbClr val="3C404B"/>
                 </a:solidFill>
                 <a:latin typeface="Arial"/>
               </a:defRPr>
@@ -3759,7 +3767,7 @@
               </a:spcAft>
               <a:defRPr sz="1200">
                 <a:solidFill>
-                  <a:srgbClr val="C8C8DC"/>
+                  <a:srgbClr val="3C404B"/>
                 </a:solidFill>
                 <a:latin typeface="Arial"/>
               </a:defRPr>
@@ -3775,7 +3783,7 @@
               </a:spcAft>
               <a:defRPr sz="1200">
                 <a:solidFill>
-                  <a:srgbClr val="C8C8DC"/>
+                  <a:srgbClr val="3C404B"/>
                 </a:solidFill>
                 <a:latin typeface="Arial"/>
               </a:defRPr>
@@ -3801,11 +3809,11 @@
             <a:avLst/>
           </a:prstGeom>
           <a:solidFill>
-            <a:srgbClr val="F8BBD0"/>
+            <a:srgbClr val="FCE4EC"/>
           </a:solidFill>
           <a:ln w="12700">
             <a:solidFill>
-              <a:srgbClr val="3C325A"/>
+              <a:srgbClr val="C8CDD7"/>
             </a:solidFill>
           </a:ln>
         </p:spPr>
@@ -3830,7 +3838,7 @@
             <a:pPr algn="ctr">
               <a:defRPr sz="950" b="1">
                 <a:solidFill>
-                  <a:srgbClr val="282828"/>
+                  <a:srgbClr val="3C3C3C"/>
                 </a:solidFill>
                 <a:latin typeface="Arial"/>
               </a:defRPr>
@@ -3857,7 +3865,7 @@
           </a:prstGeom>
           <a:ln w="15240">
             <a:solidFill>
-              <a:srgbClr val="3C325A"/>
+              <a:srgbClr val="A0A5AF"/>
             </a:solidFill>
           </a:ln>
         </p:spPr>
@@ -3891,11 +3899,11 @@
             <a:avLst/>
           </a:prstGeom>
           <a:solidFill>
-            <a:srgbClr val="FFE0B2"/>
+            <a:srgbClr val="FFF3E0"/>
           </a:solidFill>
           <a:ln w="12700">
             <a:solidFill>
-              <a:srgbClr val="3C325A"/>
+              <a:srgbClr val="C8CDD7"/>
             </a:solidFill>
           </a:ln>
         </p:spPr>
@@ -3920,7 +3928,7 @@
             <a:pPr algn="ctr">
               <a:defRPr sz="950" b="1">
                 <a:solidFill>
-                  <a:srgbClr val="282828"/>
+                  <a:srgbClr val="3C3C3C"/>
                 </a:solidFill>
                 <a:latin typeface="Arial"/>
               </a:defRPr>
@@ -3947,7 +3955,7 @@
           </a:prstGeom>
           <a:ln w="15240">
             <a:solidFill>
-              <a:srgbClr val="3C325A"/>
+              <a:srgbClr val="A0A5AF"/>
             </a:solidFill>
           </a:ln>
         </p:spPr>
@@ -3981,11 +3989,11 @@
             <a:avLst/>
           </a:prstGeom>
           <a:solidFill>
-            <a:srgbClr val="FFF9C4"/>
+            <a:srgbClr val="FFFDE7"/>
           </a:solidFill>
           <a:ln w="12700">
             <a:solidFill>
-              <a:srgbClr val="3C325A"/>
+              <a:srgbClr val="C8CDD7"/>
             </a:solidFill>
           </a:ln>
         </p:spPr>
@@ -4010,7 +4018,7 @@
             <a:pPr algn="ctr">
               <a:defRPr sz="950" b="1">
                 <a:solidFill>
-                  <a:srgbClr val="282828"/>
+                  <a:srgbClr val="3C3C3C"/>
                 </a:solidFill>
                 <a:latin typeface="Arial"/>
               </a:defRPr>
@@ -4035,10 +4043,12 @@
           <a:prstGeom prst="roundRect">
             <a:avLst/>
           </a:prstGeom>
-          <a:noFill/>
+          <a:solidFill>
+            <a:srgbClr val="F5F6F8"/>
+          </a:solidFill>
           <a:ln w="19050">
             <a:solidFill>
-              <a:srgbClr val="3C325A"/>
+              <a:srgbClr val="C8CDD7"/>
             </a:solidFill>
           </a:ln>
         </p:spPr>
@@ -4089,7 +4099,7 @@
             <a:pPr>
               <a:defRPr sz="1400" b="1">
                 <a:solidFill>
-                  <a:srgbClr val="8A2BE2"/>
+                  <a:srgbClr val="0066CC"/>
                 </a:solidFill>
                 <a:latin typeface="Arial"/>
               </a:defRPr>
@@ -4119,7 +4129,7 @@
           </a:solidFill>
           <a:ln w="12700">
             <a:solidFill>
-              <a:srgbClr val="3C325A"/>
+              <a:srgbClr val="C8CDD7"/>
             </a:solidFill>
           </a:ln>
         </p:spPr>
@@ -4144,7 +4154,7 @@
             <a:pPr algn="ctr">
               <a:defRPr sz="950" b="1">
                 <a:solidFill>
-                  <a:srgbClr val="282828"/>
+                  <a:srgbClr val="3C3C3C"/>
                 </a:solidFill>
                 <a:latin typeface="Arial"/>
               </a:defRPr>
@@ -4174,7 +4184,7 @@
           </a:solidFill>
           <a:ln w="12700">
             <a:solidFill>
-              <a:srgbClr val="3C325A"/>
+              <a:srgbClr val="C8CDD7"/>
             </a:solidFill>
           </a:ln>
         </p:spPr>
@@ -4199,7 +4209,7 @@
             <a:pPr algn="ctr">
               <a:defRPr sz="950" b="1">
                 <a:solidFill>
-                  <a:srgbClr val="282828"/>
+                  <a:srgbClr val="3C3C3C"/>
                 </a:solidFill>
                 <a:latin typeface="Arial"/>
               </a:defRPr>
@@ -4229,7 +4239,7 @@
           </a:solidFill>
           <a:ln w="12700">
             <a:solidFill>
-              <a:srgbClr val="3C325A"/>
+              <a:srgbClr val="C8CDD7"/>
             </a:solidFill>
           </a:ln>
         </p:spPr>
@@ -4254,7 +4264,7 @@
             <a:pPr algn="ctr">
               <a:defRPr sz="950" b="1">
                 <a:solidFill>
-                  <a:srgbClr val="282828"/>
+                  <a:srgbClr val="3C3C3C"/>
                 </a:solidFill>
                 <a:latin typeface="Arial"/>
               </a:defRPr>
@@ -4281,7 +4291,7 @@
           </a:prstGeom>
           <a:ln w="15240">
             <a:solidFill>
-              <a:srgbClr val="3C325A"/>
+              <a:srgbClr val="A0A5AF"/>
             </a:solidFill>
           </a:ln>
         </p:spPr>
@@ -4316,7 +4326,7 @@
           </a:prstGeom>
           <a:ln w="15240">
             <a:solidFill>
-              <a:srgbClr val="3C325A"/>
+              <a:srgbClr val="A0A5AF"/>
             </a:solidFill>
           </a:ln>
         </p:spPr>
@@ -4351,7 +4361,7 @@
           </a:prstGeom>
           <a:ln w="15240">
             <a:solidFill>
-              <a:srgbClr val="3C325A"/>
+              <a:srgbClr val="A0A5AF"/>
             </a:solidFill>
           </a:ln>
         </p:spPr>
@@ -4385,11 +4395,11 @@
             <a:avLst/>
           </a:prstGeom>
           <a:solidFill>
-            <a:srgbClr val="FFF9C4"/>
+            <a:srgbClr val="FFFDE7"/>
           </a:solidFill>
           <a:ln w="12700">
             <a:solidFill>
-              <a:srgbClr val="3C325A"/>
+              <a:srgbClr val="C8CDD7"/>
             </a:solidFill>
           </a:ln>
         </p:spPr>
@@ -4414,7 +4424,7 @@
             <a:pPr algn="ctr">
               <a:defRPr sz="950" b="1">
                 <a:solidFill>
-                  <a:srgbClr val="282828"/>
+                  <a:srgbClr val="3C3C3C"/>
                 </a:solidFill>
                 <a:latin typeface="Arial"/>
               </a:defRPr>
@@ -4441,7 +4451,7 @@
           </a:prstGeom>
           <a:ln w="15240">
             <a:solidFill>
-              <a:srgbClr val="3C325A"/>
+              <a:srgbClr val="A0A5AF"/>
             </a:solidFill>
           </a:ln>
         </p:spPr>
@@ -4476,7 +4486,7 @@
           </a:prstGeom>
           <a:ln w="15240">
             <a:solidFill>
-              <a:srgbClr val="3C325A"/>
+              <a:srgbClr val="A0A5AF"/>
             </a:solidFill>
           </a:ln>
         </p:spPr>
@@ -4511,7 +4521,7 @@
           </a:prstGeom>
           <a:ln w="15240">
             <a:solidFill>
-              <a:srgbClr val="3C325A"/>
+              <a:srgbClr val="A0A5AF"/>
             </a:solidFill>
           </a:ln>
         </p:spPr>
@@ -4545,11 +4555,11 @@
             <a:avLst/>
           </a:prstGeom>
           <a:solidFill>
-            <a:srgbClr val="E1BEE7"/>
+            <a:srgbClr val="F3E5F5"/>
           </a:solidFill>
           <a:ln w="12700">
             <a:solidFill>
-              <a:srgbClr val="3C325A"/>
+              <a:srgbClr val="C8CDD7"/>
             </a:solidFill>
           </a:ln>
         </p:spPr>
@@ -4574,7 +4584,7 @@
             <a:pPr algn="ctr">
               <a:defRPr sz="950" b="1">
                 <a:solidFill>
-                  <a:srgbClr val="282828"/>
+                  <a:srgbClr val="3C3C3C"/>
                 </a:solidFill>
                 <a:latin typeface="Arial"/>
               </a:defRPr>
@@ -4601,7 +4611,7 @@
           </a:prstGeom>
           <a:ln w="15240">
             <a:solidFill>
-              <a:srgbClr val="3C325A"/>
+              <a:srgbClr val="A0A5AF"/>
             </a:solidFill>
           </a:ln>
         </p:spPr>
@@ -4635,11 +4645,11 @@
             <a:avLst/>
           </a:prstGeom>
           <a:solidFill>
-            <a:srgbClr val="C8E6C9"/>
+            <a:srgbClr val="E8F5E9"/>
           </a:solidFill>
           <a:ln w="12700">
             <a:solidFill>
-              <a:srgbClr val="3C325A"/>
+              <a:srgbClr val="C8CDD7"/>
             </a:solidFill>
           </a:ln>
         </p:spPr>
@@ -4664,7 +4674,7 @@
             <a:pPr algn="ctr">
               <a:defRPr sz="950" b="1">
                 <a:solidFill>
-                  <a:srgbClr val="282828"/>
+                  <a:srgbClr val="3C3C3C"/>
                 </a:solidFill>
                 <a:latin typeface="Arial"/>
               </a:defRPr>
@@ -4689,7 +4699,7 @@
     <p:bg>
       <p:bgPr>
         <a:solidFill>
-          <a:srgbClr val="0A0A10"/>
+          <a:srgbClr val="FFFFFF"/>
         </a:solidFill>
         <a:effectLst/>
       </p:bgPr>
@@ -4726,7 +4736,7 @@
             <a:pPr>
               <a:defRPr sz="3000" b="1">
                 <a:solidFill>
-                  <a:srgbClr val="8A2BE2"/>
+                  <a:srgbClr val="141821"/>
                 </a:solidFill>
                 <a:latin typeface="Arial"/>
               </a:defRPr>
@@ -4752,11 +4762,11 @@
             <a:avLst/>
           </a:prstGeom>
           <a:solidFill>
-            <a:srgbClr val="181622"/>
+            <a:srgbClr val="F5F6F8"/>
           </a:solidFill>
           <a:ln w="12700">
             <a:solidFill>
-              <a:srgbClr val="3C325A"/>
+              <a:srgbClr val="C8CDD7"/>
             </a:solidFill>
           </a:ln>
         </p:spPr>
@@ -4781,7 +4791,7 @@
             <a:pPr algn="ctr">
               <a:defRPr sz="1500" b="1">
                 <a:solidFill>
-                  <a:srgbClr val="FFFFFF"/>
+                  <a:srgbClr val="141821"/>
                 </a:solidFill>
                 <a:latin typeface="Arial"/>
               </a:defRPr>
@@ -4797,7 +4807,7 @@
               </a:spcAft>
               <a:defRPr sz="900" b="1">
                 <a:solidFill>
-                  <a:srgbClr val="8A2BE2"/>
+                  <a:srgbClr val="0066CC"/>
                 </a:solidFill>
                 <a:latin typeface="Arial"/>
               </a:defRPr>
@@ -4813,7 +4823,7 @@
               </a:spcBef>
               <a:defRPr sz="1150">
                 <a:solidFill>
-                  <a:srgbClr val="C8C8DC"/>
+                  <a:srgbClr val="3C404B"/>
                 </a:solidFill>
                 <a:latin typeface="Arial"/>
               </a:defRPr>
@@ -4839,11 +4849,11 @@
             <a:avLst/>
           </a:prstGeom>
           <a:solidFill>
-            <a:srgbClr val="181622"/>
+            <a:srgbClr val="F5F6F8"/>
           </a:solidFill>
           <a:ln w="12700">
             <a:solidFill>
-              <a:srgbClr val="3C325A"/>
+              <a:srgbClr val="C8CDD7"/>
             </a:solidFill>
           </a:ln>
         </p:spPr>
@@ -4868,7 +4878,7 @@
             <a:pPr algn="ctr">
               <a:defRPr sz="1500" b="1">
                 <a:solidFill>
-                  <a:srgbClr val="FFFFFF"/>
+                  <a:srgbClr val="141821"/>
                 </a:solidFill>
                 <a:latin typeface="Arial"/>
               </a:defRPr>
@@ -4884,7 +4894,7 @@
               </a:spcAft>
               <a:defRPr sz="900" b="1">
                 <a:solidFill>
-                  <a:srgbClr val="8A2BE2"/>
+                  <a:srgbClr val="0066CC"/>
                 </a:solidFill>
                 <a:latin typeface="Arial"/>
               </a:defRPr>
@@ -4900,7 +4910,7 @@
               </a:spcBef>
               <a:defRPr sz="1150">
                 <a:solidFill>
-                  <a:srgbClr val="C8C8DC"/>
+                  <a:srgbClr val="3C404B"/>
                 </a:solidFill>
                 <a:latin typeface="Arial"/>
               </a:defRPr>
@@ -4926,11 +4936,11 @@
             <a:avLst/>
           </a:prstGeom>
           <a:solidFill>
-            <a:srgbClr val="181622"/>
+            <a:srgbClr val="F5F6F8"/>
           </a:solidFill>
           <a:ln w="12700">
             <a:solidFill>
-              <a:srgbClr val="3C325A"/>
+              <a:srgbClr val="C8CDD7"/>
             </a:solidFill>
           </a:ln>
         </p:spPr>
@@ -4955,7 +4965,7 @@
             <a:pPr algn="ctr">
               <a:defRPr sz="1500" b="1">
                 <a:solidFill>
-                  <a:srgbClr val="FFFFFF"/>
+                  <a:srgbClr val="141821"/>
                 </a:solidFill>
                 <a:latin typeface="Arial"/>
               </a:defRPr>
@@ -4971,7 +4981,7 @@
               </a:spcAft>
               <a:defRPr sz="900" b="1">
                 <a:solidFill>
-                  <a:srgbClr val="8A2BE2"/>
+                  <a:srgbClr val="0066CC"/>
                 </a:solidFill>
                 <a:latin typeface="Arial"/>
               </a:defRPr>
@@ -4987,7 +4997,7 @@
               </a:spcBef>
               <a:defRPr sz="1150">
                 <a:solidFill>
-                  <a:srgbClr val="C8C8DC"/>
+                  <a:srgbClr val="3C404B"/>
                 </a:solidFill>
                 <a:latin typeface="Arial"/>
               </a:defRPr>
@@ -5013,11 +5023,11 @@
             <a:avLst/>
           </a:prstGeom>
           <a:solidFill>
-            <a:srgbClr val="181622"/>
+            <a:srgbClr val="F5F6F8"/>
           </a:solidFill>
           <a:ln w="12700">
             <a:solidFill>
-              <a:srgbClr val="3C325A"/>
+              <a:srgbClr val="C8CDD7"/>
             </a:solidFill>
           </a:ln>
         </p:spPr>
@@ -5042,7 +5052,7 @@
             <a:pPr algn="ctr">
               <a:defRPr sz="1500" b="1">
                 <a:solidFill>
-                  <a:srgbClr val="FFFFFF"/>
+                  <a:srgbClr val="141821"/>
                 </a:solidFill>
                 <a:latin typeface="Arial"/>
               </a:defRPr>
@@ -5058,7 +5068,7 @@
               </a:spcAft>
               <a:defRPr sz="900" b="1">
                 <a:solidFill>
-                  <a:srgbClr val="8A2BE2"/>
+                  <a:srgbClr val="0066CC"/>
                 </a:solidFill>
                 <a:latin typeface="Arial"/>
               </a:defRPr>
@@ -5074,7 +5084,7 @@
               </a:spcBef>
               <a:defRPr sz="1150">
                 <a:solidFill>
-                  <a:srgbClr val="C8C8DC"/>
+                  <a:srgbClr val="3C404B"/>
                 </a:solidFill>
                 <a:latin typeface="Arial"/>
               </a:defRPr>
@@ -5096,6 +5106,14 @@
 <file path=ppt/slides/slide5.xml><?xml version="1.0" encoding="utf-8"?>
 <p:sld xmlns:a="http://schemas.openxmlformats.org/drawingml/2006/main" xmlns:p="http://schemas.openxmlformats.org/presentationml/2006/main" xmlns:r="http://schemas.openxmlformats.org/officeDocument/2006/relationships">
   <p:cSld>
+    <p:bg>
+      <p:bgPr>
+        <a:solidFill>
+          <a:srgbClr val="FFFFFF"/>
+        </a:solidFill>
+        <a:effectLst/>
+      </p:bgPr>
+    </p:bg>
     <p:spTree>
       <p:nvGrpSpPr>
         <p:cNvPr id="1" name=""/>
@@ -5119,8 +5137,8 @@
         </p:blipFill>
         <p:spPr>
           <a:xfrm>
-            <a:off x="0" y="0"/>
-            <a:ext cx="12191695" cy="6858000"/>
+            <a:off x="6217920" y="731520"/>
+            <a:ext cx="5212080" cy="5303520"/>
           </a:xfrm>
           <a:prstGeom prst="rect">
             <a:avLst/>
@@ -5152,7 +5170,7 @@
             <a:pPr>
               <a:defRPr sz="3000" b="1">
                 <a:solidFill>
-                  <a:srgbClr val="FFFFFF"/>
+                  <a:srgbClr val="141821"/>
                 </a:solidFill>
                 <a:latin typeface="Arial"/>
               </a:defRPr>
@@ -5194,7 +5212,7 @@
                       <a:pPr algn="ctr">
                         <a:defRPr sz="1300" b="1">
                           <a:solidFill>
-                            <a:srgbClr val="8A2BE2"/>
+                            <a:srgbClr val="0066CC"/>
                           </a:solidFill>
                           <a:latin typeface="Arial"/>
                         </a:defRPr>
@@ -5206,7 +5224,7 @@
                   </a:txBody>
                   <a:tcPr>
                     <a:solidFill>
-                      <a:srgbClr val="181622"/>
+                      <a:srgbClr val="F5F6F8"/>
                     </a:solidFill>
                   </a:tcPr>
                 </a:tc>
@@ -5218,7 +5236,7 @@
                       <a:pPr algn="ctr">
                         <a:defRPr sz="1300" b="1">
                           <a:solidFill>
-                            <a:srgbClr val="8A2BE2"/>
+                            <a:srgbClr val="0066CC"/>
                           </a:solidFill>
                           <a:latin typeface="Arial"/>
                         </a:defRPr>
@@ -5230,7 +5248,7 @@
                   </a:txBody>
                   <a:tcPr>
                     <a:solidFill>
-                      <a:srgbClr val="181622"/>
+                      <a:srgbClr val="F5F6F8"/>
                     </a:solidFill>
                   </a:tcPr>
                 </a:tc>
@@ -5244,7 +5262,7 @@
                       <a:pPr algn="ctr">
                         <a:defRPr sz="1100">
                           <a:solidFill>
-                            <a:srgbClr val="C8C8DC"/>
+                            <a:srgbClr val="3C404B"/>
                           </a:solidFill>
                           <a:latin typeface="Arial"/>
                         </a:defRPr>
@@ -5256,7 +5274,7 @@
                   </a:txBody>
                   <a:tcPr>
                     <a:solidFill>
-                      <a:srgbClr val="0A0A10"/>
+                      <a:srgbClr val="FFFFFF"/>
                     </a:solidFill>
                   </a:tcPr>
                 </a:tc>
@@ -5268,7 +5286,7 @@
                       <a:pPr algn="ctr">
                         <a:defRPr sz="1100" b="1">
                           <a:solidFill>
-                            <a:srgbClr val="FFFFFF"/>
+                            <a:srgbClr val="141821"/>
                           </a:solidFill>
                           <a:latin typeface="Arial"/>
                         </a:defRPr>
@@ -5280,7 +5298,7 @@
                   </a:txBody>
                   <a:tcPr>
                     <a:solidFill>
-                      <a:srgbClr val="0A0A10"/>
+                      <a:srgbClr val="FFFFFF"/>
                     </a:solidFill>
                   </a:tcPr>
                 </a:tc>
@@ -5294,7 +5312,7 @@
                       <a:pPr algn="ctr">
                         <a:defRPr sz="1100">
                           <a:solidFill>
-                            <a:srgbClr val="C8C8DC"/>
+                            <a:srgbClr val="3C404B"/>
                           </a:solidFill>
                           <a:latin typeface="Arial"/>
                         </a:defRPr>
@@ -5306,7 +5324,7 @@
                   </a:txBody>
                   <a:tcPr>
                     <a:solidFill>
-                      <a:srgbClr val="0A0A10"/>
+                      <a:srgbClr val="FFFFFF"/>
                     </a:solidFill>
                   </a:tcPr>
                 </a:tc>
@@ -5318,7 +5336,7 @@
                       <a:pPr algn="ctr">
                         <a:defRPr sz="1100" b="1">
                           <a:solidFill>
-                            <a:srgbClr val="FFFFFF"/>
+                            <a:srgbClr val="141821"/>
                           </a:solidFill>
                           <a:latin typeface="Arial"/>
                         </a:defRPr>
@@ -5330,7 +5348,7 @@
                   </a:txBody>
                   <a:tcPr>
                     <a:solidFill>
-                      <a:srgbClr val="0A0A10"/>
+                      <a:srgbClr val="FFFFFF"/>
                     </a:solidFill>
                   </a:tcPr>
                 </a:tc>
@@ -5344,7 +5362,7 @@
                       <a:pPr algn="ctr">
                         <a:defRPr sz="1100">
                           <a:solidFill>
-                            <a:srgbClr val="C8C8DC"/>
+                            <a:srgbClr val="3C404B"/>
                           </a:solidFill>
                           <a:latin typeface="Arial"/>
                         </a:defRPr>
@@ -5356,7 +5374,7 @@
                   </a:txBody>
                   <a:tcPr>
                     <a:solidFill>
-                      <a:srgbClr val="0A0A10"/>
+                      <a:srgbClr val="FFFFFF"/>
                     </a:solidFill>
                   </a:tcPr>
                 </a:tc>
@@ -5368,7 +5386,7 @@
                       <a:pPr algn="ctr">
                         <a:defRPr sz="1100" b="1">
                           <a:solidFill>
-                            <a:srgbClr val="FFFFFF"/>
+                            <a:srgbClr val="141821"/>
                           </a:solidFill>
                           <a:latin typeface="Arial"/>
                         </a:defRPr>
@@ -5380,7 +5398,7 @@
                   </a:txBody>
                   <a:tcPr>
                     <a:solidFill>
-                      <a:srgbClr val="0A0A10"/>
+                      <a:srgbClr val="FFFFFF"/>
                     </a:solidFill>
                   </a:tcPr>
                 </a:tc>
@@ -5394,7 +5412,7 @@
                       <a:pPr algn="ctr">
                         <a:defRPr sz="1100">
                           <a:solidFill>
-                            <a:srgbClr val="C8C8DC"/>
+                            <a:srgbClr val="3C404B"/>
                           </a:solidFill>
                           <a:latin typeface="Arial"/>
                         </a:defRPr>
@@ -5406,7 +5424,7 @@
                   </a:txBody>
                   <a:tcPr>
                     <a:solidFill>
-                      <a:srgbClr val="0A0A10"/>
+                      <a:srgbClr val="FFFFFF"/>
                     </a:solidFill>
                   </a:tcPr>
                 </a:tc>
@@ -5418,7 +5436,7 @@
                       <a:pPr algn="ctr">
                         <a:defRPr sz="1100" b="1">
                           <a:solidFill>
-                            <a:srgbClr val="FFFFFF"/>
+                            <a:srgbClr val="141821"/>
                           </a:solidFill>
                           <a:latin typeface="Arial"/>
                         </a:defRPr>
@@ -5430,7 +5448,7 @@
                   </a:txBody>
                   <a:tcPr>
                     <a:solidFill>
-                      <a:srgbClr val="0A0A10"/>
+                      <a:srgbClr val="FFFFFF"/>
                     </a:solidFill>
                   </a:tcPr>
                 </a:tc>
@@ -5467,7 +5485,7 @@
               </a:spcAft>
               <a:defRPr sz="1500" b="1">
                 <a:solidFill>
-                  <a:srgbClr val="8A2BE2"/>
+                  <a:srgbClr val="0066CC"/>
                 </a:solidFill>
                 <a:latin typeface="Arial"/>
               </a:defRPr>
@@ -5483,7 +5501,7 @@
               </a:spcAft>
               <a:defRPr sz="1050">
                 <a:solidFill>
-                  <a:srgbClr val="C8C8DC"/>
+                  <a:srgbClr val="3C404B"/>
                 </a:solidFill>
                 <a:latin typeface="Arial"/>
               </a:defRPr>
@@ -5499,7 +5517,7 @@
               </a:spcAft>
               <a:defRPr sz="1050">
                 <a:solidFill>
-                  <a:srgbClr val="C8C8DC"/>
+                  <a:srgbClr val="3C404B"/>
                 </a:solidFill>
                 <a:latin typeface="Arial"/>
               </a:defRPr>
@@ -5515,7 +5533,7 @@
               </a:spcAft>
               <a:defRPr sz="1050">
                 <a:solidFill>
-                  <a:srgbClr val="C8C8DC"/>
+                  <a:srgbClr val="3C404B"/>
                 </a:solidFill>
                 <a:latin typeface="Arial"/>
               </a:defRPr>
@@ -5531,7 +5549,7 @@
               </a:spcAft>
               <a:defRPr sz="1050">
                 <a:solidFill>
-                  <a:srgbClr val="C8C8DC"/>
+                  <a:srgbClr val="3C404B"/>
                 </a:solidFill>
                 <a:latin typeface="Arial"/>
               </a:defRPr>
@@ -5553,6 +5571,14 @@
 <file path=ppt/slides/slide6.xml><?xml version="1.0" encoding="utf-8"?>
 <p:sld xmlns:a="http://schemas.openxmlformats.org/drawingml/2006/main" xmlns:p="http://schemas.openxmlformats.org/presentationml/2006/main" xmlns:r="http://schemas.openxmlformats.org/officeDocument/2006/relationships">
   <p:cSld>
+    <p:bg>
+      <p:bgPr>
+        <a:solidFill>
+          <a:srgbClr val="FFFFFF"/>
+        </a:solidFill>
+        <a:effectLst/>
+      </p:bgPr>
+    </p:bg>
     <p:spTree>
       <p:nvGrpSpPr>
         <p:cNvPr id="1" name=""/>
@@ -5576,8 +5602,8 @@
         </p:blipFill>
         <p:spPr>
           <a:xfrm>
-            <a:off x="0" y="0"/>
-            <a:ext cx="12191695" cy="6858000"/>
+            <a:off x="6217920" y="731520"/>
+            <a:ext cx="5212080" cy="5303520"/>
           </a:xfrm>
           <a:prstGeom prst="rect">
             <a:avLst/>
@@ -5609,7 +5635,7 @@
             <a:pPr>
               <a:defRPr sz="3000" b="1">
                 <a:solidFill>
-                  <a:srgbClr val="FFFFFF"/>
+                  <a:srgbClr val="141821"/>
                 </a:solidFill>
                 <a:latin typeface="Arial"/>
               </a:defRPr>
@@ -5648,7 +5674,7 @@
               </a:spcBef>
               <a:defRPr sz="1400" b="1">
                 <a:solidFill>
-                  <a:srgbClr val="8A2BE2"/>
+                  <a:srgbClr val="0066CC"/>
                 </a:solidFill>
                 <a:latin typeface="Arial"/>
               </a:defRPr>
@@ -5664,7 +5690,7 @@
               </a:spcAft>
               <a:defRPr sz="1100">
                 <a:solidFill>
-                  <a:srgbClr val="C8C8DC"/>
+                  <a:srgbClr val="3C404B"/>
                 </a:solidFill>
                 <a:latin typeface="Arial"/>
               </a:defRPr>
@@ -5688,7 +5714,7 @@
               </a:spcBef>
               <a:defRPr sz="1400" b="1">
                 <a:solidFill>
-                  <a:srgbClr val="8A2BE2"/>
+                  <a:srgbClr val="0066CC"/>
                 </a:solidFill>
                 <a:latin typeface="Arial"/>
               </a:defRPr>
@@ -5704,7 +5730,7 @@
               </a:spcAft>
               <a:defRPr sz="1100">
                 <a:solidFill>
-                  <a:srgbClr val="C8C8DC"/>
+                  <a:srgbClr val="3C404B"/>
                 </a:solidFill>
                 <a:latin typeface="Arial"/>
               </a:defRPr>
@@ -5724,7 +5750,7 @@
               </a:spcBef>
               <a:defRPr sz="1400" b="1">
                 <a:solidFill>
-                  <a:srgbClr val="8A2BE2"/>
+                  <a:srgbClr val="0066CC"/>
                 </a:solidFill>
                 <a:latin typeface="Arial"/>
               </a:defRPr>
@@ -5740,7 +5766,7 @@
               </a:spcAft>
               <a:defRPr sz="1100">
                 <a:solidFill>
-                  <a:srgbClr val="C8C8DC"/>
+                  <a:srgbClr val="3C404B"/>
                 </a:solidFill>
                 <a:latin typeface="Arial"/>
               </a:defRPr>
@@ -5765,7 +5791,7 @@
     <p:bg>
       <p:bgPr>
         <a:solidFill>
-          <a:srgbClr val="0A0A10"/>
+          <a:srgbClr val="FFFFFF"/>
         </a:solidFill>
         <a:effectLst/>
       </p:bgPr>
@@ -5802,7 +5828,7 @@
             <a:pPr>
               <a:defRPr sz="3000" b="1">
                 <a:solidFill>
-                  <a:srgbClr val="8A2BE2"/>
+                  <a:srgbClr val="141821"/>
                 </a:solidFill>
                 <a:latin typeface="Arial"/>
               </a:defRPr>
@@ -5828,11 +5854,11 @@
             <a:avLst/>
           </a:prstGeom>
           <a:solidFill>
-            <a:srgbClr val="181622"/>
+            <a:srgbClr val="F5F6F8"/>
           </a:solidFill>
           <a:ln w="12700">
             <a:solidFill>
-              <a:srgbClr val="3C325A"/>
+              <a:srgbClr val="C8CDD7"/>
             </a:solidFill>
           </a:ln>
         </p:spPr>
@@ -5860,7 +5886,7 @@
               </a:spcAft>
               <a:defRPr sz="1800" b="1">
                 <a:solidFill>
-                  <a:srgbClr val="FFFFFF"/>
+                  <a:srgbClr val="141821"/>
                 </a:solidFill>
                 <a:latin typeface="Arial"/>
               </a:defRPr>
@@ -5876,7 +5902,7 @@
               </a:spcAft>
               <a:defRPr sz="1300">
                 <a:solidFill>
-                  <a:srgbClr val="C8C8DC"/>
+                  <a:srgbClr val="3C404B"/>
                 </a:solidFill>
                 <a:latin typeface="Arial"/>
               </a:defRPr>
@@ -5892,7 +5918,7 @@
               </a:spcAft>
               <a:defRPr sz="1300">
                 <a:solidFill>
-                  <a:srgbClr val="C8C8DC"/>
+                  <a:srgbClr val="3C404B"/>
                 </a:solidFill>
                 <a:latin typeface="Arial"/>
               </a:defRPr>
@@ -5908,7 +5934,7 @@
               </a:spcAft>
               <a:defRPr sz="1300">
                 <a:solidFill>
-                  <a:srgbClr val="C8C8DC"/>
+                  <a:srgbClr val="3C404B"/>
                 </a:solidFill>
                 <a:latin typeface="Arial"/>
               </a:defRPr>
@@ -5934,11 +5960,11 @@
             <a:avLst/>
           </a:prstGeom>
           <a:solidFill>
-            <a:srgbClr val="181622"/>
+            <a:srgbClr val="F5F6F8"/>
           </a:solidFill>
           <a:ln w="12700">
             <a:solidFill>
-              <a:srgbClr val="3C325A"/>
+              <a:srgbClr val="C8CDD7"/>
             </a:solidFill>
           </a:ln>
         </p:spPr>
@@ -5966,7 +5992,7 @@
               </a:spcAft>
               <a:defRPr sz="1800" b="1">
                 <a:solidFill>
-                  <a:srgbClr val="8A2BE2"/>
+                  <a:srgbClr val="0066CC"/>
                 </a:solidFill>
                 <a:latin typeface="Arial"/>
               </a:defRPr>
@@ -5982,7 +6008,7 @@
               </a:spcBef>
               <a:defRPr sz="1200">
                 <a:solidFill>
-                  <a:srgbClr val="C8C8DC"/>
+                  <a:srgbClr val="3C404B"/>
                 </a:solidFill>
                 <a:latin typeface="Arial"/>
               </a:defRPr>

</xml_diff>

<commit_message>
Revert "docs: Change presentation theme to minimal office white, adding bounded pictures on the right side"
This reverts commit 8804d2d124e5f92f57e4803d180f0205777603bb.
</commit_message>
<xml_diff>
--- a/reports/cdac_project_review.pptx
+++ b/reports/cdac_project_review.pptx
@@ -3087,14 +3087,6 @@
 <file path=ppt/slides/slide1.xml><?xml version="1.0" encoding="utf-8"?>
 <p:sld xmlns:a="http://schemas.openxmlformats.org/drawingml/2006/main" xmlns:p="http://schemas.openxmlformats.org/presentationml/2006/main" xmlns:r="http://schemas.openxmlformats.org/officeDocument/2006/relationships">
   <p:cSld>
-    <p:bg>
-      <p:bgPr>
-        <a:solidFill>
-          <a:srgbClr val="FFFFFF"/>
-        </a:solidFill>
-        <a:effectLst/>
-      </p:bgPr>
-    </p:bg>
     <p:spTree>
       <p:nvGrpSpPr>
         <p:cNvPr id="1" name=""/>
@@ -3118,8 +3110,8 @@
         </p:blipFill>
         <p:spPr>
           <a:xfrm>
-            <a:off x="6217920" y="731520"/>
-            <a:ext cx="5212080" cy="5303520"/>
+            <a:off x="0" y="0"/>
+            <a:ext cx="12191695" cy="6858000"/>
           </a:xfrm>
           <a:prstGeom prst="rect">
             <a:avLst/>
@@ -3151,7 +3143,7 @@
             <a:pPr>
               <a:defRPr sz="4200" b="1">
                 <a:solidFill>
-                  <a:srgbClr val="141821"/>
+                  <a:srgbClr val="FFFFFF"/>
                 </a:solidFill>
                 <a:latin typeface="Arial"/>
               </a:defRPr>
@@ -3167,7 +3159,7 @@
               </a:spcBef>
               <a:defRPr sz="1500" b="1">
                 <a:solidFill>
-                  <a:srgbClr val="0066CC"/>
+                  <a:srgbClr val="8A2BE2"/>
                 </a:solidFill>
                 <a:latin typeface="Arial"/>
               </a:defRPr>
@@ -3203,7 +3195,7 @@
             <a:pPr>
               <a:defRPr sz="1150" b="1">
                 <a:solidFill>
-                  <a:srgbClr val="3C404B"/>
+                  <a:srgbClr val="C8C8DC"/>
                 </a:solidFill>
                 <a:latin typeface="Arial"/>
               </a:defRPr>
@@ -3219,7 +3211,7 @@
               </a:spcBef>
               <a:defRPr sz="1150" b="1">
                 <a:solidFill>
-                  <a:srgbClr val="3C404B"/>
+                  <a:srgbClr val="C8C8DC"/>
                 </a:solidFill>
                 <a:latin typeface="Arial"/>
               </a:defRPr>
@@ -3235,7 +3227,7 @@
               </a:spcBef>
               <a:defRPr sz="1150">
                 <a:solidFill>
-                  <a:srgbClr val="6E737D"/>
+                  <a:srgbClr val="827896"/>
                 </a:solidFill>
                 <a:latin typeface="Arial"/>
               </a:defRPr>
@@ -3261,11 +3253,11 @@
             <a:avLst/>
           </a:prstGeom>
           <a:solidFill>
-            <a:srgbClr val="F5F6F8"/>
+            <a:srgbClr val="181622"/>
           </a:solidFill>
           <a:ln w="12700">
             <a:solidFill>
-              <a:srgbClr val="C8CDD7"/>
+              <a:srgbClr val="3C325A"/>
             </a:solidFill>
           </a:ln>
         </p:spPr>
@@ -3290,7 +3282,7 @@
             <a:pPr algn="ctr">
               <a:defRPr sz="1500" b="1">
                 <a:solidFill>
-                  <a:srgbClr val="0066CC"/>
+                  <a:srgbClr val="8A2BE2"/>
                 </a:solidFill>
                 <a:latin typeface="Arial"/>
               </a:defRPr>
@@ -3306,7 +3298,7 @@
               </a:spcBef>
               <a:defRPr sz="1100">
                 <a:solidFill>
-                  <a:srgbClr val="3C404B"/>
+                  <a:srgbClr val="C8C8DC"/>
                 </a:solidFill>
                 <a:latin typeface="Arial"/>
               </a:defRPr>
@@ -3343,7 +3335,7 @@
     <p:bg>
       <p:bgPr>
         <a:solidFill>
-          <a:srgbClr val="FFFFFF"/>
+          <a:srgbClr val="0A0A10"/>
         </a:solidFill>
         <a:effectLst/>
       </p:bgPr>
@@ -3380,7 +3372,7 @@
             <a:pPr>
               <a:defRPr sz="3000" b="1">
                 <a:solidFill>
-                  <a:srgbClr val="141821"/>
+                  <a:srgbClr val="8A2BE2"/>
                 </a:solidFill>
                 <a:latin typeface="Arial"/>
               </a:defRPr>
@@ -3419,7 +3411,7 @@
               </a:spcAft>
               <a:defRPr sz="1800" b="1">
                 <a:solidFill>
-                  <a:srgbClr val="0066CC"/>
+                  <a:srgbClr val="8A2BE2"/>
                 </a:solidFill>
                 <a:latin typeface="Arial"/>
               </a:defRPr>
@@ -3435,7 +3427,7 @@
               </a:spcAft>
               <a:defRPr sz="1300">
                 <a:solidFill>
-                  <a:srgbClr val="3C404B"/>
+                  <a:srgbClr val="C8C8DC"/>
                 </a:solidFill>
                 <a:latin typeface="Arial"/>
               </a:defRPr>
@@ -3451,7 +3443,7 @@
               </a:spcAft>
               <a:defRPr sz="1300">
                 <a:solidFill>
-                  <a:srgbClr val="3C404B"/>
+                  <a:srgbClr val="C8C8DC"/>
                 </a:solidFill>
                 <a:latin typeface="Arial"/>
               </a:defRPr>
@@ -3467,7 +3459,7 @@
               </a:spcAft>
               <a:defRPr sz="1300">
                 <a:solidFill>
-                  <a:srgbClr val="3C404B"/>
+                  <a:srgbClr val="C8C8DC"/>
                 </a:solidFill>
                 <a:latin typeface="Arial"/>
               </a:defRPr>
@@ -3483,7 +3475,7 @@
               </a:spcAft>
               <a:defRPr sz="1300">
                 <a:solidFill>
-                  <a:srgbClr val="3C404B"/>
+                  <a:srgbClr val="C8C8DC"/>
                 </a:solidFill>
                 <a:latin typeface="Arial"/>
               </a:defRPr>
@@ -3522,7 +3514,7 @@
               </a:spcAft>
               <a:defRPr sz="1800" b="1">
                 <a:solidFill>
-                  <a:srgbClr val="141821"/>
+                  <a:srgbClr val="FFFFFF"/>
                 </a:solidFill>
                 <a:latin typeface="Arial"/>
               </a:defRPr>
@@ -3538,7 +3530,7 @@
               </a:spcBef>
               <a:defRPr sz="1400" b="1">
                 <a:solidFill>
-                  <a:srgbClr val="0066CC"/>
+                  <a:srgbClr val="8A2BE2"/>
                 </a:solidFill>
                 <a:latin typeface="Arial"/>
               </a:defRPr>
@@ -3554,7 +3546,7 @@
               </a:spcAft>
               <a:defRPr sz="1200">
                 <a:solidFill>
-                  <a:srgbClr val="3C404B"/>
+                  <a:srgbClr val="C8C8DC"/>
                 </a:solidFill>
                 <a:latin typeface="Arial"/>
               </a:defRPr>
@@ -3570,7 +3562,7 @@
               </a:spcBef>
               <a:defRPr sz="1400" b="1">
                 <a:solidFill>
-                  <a:srgbClr val="0066CC"/>
+                  <a:srgbClr val="8A2BE2"/>
                 </a:solidFill>
                 <a:latin typeface="Arial"/>
               </a:defRPr>
@@ -3586,7 +3578,7 @@
               </a:spcAft>
               <a:defRPr sz="1200">
                 <a:solidFill>
-                  <a:srgbClr val="3C404B"/>
+                  <a:srgbClr val="C8C8DC"/>
                 </a:solidFill>
                 <a:latin typeface="Arial"/>
               </a:defRPr>
@@ -3602,7 +3594,7 @@
               </a:spcBef>
               <a:defRPr sz="1400" b="1">
                 <a:solidFill>
-                  <a:srgbClr val="0066CC"/>
+                  <a:srgbClr val="8A2BE2"/>
                 </a:solidFill>
                 <a:latin typeface="Arial"/>
               </a:defRPr>
@@ -3618,7 +3610,7 @@
               </a:spcAft>
               <a:defRPr sz="1200">
                 <a:solidFill>
-                  <a:srgbClr val="3C404B"/>
+                  <a:srgbClr val="C8C8DC"/>
                 </a:solidFill>
                 <a:latin typeface="Arial"/>
               </a:defRPr>
@@ -3643,7 +3635,7 @@
     <p:bg>
       <p:bgPr>
         <a:solidFill>
-          <a:srgbClr val="FFFFFF"/>
+          <a:srgbClr val="0A0A10"/>
         </a:solidFill>
         <a:effectLst/>
       </p:bgPr>
@@ -3680,7 +3672,7 @@
             <a:pPr>
               <a:defRPr sz="3000" b="1">
                 <a:solidFill>
-                  <a:srgbClr val="141821"/>
+                  <a:srgbClr val="8A2BE2"/>
                 </a:solidFill>
                 <a:latin typeface="Arial"/>
               </a:defRPr>
@@ -3719,7 +3711,7 @@
               </a:spcAft>
               <a:defRPr sz="1800" b="1">
                 <a:solidFill>
-                  <a:srgbClr val="0066CC"/>
+                  <a:srgbClr val="8A2BE2"/>
                 </a:solidFill>
                 <a:latin typeface="Arial"/>
               </a:defRPr>
@@ -3735,7 +3727,7 @@
               </a:spcAft>
               <a:defRPr sz="1200">
                 <a:solidFill>
-                  <a:srgbClr val="3C404B"/>
+                  <a:srgbClr val="C8C8DC"/>
                 </a:solidFill>
                 <a:latin typeface="Arial"/>
               </a:defRPr>
@@ -3751,7 +3743,7 @@
               </a:spcAft>
               <a:defRPr sz="1200">
                 <a:solidFill>
-                  <a:srgbClr val="3C404B"/>
+                  <a:srgbClr val="C8C8DC"/>
                 </a:solidFill>
                 <a:latin typeface="Arial"/>
               </a:defRPr>
@@ -3767,7 +3759,7 @@
               </a:spcAft>
               <a:defRPr sz="1200">
                 <a:solidFill>
-                  <a:srgbClr val="3C404B"/>
+                  <a:srgbClr val="C8C8DC"/>
                 </a:solidFill>
                 <a:latin typeface="Arial"/>
               </a:defRPr>
@@ -3783,7 +3775,7 @@
               </a:spcAft>
               <a:defRPr sz="1200">
                 <a:solidFill>
-                  <a:srgbClr val="3C404B"/>
+                  <a:srgbClr val="C8C8DC"/>
                 </a:solidFill>
                 <a:latin typeface="Arial"/>
               </a:defRPr>
@@ -3809,11 +3801,11 @@
             <a:avLst/>
           </a:prstGeom>
           <a:solidFill>
-            <a:srgbClr val="FCE4EC"/>
+            <a:srgbClr val="F8BBD0"/>
           </a:solidFill>
           <a:ln w="12700">
             <a:solidFill>
-              <a:srgbClr val="C8CDD7"/>
+              <a:srgbClr val="3C325A"/>
             </a:solidFill>
           </a:ln>
         </p:spPr>
@@ -3838,7 +3830,7 @@
             <a:pPr algn="ctr">
               <a:defRPr sz="950" b="1">
                 <a:solidFill>
-                  <a:srgbClr val="3C3C3C"/>
+                  <a:srgbClr val="282828"/>
                 </a:solidFill>
                 <a:latin typeface="Arial"/>
               </a:defRPr>
@@ -3865,7 +3857,7 @@
           </a:prstGeom>
           <a:ln w="15240">
             <a:solidFill>
-              <a:srgbClr val="A0A5AF"/>
+              <a:srgbClr val="3C325A"/>
             </a:solidFill>
           </a:ln>
         </p:spPr>
@@ -3899,11 +3891,11 @@
             <a:avLst/>
           </a:prstGeom>
           <a:solidFill>
-            <a:srgbClr val="FFF3E0"/>
+            <a:srgbClr val="FFE0B2"/>
           </a:solidFill>
           <a:ln w="12700">
             <a:solidFill>
-              <a:srgbClr val="C8CDD7"/>
+              <a:srgbClr val="3C325A"/>
             </a:solidFill>
           </a:ln>
         </p:spPr>
@@ -3928,7 +3920,7 @@
             <a:pPr algn="ctr">
               <a:defRPr sz="950" b="1">
                 <a:solidFill>
-                  <a:srgbClr val="3C3C3C"/>
+                  <a:srgbClr val="282828"/>
                 </a:solidFill>
                 <a:latin typeface="Arial"/>
               </a:defRPr>
@@ -3955,7 +3947,7 @@
           </a:prstGeom>
           <a:ln w="15240">
             <a:solidFill>
-              <a:srgbClr val="A0A5AF"/>
+              <a:srgbClr val="3C325A"/>
             </a:solidFill>
           </a:ln>
         </p:spPr>
@@ -3989,11 +3981,11 @@
             <a:avLst/>
           </a:prstGeom>
           <a:solidFill>
-            <a:srgbClr val="FFFDE7"/>
+            <a:srgbClr val="FFF9C4"/>
           </a:solidFill>
           <a:ln w="12700">
             <a:solidFill>
-              <a:srgbClr val="C8CDD7"/>
+              <a:srgbClr val="3C325A"/>
             </a:solidFill>
           </a:ln>
         </p:spPr>
@@ -4018,7 +4010,7 @@
             <a:pPr algn="ctr">
               <a:defRPr sz="950" b="1">
                 <a:solidFill>
-                  <a:srgbClr val="3C3C3C"/>
+                  <a:srgbClr val="282828"/>
                 </a:solidFill>
                 <a:latin typeface="Arial"/>
               </a:defRPr>
@@ -4043,12 +4035,10 @@
           <a:prstGeom prst="roundRect">
             <a:avLst/>
           </a:prstGeom>
-          <a:solidFill>
-            <a:srgbClr val="F5F6F8"/>
-          </a:solidFill>
+          <a:noFill/>
           <a:ln w="19050">
             <a:solidFill>
-              <a:srgbClr val="C8CDD7"/>
+              <a:srgbClr val="3C325A"/>
             </a:solidFill>
           </a:ln>
         </p:spPr>
@@ -4099,7 +4089,7 @@
             <a:pPr>
               <a:defRPr sz="1400" b="1">
                 <a:solidFill>
-                  <a:srgbClr val="0066CC"/>
+                  <a:srgbClr val="8A2BE2"/>
                 </a:solidFill>
                 <a:latin typeface="Arial"/>
               </a:defRPr>
@@ -4129,7 +4119,7 @@
           </a:solidFill>
           <a:ln w="12700">
             <a:solidFill>
-              <a:srgbClr val="C8CDD7"/>
+              <a:srgbClr val="3C325A"/>
             </a:solidFill>
           </a:ln>
         </p:spPr>
@@ -4154,7 +4144,7 @@
             <a:pPr algn="ctr">
               <a:defRPr sz="950" b="1">
                 <a:solidFill>
-                  <a:srgbClr val="3C3C3C"/>
+                  <a:srgbClr val="282828"/>
                 </a:solidFill>
                 <a:latin typeface="Arial"/>
               </a:defRPr>
@@ -4184,7 +4174,7 @@
           </a:solidFill>
           <a:ln w="12700">
             <a:solidFill>
-              <a:srgbClr val="C8CDD7"/>
+              <a:srgbClr val="3C325A"/>
             </a:solidFill>
           </a:ln>
         </p:spPr>
@@ -4209,7 +4199,7 @@
             <a:pPr algn="ctr">
               <a:defRPr sz="950" b="1">
                 <a:solidFill>
-                  <a:srgbClr val="3C3C3C"/>
+                  <a:srgbClr val="282828"/>
                 </a:solidFill>
                 <a:latin typeface="Arial"/>
               </a:defRPr>
@@ -4239,7 +4229,7 @@
           </a:solidFill>
           <a:ln w="12700">
             <a:solidFill>
-              <a:srgbClr val="C8CDD7"/>
+              <a:srgbClr val="3C325A"/>
             </a:solidFill>
           </a:ln>
         </p:spPr>
@@ -4264,7 +4254,7 @@
             <a:pPr algn="ctr">
               <a:defRPr sz="950" b="1">
                 <a:solidFill>
-                  <a:srgbClr val="3C3C3C"/>
+                  <a:srgbClr val="282828"/>
                 </a:solidFill>
                 <a:latin typeface="Arial"/>
               </a:defRPr>
@@ -4291,7 +4281,7 @@
           </a:prstGeom>
           <a:ln w="15240">
             <a:solidFill>
-              <a:srgbClr val="A0A5AF"/>
+              <a:srgbClr val="3C325A"/>
             </a:solidFill>
           </a:ln>
         </p:spPr>
@@ -4326,7 +4316,7 @@
           </a:prstGeom>
           <a:ln w="15240">
             <a:solidFill>
-              <a:srgbClr val="A0A5AF"/>
+              <a:srgbClr val="3C325A"/>
             </a:solidFill>
           </a:ln>
         </p:spPr>
@@ -4361,7 +4351,7 @@
           </a:prstGeom>
           <a:ln w="15240">
             <a:solidFill>
-              <a:srgbClr val="A0A5AF"/>
+              <a:srgbClr val="3C325A"/>
             </a:solidFill>
           </a:ln>
         </p:spPr>
@@ -4395,11 +4385,11 @@
             <a:avLst/>
           </a:prstGeom>
           <a:solidFill>
-            <a:srgbClr val="FFFDE7"/>
+            <a:srgbClr val="FFF9C4"/>
           </a:solidFill>
           <a:ln w="12700">
             <a:solidFill>
-              <a:srgbClr val="C8CDD7"/>
+              <a:srgbClr val="3C325A"/>
             </a:solidFill>
           </a:ln>
         </p:spPr>
@@ -4424,7 +4414,7 @@
             <a:pPr algn="ctr">
               <a:defRPr sz="950" b="1">
                 <a:solidFill>
-                  <a:srgbClr val="3C3C3C"/>
+                  <a:srgbClr val="282828"/>
                 </a:solidFill>
                 <a:latin typeface="Arial"/>
               </a:defRPr>
@@ -4451,7 +4441,7 @@
           </a:prstGeom>
           <a:ln w="15240">
             <a:solidFill>
-              <a:srgbClr val="A0A5AF"/>
+              <a:srgbClr val="3C325A"/>
             </a:solidFill>
           </a:ln>
         </p:spPr>
@@ -4486,7 +4476,7 @@
           </a:prstGeom>
           <a:ln w="15240">
             <a:solidFill>
-              <a:srgbClr val="A0A5AF"/>
+              <a:srgbClr val="3C325A"/>
             </a:solidFill>
           </a:ln>
         </p:spPr>
@@ -4521,7 +4511,7 @@
           </a:prstGeom>
           <a:ln w="15240">
             <a:solidFill>
-              <a:srgbClr val="A0A5AF"/>
+              <a:srgbClr val="3C325A"/>
             </a:solidFill>
           </a:ln>
         </p:spPr>
@@ -4555,11 +4545,11 @@
             <a:avLst/>
           </a:prstGeom>
           <a:solidFill>
-            <a:srgbClr val="F3E5F5"/>
+            <a:srgbClr val="E1BEE7"/>
           </a:solidFill>
           <a:ln w="12700">
             <a:solidFill>
-              <a:srgbClr val="C8CDD7"/>
+              <a:srgbClr val="3C325A"/>
             </a:solidFill>
           </a:ln>
         </p:spPr>
@@ -4584,7 +4574,7 @@
             <a:pPr algn="ctr">
               <a:defRPr sz="950" b="1">
                 <a:solidFill>
-                  <a:srgbClr val="3C3C3C"/>
+                  <a:srgbClr val="282828"/>
                 </a:solidFill>
                 <a:latin typeface="Arial"/>
               </a:defRPr>
@@ -4611,7 +4601,7 @@
           </a:prstGeom>
           <a:ln w="15240">
             <a:solidFill>
-              <a:srgbClr val="A0A5AF"/>
+              <a:srgbClr val="3C325A"/>
             </a:solidFill>
           </a:ln>
         </p:spPr>
@@ -4645,11 +4635,11 @@
             <a:avLst/>
           </a:prstGeom>
           <a:solidFill>
-            <a:srgbClr val="E8F5E9"/>
+            <a:srgbClr val="C8E6C9"/>
           </a:solidFill>
           <a:ln w="12700">
             <a:solidFill>
-              <a:srgbClr val="C8CDD7"/>
+              <a:srgbClr val="3C325A"/>
             </a:solidFill>
           </a:ln>
         </p:spPr>
@@ -4674,7 +4664,7 @@
             <a:pPr algn="ctr">
               <a:defRPr sz="950" b="1">
                 <a:solidFill>
-                  <a:srgbClr val="3C3C3C"/>
+                  <a:srgbClr val="282828"/>
                 </a:solidFill>
                 <a:latin typeface="Arial"/>
               </a:defRPr>
@@ -4699,7 +4689,7 @@
     <p:bg>
       <p:bgPr>
         <a:solidFill>
-          <a:srgbClr val="FFFFFF"/>
+          <a:srgbClr val="0A0A10"/>
         </a:solidFill>
         <a:effectLst/>
       </p:bgPr>
@@ -4736,7 +4726,7 @@
             <a:pPr>
               <a:defRPr sz="3000" b="1">
                 <a:solidFill>
-                  <a:srgbClr val="141821"/>
+                  <a:srgbClr val="8A2BE2"/>
                 </a:solidFill>
                 <a:latin typeface="Arial"/>
               </a:defRPr>
@@ -4762,11 +4752,11 @@
             <a:avLst/>
           </a:prstGeom>
           <a:solidFill>
-            <a:srgbClr val="F5F6F8"/>
+            <a:srgbClr val="181622"/>
           </a:solidFill>
           <a:ln w="12700">
             <a:solidFill>
-              <a:srgbClr val="C8CDD7"/>
+              <a:srgbClr val="3C325A"/>
             </a:solidFill>
           </a:ln>
         </p:spPr>
@@ -4791,7 +4781,7 @@
             <a:pPr algn="ctr">
               <a:defRPr sz="1500" b="1">
                 <a:solidFill>
-                  <a:srgbClr val="141821"/>
+                  <a:srgbClr val="FFFFFF"/>
                 </a:solidFill>
                 <a:latin typeface="Arial"/>
               </a:defRPr>
@@ -4807,7 +4797,7 @@
               </a:spcAft>
               <a:defRPr sz="900" b="1">
                 <a:solidFill>
-                  <a:srgbClr val="0066CC"/>
+                  <a:srgbClr val="8A2BE2"/>
                 </a:solidFill>
                 <a:latin typeface="Arial"/>
               </a:defRPr>
@@ -4823,7 +4813,7 @@
               </a:spcBef>
               <a:defRPr sz="1150">
                 <a:solidFill>
-                  <a:srgbClr val="3C404B"/>
+                  <a:srgbClr val="C8C8DC"/>
                 </a:solidFill>
                 <a:latin typeface="Arial"/>
               </a:defRPr>
@@ -4849,11 +4839,11 @@
             <a:avLst/>
           </a:prstGeom>
           <a:solidFill>
-            <a:srgbClr val="F5F6F8"/>
+            <a:srgbClr val="181622"/>
           </a:solidFill>
           <a:ln w="12700">
             <a:solidFill>
-              <a:srgbClr val="C8CDD7"/>
+              <a:srgbClr val="3C325A"/>
             </a:solidFill>
           </a:ln>
         </p:spPr>
@@ -4878,7 +4868,7 @@
             <a:pPr algn="ctr">
               <a:defRPr sz="1500" b="1">
                 <a:solidFill>
-                  <a:srgbClr val="141821"/>
+                  <a:srgbClr val="FFFFFF"/>
                 </a:solidFill>
                 <a:latin typeface="Arial"/>
               </a:defRPr>
@@ -4894,7 +4884,7 @@
               </a:spcAft>
               <a:defRPr sz="900" b="1">
                 <a:solidFill>
-                  <a:srgbClr val="0066CC"/>
+                  <a:srgbClr val="8A2BE2"/>
                 </a:solidFill>
                 <a:latin typeface="Arial"/>
               </a:defRPr>
@@ -4910,7 +4900,7 @@
               </a:spcBef>
               <a:defRPr sz="1150">
                 <a:solidFill>
-                  <a:srgbClr val="3C404B"/>
+                  <a:srgbClr val="C8C8DC"/>
                 </a:solidFill>
                 <a:latin typeface="Arial"/>
               </a:defRPr>
@@ -4936,11 +4926,11 @@
             <a:avLst/>
           </a:prstGeom>
           <a:solidFill>
-            <a:srgbClr val="F5F6F8"/>
+            <a:srgbClr val="181622"/>
           </a:solidFill>
           <a:ln w="12700">
             <a:solidFill>
-              <a:srgbClr val="C8CDD7"/>
+              <a:srgbClr val="3C325A"/>
             </a:solidFill>
           </a:ln>
         </p:spPr>
@@ -4965,7 +4955,7 @@
             <a:pPr algn="ctr">
               <a:defRPr sz="1500" b="1">
                 <a:solidFill>
-                  <a:srgbClr val="141821"/>
+                  <a:srgbClr val="FFFFFF"/>
                 </a:solidFill>
                 <a:latin typeface="Arial"/>
               </a:defRPr>
@@ -4981,7 +4971,7 @@
               </a:spcAft>
               <a:defRPr sz="900" b="1">
                 <a:solidFill>
-                  <a:srgbClr val="0066CC"/>
+                  <a:srgbClr val="8A2BE2"/>
                 </a:solidFill>
                 <a:latin typeface="Arial"/>
               </a:defRPr>
@@ -4997,7 +4987,7 @@
               </a:spcBef>
               <a:defRPr sz="1150">
                 <a:solidFill>
-                  <a:srgbClr val="3C404B"/>
+                  <a:srgbClr val="C8C8DC"/>
                 </a:solidFill>
                 <a:latin typeface="Arial"/>
               </a:defRPr>
@@ -5023,11 +5013,11 @@
             <a:avLst/>
           </a:prstGeom>
           <a:solidFill>
-            <a:srgbClr val="F5F6F8"/>
+            <a:srgbClr val="181622"/>
           </a:solidFill>
           <a:ln w="12700">
             <a:solidFill>
-              <a:srgbClr val="C8CDD7"/>
+              <a:srgbClr val="3C325A"/>
             </a:solidFill>
           </a:ln>
         </p:spPr>
@@ -5052,7 +5042,7 @@
             <a:pPr algn="ctr">
               <a:defRPr sz="1500" b="1">
                 <a:solidFill>
-                  <a:srgbClr val="141821"/>
+                  <a:srgbClr val="FFFFFF"/>
                 </a:solidFill>
                 <a:latin typeface="Arial"/>
               </a:defRPr>
@@ -5068,7 +5058,7 @@
               </a:spcAft>
               <a:defRPr sz="900" b="1">
                 <a:solidFill>
-                  <a:srgbClr val="0066CC"/>
+                  <a:srgbClr val="8A2BE2"/>
                 </a:solidFill>
                 <a:latin typeface="Arial"/>
               </a:defRPr>
@@ -5084,7 +5074,7 @@
               </a:spcBef>
               <a:defRPr sz="1150">
                 <a:solidFill>
-                  <a:srgbClr val="3C404B"/>
+                  <a:srgbClr val="C8C8DC"/>
                 </a:solidFill>
                 <a:latin typeface="Arial"/>
               </a:defRPr>
@@ -5106,14 +5096,6 @@
 <file path=ppt/slides/slide5.xml><?xml version="1.0" encoding="utf-8"?>
 <p:sld xmlns:a="http://schemas.openxmlformats.org/drawingml/2006/main" xmlns:p="http://schemas.openxmlformats.org/presentationml/2006/main" xmlns:r="http://schemas.openxmlformats.org/officeDocument/2006/relationships">
   <p:cSld>
-    <p:bg>
-      <p:bgPr>
-        <a:solidFill>
-          <a:srgbClr val="FFFFFF"/>
-        </a:solidFill>
-        <a:effectLst/>
-      </p:bgPr>
-    </p:bg>
     <p:spTree>
       <p:nvGrpSpPr>
         <p:cNvPr id="1" name=""/>
@@ -5137,8 +5119,8 @@
         </p:blipFill>
         <p:spPr>
           <a:xfrm>
-            <a:off x="6217920" y="731520"/>
-            <a:ext cx="5212080" cy="5303520"/>
+            <a:off x="0" y="0"/>
+            <a:ext cx="12191695" cy="6858000"/>
           </a:xfrm>
           <a:prstGeom prst="rect">
             <a:avLst/>
@@ -5170,7 +5152,7 @@
             <a:pPr>
               <a:defRPr sz="3000" b="1">
                 <a:solidFill>
-                  <a:srgbClr val="141821"/>
+                  <a:srgbClr val="FFFFFF"/>
                 </a:solidFill>
                 <a:latin typeface="Arial"/>
               </a:defRPr>
@@ -5212,7 +5194,7 @@
                       <a:pPr algn="ctr">
                         <a:defRPr sz="1300" b="1">
                           <a:solidFill>
-                            <a:srgbClr val="0066CC"/>
+                            <a:srgbClr val="8A2BE2"/>
                           </a:solidFill>
                           <a:latin typeface="Arial"/>
                         </a:defRPr>
@@ -5224,7 +5206,7 @@
                   </a:txBody>
                   <a:tcPr>
                     <a:solidFill>
-                      <a:srgbClr val="F5F6F8"/>
+                      <a:srgbClr val="181622"/>
                     </a:solidFill>
                   </a:tcPr>
                 </a:tc>
@@ -5236,7 +5218,7 @@
                       <a:pPr algn="ctr">
                         <a:defRPr sz="1300" b="1">
                           <a:solidFill>
-                            <a:srgbClr val="0066CC"/>
+                            <a:srgbClr val="8A2BE2"/>
                           </a:solidFill>
                           <a:latin typeface="Arial"/>
                         </a:defRPr>
@@ -5248,7 +5230,7 @@
                   </a:txBody>
                   <a:tcPr>
                     <a:solidFill>
-                      <a:srgbClr val="F5F6F8"/>
+                      <a:srgbClr val="181622"/>
                     </a:solidFill>
                   </a:tcPr>
                 </a:tc>
@@ -5262,7 +5244,7 @@
                       <a:pPr algn="ctr">
                         <a:defRPr sz="1100">
                           <a:solidFill>
-                            <a:srgbClr val="3C404B"/>
+                            <a:srgbClr val="C8C8DC"/>
                           </a:solidFill>
                           <a:latin typeface="Arial"/>
                         </a:defRPr>
@@ -5274,7 +5256,7 @@
                   </a:txBody>
                   <a:tcPr>
                     <a:solidFill>
-                      <a:srgbClr val="FFFFFF"/>
+                      <a:srgbClr val="0A0A10"/>
                     </a:solidFill>
                   </a:tcPr>
                 </a:tc>
@@ -5286,7 +5268,7 @@
                       <a:pPr algn="ctr">
                         <a:defRPr sz="1100" b="1">
                           <a:solidFill>
-                            <a:srgbClr val="141821"/>
+                            <a:srgbClr val="FFFFFF"/>
                           </a:solidFill>
                           <a:latin typeface="Arial"/>
                         </a:defRPr>
@@ -5298,7 +5280,7 @@
                   </a:txBody>
                   <a:tcPr>
                     <a:solidFill>
-                      <a:srgbClr val="FFFFFF"/>
+                      <a:srgbClr val="0A0A10"/>
                     </a:solidFill>
                   </a:tcPr>
                 </a:tc>
@@ -5312,7 +5294,7 @@
                       <a:pPr algn="ctr">
                         <a:defRPr sz="1100">
                           <a:solidFill>
-                            <a:srgbClr val="3C404B"/>
+                            <a:srgbClr val="C8C8DC"/>
                           </a:solidFill>
                           <a:latin typeface="Arial"/>
                         </a:defRPr>
@@ -5324,7 +5306,7 @@
                   </a:txBody>
                   <a:tcPr>
                     <a:solidFill>
-                      <a:srgbClr val="FFFFFF"/>
+                      <a:srgbClr val="0A0A10"/>
                     </a:solidFill>
                   </a:tcPr>
                 </a:tc>
@@ -5336,7 +5318,7 @@
                       <a:pPr algn="ctr">
                         <a:defRPr sz="1100" b="1">
                           <a:solidFill>
-                            <a:srgbClr val="141821"/>
+                            <a:srgbClr val="FFFFFF"/>
                           </a:solidFill>
                           <a:latin typeface="Arial"/>
                         </a:defRPr>
@@ -5348,7 +5330,7 @@
                   </a:txBody>
                   <a:tcPr>
                     <a:solidFill>
-                      <a:srgbClr val="FFFFFF"/>
+                      <a:srgbClr val="0A0A10"/>
                     </a:solidFill>
                   </a:tcPr>
                 </a:tc>
@@ -5362,7 +5344,7 @@
                       <a:pPr algn="ctr">
                         <a:defRPr sz="1100">
                           <a:solidFill>
-                            <a:srgbClr val="3C404B"/>
+                            <a:srgbClr val="C8C8DC"/>
                           </a:solidFill>
                           <a:latin typeface="Arial"/>
                         </a:defRPr>
@@ -5374,7 +5356,7 @@
                   </a:txBody>
                   <a:tcPr>
                     <a:solidFill>
-                      <a:srgbClr val="FFFFFF"/>
+                      <a:srgbClr val="0A0A10"/>
                     </a:solidFill>
                   </a:tcPr>
                 </a:tc>
@@ -5386,7 +5368,7 @@
                       <a:pPr algn="ctr">
                         <a:defRPr sz="1100" b="1">
                           <a:solidFill>
-                            <a:srgbClr val="141821"/>
+                            <a:srgbClr val="FFFFFF"/>
                           </a:solidFill>
                           <a:latin typeface="Arial"/>
                         </a:defRPr>
@@ -5398,7 +5380,7 @@
                   </a:txBody>
                   <a:tcPr>
                     <a:solidFill>
-                      <a:srgbClr val="FFFFFF"/>
+                      <a:srgbClr val="0A0A10"/>
                     </a:solidFill>
                   </a:tcPr>
                 </a:tc>
@@ -5412,7 +5394,7 @@
                       <a:pPr algn="ctr">
                         <a:defRPr sz="1100">
                           <a:solidFill>
-                            <a:srgbClr val="3C404B"/>
+                            <a:srgbClr val="C8C8DC"/>
                           </a:solidFill>
                           <a:latin typeface="Arial"/>
                         </a:defRPr>
@@ -5424,7 +5406,7 @@
                   </a:txBody>
                   <a:tcPr>
                     <a:solidFill>
-                      <a:srgbClr val="FFFFFF"/>
+                      <a:srgbClr val="0A0A10"/>
                     </a:solidFill>
                   </a:tcPr>
                 </a:tc>
@@ -5436,7 +5418,7 @@
                       <a:pPr algn="ctr">
                         <a:defRPr sz="1100" b="1">
                           <a:solidFill>
-                            <a:srgbClr val="141821"/>
+                            <a:srgbClr val="FFFFFF"/>
                           </a:solidFill>
                           <a:latin typeface="Arial"/>
                         </a:defRPr>
@@ -5448,7 +5430,7 @@
                   </a:txBody>
                   <a:tcPr>
                     <a:solidFill>
-                      <a:srgbClr val="FFFFFF"/>
+                      <a:srgbClr val="0A0A10"/>
                     </a:solidFill>
                   </a:tcPr>
                 </a:tc>
@@ -5485,7 +5467,7 @@
               </a:spcAft>
               <a:defRPr sz="1500" b="1">
                 <a:solidFill>
-                  <a:srgbClr val="0066CC"/>
+                  <a:srgbClr val="8A2BE2"/>
                 </a:solidFill>
                 <a:latin typeface="Arial"/>
               </a:defRPr>
@@ -5501,7 +5483,7 @@
               </a:spcAft>
               <a:defRPr sz="1050">
                 <a:solidFill>
-                  <a:srgbClr val="3C404B"/>
+                  <a:srgbClr val="C8C8DC"/>
                 </a:solidFill>
                 <a:latin typeface="Arial"/>
               </a:defRPr>
@@ -5517,7 +5499,7 @@
               </a:spcAft>
               <a:defRPr sz="1050">
                 <a:solidFill>
-                  <a:srgbClr val="3C404B"/>
+                  <a:srgbClr val="C8C8DC"/>
                 </a:solidFill>
                 <a:latin typeface="Arial"/>
               </a:defRPr>
@@ -5533,7 +5515,7 @@
               </a:spcAft>
               <a:defRPr sz="1050">
                 <a:solidFill>
-                  <a:srgbClr val="3C404B"/>
+                  <a:srgbClr val="C8C8DC"/>
                 </a:solidFill>
                 <a:latin typeface="Arial"/>
               </a:defRPr>
@@ -5549,7 +5531,7 @@
               </a:spcAft>
               <a:defRPr sz="1050">
                 <a:solidFill>
-                  <a:srgbClr val="3C404B"/>
+                  <a:srgbClr val="C8C8DC"/>
                 </a:solidFill>
                 <a:latin typeface="Arial"/>
               </a:defRPr>
@@ -5571,14 +5553,6 @@
 <file path=ppt/slides/slide6.xml><?xml version="1.0" encoding="utf-8"?>
 <p:sld xmlns:a="http://schemas.openxmlformats.org/drawingml/2006/main" xmlns:p="http://schemas.openxmlformats.org/presentationml/2006/main" xmlns:r="http://schemas.openxmlformats.org/officeDocument/2006/relationships">
   <p:cSld>
-    <p:bg>
-      <p:bgPr>
-        <a:solidFill>
-          <a:srgbClr val="FFFFFF"/>
-        </a:solidFill>
-        <a:effectLst/>
-      </p:bgPr>
-    </p:bg>
     <p:spTree>
       <p:nvGrpSpPr>
         <p:cNvPr id="1" name=""/>
@@ -5602,8 +5576,8 @@
         </p:blipFill>
         <p:spPr>
           <a:xfrm>
-            <a:off x="6217920" y="731520"/>
-            <a:ext cx="5212080" cy="5303520"/>
+            <a:off x="0" y="0"/>
+            <a:ext cx="12191695" cy="6858000"/>
           </a:xfrm>
           <a:prstGeom prst="rect">
             <a:avLst/>
@@ -5635,7 +5609,7 @@
             <a:pPr>
               <a:defRPr sz="3000" b="1">
                 <a:solidFill>
-                  <a:srgbClr val="141821"/>
+                  <a:srgbClr val="FFFFFF"/>
                 </a:solidFill>
                 <a:latin typeface="Arial"/>
               </a:defRPr>
@@ -5674,7 +5648,7 @@
               </a:spcBef>
               <a:defRPr sz="1400" b="1">
                 <a:solidFill>
-                  <a:srgbClr val="0066CC"/>
+                  <a:srgbClr val="8A2BE2"/>
                 </a:solidFill>
                 <a:latin typeface="Arial"/>
               </a:defRPr>
@@ -5690,7 +5664,7 @@
               </a:spcAft>
               <a:defRPr sz="1100">
                 <a:solidFill>
-                  <a:srgbClr val="3C404B"/>
+                  <a:srgbClr val="C8C8DC"/>
                 </a:solidFill>
                 <a:latin typeface="Arial"/>
               </a:defRPr>
@@ -5714,7 +5688,7 @@
               </a:spcBef>
               <a:defRPr sz="1400" b="1">
                 <a:solidFill>
-                  <a:srgbClr val="0066CC"/>
+                  <a:srgbClr val="8A2BE2"/>
                 </a:solidFill>
                 <a:latin typeface="Arial"/>
               </a:defRPr>
@@ -5730,7 +5704,7 @@
               </a:spcAft>
               <a:defRPr sz="1100">
                 <a:solidFill>
-                  <a:srgbClr val="3C404B"/>
+                  <a:srgbClr val="C8C8DC"/>
                 </a:solidFill>
                 <a:latin typeface="Arial"/>
               </a:defRPr>
@@ -5750,7 +5724,7 @@
               </a:spcBef>
               <a:defRPr sz="1400" b="1">
                 <a:solidFill>
-                  <a:srgbClr val="0066CC"/>
+                  <a:srgbClr val="8A2BE2"/>
                 </a:solidFill>
                 <a:latin typeface="Arial"/>
               </a:defRPr>
@@ -5766,7 +5740,7 @@
               </a:spcAft>
               <a:defRPr sz="1100">
                 <a:solidFill>
-                  <a:srgbClr val="3C404B"/>
+                  <a:srgbClr val="C8C8DC"/>
                 </a:solidFill>
                 <a:latin typeface="Arial"/>
               </a:defRPr>
@@ -5791,7 +5765,7 @@
     <p:bg>
       <p:bgPr>
         <a:solidFill>
-          <a:srgbClr val="FFFFFF"/>
+          <a:srgbClr val="0A0A10"/>
         </a:solidFill>
         <a:effectLst/>
       </p:bgPr>
@@ -5828,7 +5802,7 @@
             <a:pPr>
               <a:defRPr sz="3000" b="1">
                 <a:solidFill>
-                  <a:srgbClr val="141821"/>
+                  <a:srgbClr val="8A2BE2"/>
                 </a:solidFill>
                 <a:latin typeface="Arial"/>
               </a:defRPr>
@@ -5854,11 +5828,11 @@
             <a:avLst/>
           </a:prstGeom>
           <a:solidFill>
-            <a:srgbClr val="F5F6F8"/>
+            <a:srgbClr val="181622"/>
           </a:solidFill>
           <a:ln w="12700">
             <a:solidFill>
-              <a:srgbClr val="C8CDD7"/>
+              <a:srgbClr val="3C325A"/>
             </a:solidFill>
           </a:ln>
         </p:spPr>
@@ -5886,7 +5860,7 @@
               </a:spcAft>
               <a:defRPr sz="1800" b="1">
                 <a:solidFill>
-                  <a:srgbClr val="141821"/>
+                  <a:srgbClr val="FFFFFF"/>
                 </a:solidFill>
                 <a:latin typeface="Arial"/>
               </a:defRPr>
@@ -5902,7 +5876,7 @@
               </a:spcAft>
               <a:defRPr sz="1300">
                 <a:solidFill>
-                  <a:srgbClr val="3C404B"/>
+                  <a:srgbClr val="C8C8DC"/>
                 </a:solidFill>
                 <a:latin typeface="Arial"/>
               </a:defRPr>
@@ -5918,7 +5892,7 @@
               </a:spcAft>
               <a:defRPr sz="1300">
                 <a:solidFill>
-                  <a:srgbClr val="3C404B"/>
+                  <a:srgbClr val="C8C8DC"/>
                 </a:solidFill>
                 <a:latin typeface="Arial"/>
               </a:defRPr>
@@ -5934,7 +5908,7 @@
               </a:spcAft>
               <a:defRPr sz="1300">
                 <a:solidFill>
-                  <a:srgbClr val="3C404B"/>
+                  <a:srgbClr val="C8C8DC"/>
                 </a:solidFill>
                 <a:latin typeface="Arial"/>
               </a:defRPr>
@@ -5960,11 +5934,11 @@
             <a:avLst/>
           </a:prstGeom>
           <a:solidFill>
-            <a:srgbClr val="F5F6F8"/>
+            <a:srgbClr val="181622"/>
           </a:solidFill>
           <a:ln w="12700">
             <a:solidFill>
-              <a:srgbClr val="C8CDD7"/>
+              <a:srgbClr val="3C325A"/>
             </a:solidFill>
           </a:ln>
         </p:spPr>
@@ -5992,7 +5966,7 @@
               </a:spcAft>
               <a:defRPr sz="1800" b="1">
                 <a:solidFill>
-                  <a:srgbClr val="0066CC"/>
+                  <a:srgbClr val="8A2BE2"/>
                 </a:solidFill>
                 <a:latin typeface="Arial"/>
               </a:defRPr>
@@ -6008,7 +5982,7 @@
               </a:spcBef>
               <a:defRPr sz="1200">
                 <a:solidFill>
-                  <a:srgbClr val="3C404B"/>
+                  <a:srgbClr val="C8C8DC"/>
                 </a:solidFill>
                 <a:latin typeface="Arial"/>
               </a:defRPr>

</xml_diff>

<commit_message>
docs: Reorganize slides structure into McKinsey SCR theme with Action Titles
</commit_message>
<xml_diff>
--- a/reports/cdac_project_review.pptx
+++ b/reports/cdac_project_review.pptx
@@ -3126,8 +3126,8 @@
         </p:nvSpPr>
         <p:spPr>
           <a:xfrm>
-            <a:off x="685800" y="365760"/>
-            <a:ext cx="5029200" cy="1463040"/>
+            <a:off x="685800" y="274320"/>
+            <a:ext cx="5029200" cy="1554480"/>
           </a:xfrm>
           <a:prstGeom prst="rect">
             <a:avLst/>
@@ -3141,7 +3141,7 @@
           <a:lstStyle/>
           <a:p>
             <a:pPr>
-              <a:defRPr sz="4200" b="1">
+              <a:defRPr sz="4000" b="1">
                 <a:solidFill>
                   <a:srgbClr val="FFFFFF"/>
                 </a:solidFill>
@@ -3155,9 +3155,9 @@
           <a:p>
             <a:pPr>
               <a:spcBef>
-                <a:spcPts val="600"/>
+                <a:spcPts val="400"/>
               </a:spcBef>
-              <a:defRPr sz="1500" b="1">
+              <a:defRPr sz="1400" b="1">
                 <a:solidFill>
                   <a:srgbClr val="8A2BE2"/>
                 </a:solidFill>
@@ -3165,7 +3165,7 @@
               </a:defRPr>
             </a:pPr>
             <a:r>
-              <a:t>Multimodal Real-Time Biometric Liveness &amp; Identity Verification System</a:t>
+              <a:t>Multimodal Real-Time Biometric Liveness &amp; Identity Verification</a:t>
             </a:r>
           </a:p>
         </p:txBody>
@@ -3178,7 +3178,7 @@
         </p:nvSpPr>
         <p:spPr>
           <a:xfrm>
-            <a:off x="685800" y="1920240"/>
+            <a:off x="685800" y="1828800"/>
             <a:ext cx="5029200" cy="1005840"/>
           </a:xfrm>
           <a:prstGeom prst="rect">
@@ -3193,7 +3193,7 @@
           <a:lstStyle/>
           <a:p>
             <a:pPr>
-              <a:defRPr sz="1150" b="1">
+              <a:defRPr sz="1100" b="1">
                 <a:solidFill>
                   <a:srgbClr val="C8C8DC"/>
                 </a:solidFill>
@@ -3209,7 +3209,7 @@
               <a:spcBef>
                 <a:spcPts val="300"/>
               </a:spcBef>
-              <a:defRPr sz="1150" b="1">
+              <a:defRPr sz="1100" b="1">
                 <a:solidFill>
                   <a:srgbClr val="C8C8DC"/>
                 </a:solidFill>
@@ -3225,7 +3225,7 @@
               <a:spcBef>
                 <a:spcPts val="500"/>
               </a:spcBef>
-              <a:defRPr sz="1150">
+              <a:defRPr sz="1100">
                 <a:solidFill>
                   <a:srgbClr val="827896"/>
                 </a:solidFill>
@@ -3246,8 +3246,8 @@
         </p:nvSpPr>
         <p:spPr>
           <a:xfrm>
-            <a:off x="685800" y="3017520"/>
-            <a:ext cx="5029200" cy="3291840"/>
+            <a:off x="685800" y="2926080"/>
+            <a:ext cx="5029200" cy="3383280"/>
           </a:xfrm>
           <a:prstGeom prst="roundRect">
             <a:avLst/>
@@ -3276,11 +3276,11 @@
           </a:fontRef>
         </p:style>
         <p:txBody>
-          <a:bodyPr rtlCol="0" anchor="ctr" wrap="square" lIns="228600" tIns="228600" rIns="228600" bIns="228600"/>
+          <a:bodyPr rtlCol="0" anchor="ctr" wrap="square" lIns="228600" tIns="182880" rIns="228600" bIns="182880"/>
           <a:lstStyle/>
           <a:p>
             <a:pPr algn="ctr">
-              <a:defRPr sz="1500" b="1">
+              <a:defRPr sz="1400" b="1">
                 <a:solidFill>
                   <a:srgbClr val="8A2BE2"/>
                 </a:solidFill>
@@ -3288,7 +3288,7 @@
               </a:defRPr>
             </a:pPr>
             <a:r>
-              <a:t>PROBLEM FORMULATION</a:t>
+              <a:t>SITUATION &amp; COMPLICATION</a:t>
             </a:r>
           </a:p>
           <a:p>
@@ -3296,7 +3296,7 @@
               <a:spcBef>
                 <a:spcPts val="600"/>
               </a:spcBef>
-              <a:defRPr sz="1100">
+              <a:defRPr sz="1050">
                 <a:solidFill>
                   <a:srgbClr val="C8C8DC"/>
                 </a:solidFill>
@@ -3304,19 +3304,15 @@
               </a:defRPr>
             </a:pPr>
             <a:r>
-              <a:t>Remote biometric systems face vulnerabilities to spoofing:</a:t>
+              <a:t>• Context: Remote high-stakes evaluations (exams, interviews) rely on standard 2D webcams for candidate authentication.</a:t>
             </a:r>
             <a:br/>
             <a:r>
-              <a:t>• Presentation Attacks (PA): Static photo prints, video loop replays, and 3D masks deceive traditional facial recognition.</a:t>
+              <a:t>• Complication: Traditional facial recognition is bypassed by presentation attacks (printed photos, video replay screens) and mid-session identity swapping.</a:t>
             </a:r>
             <a:br/>
             <a:r>
-              <a:t>• Identity Swapping: User swaps mid-session (tag-team cheating) during active testing or authentication.</a:t>
-            </a:r>
-            <a:br/>
-            <a:r>
-              <a:t>• Deployment Limits: Existing anti-spoofing methods require specialized depth hardware, rendering wide scale deployments impractical.</a:t>
+              <a:t>• Resolution: SHIELD introduces a unified real-time framework integrating facial texture patterns, physiological cardiac pulse (rPPG), and active behavioral challenges.</a:t>
             </a:r>
           </a:p>
         </p:txBody>
@@ -3355,8 +3351,8 @@
         </p:nvSpPr>
         <p:spPr>
           <a:xfrm>
-            <a:off x="685800" y="365760"/>
-            <a:ext cx="10817352" cy="731520"/>
+            <a:off x="685800" y="320040"/>
+            <a:ext cx="10817352" cy="914400"/>
           </a:xfrm>
           <a:prstGeom prst="rect">
             <a:avLst/>
@@ -3370,7 +3366,7 @@
           <a:lstStyle/>
           <a:p>
             <a:pPr>
-              <a:defRPr sz="3000" b="1">
+              <a:defRPr sz="2200" b="1">
                 <a:solidFill>
                   <a:srgbClr val="8A2BE2"/>
                 </a:solidFill>
@@ -3378,7 +3374,7 @@
               </a:defRPr>
             </a:pPr>
             <a:r>
-              <a:t>Project Objectives</a:t>
+              <a:t>Objectives: Establishing a Standard-Compliant, Low-Latency Defense for Remote Identity Verification</a:t>
             </a:r>
           </a:p>
         </p:txBody>
@@ -3655,8 +3651,8 @@
         </p:nvSpPr>
         <p:spPr>
           <a:xfrm>
-            <a:off x="685800" y="365760"/>
-            <a:ext cx="10817352" cy="731520"/>
+            <a:off x="685800" y="320040"/>
+            <a:ext cx="10817352" cy="914400"/>
           </a:xfrm>
           <a:prstGeom prst="rect">
             <a:avLst/>
@@ -3670,7 +3666,7 @@
           <a:lstStyle/>
           <a:p>
             <a:pPr>
-              <a:defRPr sz="3000" b="1">
+              <a:defRPr sz="2200" b="1">
                 <a:solidFill>
                   <a:srgbClr val="8A2BE2"/>
                 </a:solidFill>
@@ -3678,7 +3674,7 @@
               </a:defRPr>
             </a:pPr>
             <a:r>
-              <a:t>System Architecture Pipeline</a:t>
+              <a:t>Architecture: Multi-Tiered Verification Processing Raw Webcam Frames to Final Score Fusion</a:t>
             </a:r>
           </a:p>
         </p:txBody>
@@ -4709,8 +4705,8 @@
         </p:nvSpPr>
         <p:spPr>
           <a:xfrm>
-            <a:off x="685800" y="365760"/>
-            <a:ext cx="10817352" cy="731520"/>
+            <a:off x="685800" y="320040"/>
+            <a:ext cx="10817352" cy="914400"/>
           </a:xfrm>
           <a:prstGeom prst="rect">
             <a:avLst/>
@@ -4724,7 +4720,7 @@
           <a:lstStyle/>
           <a:p>
             <a:pPr>
-              <a:defRPr sz="3000" b="1">
+              <a:defRPr sz="2200" b="1">
                 <a:solidFill>
                   <a:srgbClr val="8A2BE2"/>
                 </a:solidFill>
@@ -4732,7 +4728,7 @@
               </a:defRPr>
             </a:pPr>
             <a:r>
-              <a:t>Multimodal Verification Pillars</a:t>
+              <a:t>Defense Pillars: Combining Spatial Textures, Cardiac Physiology, and Active Directives</a:t>
             </a:r>
           </a:p>
         </p:txBody>
@@ -5135,8 +5131,8 @@
         </p:nvSpPr>
         <p:spPr>
           <a:xfrm>
-            <a:off x="685800" y="365760"/>
-            <a:ext cx="5120640" cy="731520"/>
+            <a:off x="685800" y="274320"/>
+            <a:ext cx="5120640" cy="914400"/>
           </a:xfrm>
           <a:prstGeom prst="rect">
             <a:avLst/>
@@ -5150,7 +5146,7 @@
           <a:lstStyle/>
           <a:p>
             <a:pPr>
-              <a:defRPr sz="3000" b="1">
+              <a:defRPr sz="1900" b="1">
                 <a:solidFill>
                   <a:srgbClr val="FFFFFF"/>
                 </a:solidFill>
@@ -5158,7 +5154,7 @@
               </a:defRPr>
             </a:pPr>
             <a:r>
-              <a:t>Results &amp; Evaluation Matrix</a:t>
+              <a:t>Results: SHIELD Exceeds Enterprise Standards with 1.0% ACER at 85ms Latency</a:t>
             </a:r>
           </a:p>
         </p:txBody>
@@ -5172,7 +5168,7 @@
           <p:nvPr/>
         </p:nvGraphicFramePr>
         <p:xfrm>
-          <a:off x="685800" y="1188720"/>
+          <a:off x="685800" y="1280160"/>
           <a:ext cx="5120640" cy="2011680"/>
         </p:xfrm>
         <a:graphic>
@@ -5447,8 +5443,8 @@
         </p:nvSpPr>
         <p:spPr>
           <a:xfrm>
-            <a:off x="685800" y="3383280"/>
-            <a:ext cx="5120640" cy="3017520"/>
+            <a:off x="685800" y="3474720"/>
+            <a:ext cx="5120640" cy="2926080"/>
           </a:xfrm>
           <a:prstGeom prst="rect">
             <a:avLst/>
@@ -5592,8 +5588,8 @@
         </p:nvSpPr>
         <p:spPr>
           <a:xfrm>
-            <a:off x="685800" y="365760"/>
-            <a:ext cx="5120640" cy="731520"/>
+            <a:off x="685800" y="274320"/>
+            <a:ext cx="5120640" cy="914400"/>
           </a:xfrm>
           <a:prstGeom prst="rect">
             <a:avLst/>
@@ -5607,7 +5603,7 @@
           <a:lstStyle/>
           <a:p>
             <a:pPr>
-              <a:defRPr sz="3000" b="1">
+              <a:defRPr sz="1900" b="1">
                 <a:solidFill>
                   <a:srgbClr val="FFFFFF"/>
                 </a:solidFill>
@@ -5615,7 +5611,7 @@
               </a:defRPr>
             </a:pPr>
             <a:r>
-              <a:t>Novelty &amp; Custom Contributions</a:t>
+              <a:t>Novelty: Scale-Invariant Identity Landmark Trajectories Prevent Mid-Session Swapping</a:t>
             </a:r>
           </a:p>
         </p:txBody>
@@ -5628,8 +5624,8 @@
         </p:nvSpPr>
         <p:spPr>
           <a:xfrm>
-            <a:off x="685800" y="1188720"/>
-            <a:ext cx="5120640" cy="5303520"/>
+            <a:off x="685800" y="1280160"/>
+            <a:ext cx="5120640" cy="5212080"/>
           </a:xfrm>
           <a:prstGeom prst="rect">
             <a:avLst/>
@@ -5785,8 +5781,8 @@
         </p:nvSpPr>
         <p:spPr>
           <a:xfrm>
-            <a:off x="685800" y="365760"/>
-            <a:ext cx="10817352" cy="731520"/>
+            <a:off x="685800" y="320040"/>
+            <a:ext cx="10817352" cy="914400"/>
           </a:xfrm>
           <a:prstGeom prst="rect">
             <a:avLst/>
@@ -5800,7 +5796,7 @@
           <a:lstStyle/>
           <a:p>
             <a:pPr>
-              <a:defRPr sz="3000" b="1">
+              <a:defRPr sz="2200" b="1">
                 <a:solidFill>
                   <a:srgbClr val="8A2BE2"/>
                 </a:solidFill>
@@ -5808,7 +5804,7 @@
               </a:defRPr>
             </a:pPr>
             <a:r>
-              <a:t>Interface Design &amp; Live Demonstration</a:t>
+              <a:t>Deployment: Flutter Dashboard and WebSocket Ingestion Enable Seamless Live Audit Trails</a:t>
             </a:r>
           </a:p>
         </p:txBody>

</xml_diff>

<commit_message>
docs: Completely build McKinsey consulting style slides from scratch with pure typography layout
</commit_message>
<xml_diff>
--- a/reports/cdac_project_review.pptx
+++ b/reports/cdac_project_review.pptx
@@ -3087,6 +3087,14 @@
 <file path=ppt/slides/slide1.xml><?xml version="1.0" encoding="utf-8"?>
 <p:sld xmlns:a="http://schemas.openxmlformats.org/drawingml/2006/main" xmlns:p="http://schemas.openxmlformats.org/presentationml/2006/main" xmlns:r="http://schemas.openxmlformats.org/officeDocument/2006/relationships">
   <p:cSld>
+    <p:bg>
+      <p:bgPr>
+        <a:solidFill>
+          <a:srgbClr val="FFFFFF"/>
+        </a:solidFill>
+        <a:effectLst/>
+      </p:bgPr>
+    </p:bg>
     <p:spTree>
       <p:nvGrpSpPr>
         <p:cNvPr id="1" name=""/>
@@ -3094,40 +3102,16 @@
         <p:nvPr/>
       </p:nvGrpSpPr>
       <p:grpSpPr/>
-      <p:pic>
-        <p:nvPicPr>
-          <p:cNvPr id="2" name="Picture 1" descr="shield_cover_visual_1783185170999.jpg"/>
-          <p:cNvPicPr>
-            <a:picLocks noChangeAspect="1"/>
-          </p:cNvPicPr>
+      <p:sp>
+        <p:nvSpPr>
+          <p:cNvPr id="2" name="TextBox 1"/>
+          <p:cNvSpPr txBox="1"/>
           <p:nvPr/>
-        </p:nvPicPr>
-        <p:blipFill>
-          <a:blip r:embed="rId2"/>
-          <a:stretch>
-            <a:fillRect/>
-          </a:stretch>
-        </p:blipFill>
+        </p:nvSpPr>
         <p:spPr>
           <a:xfrm>
-            <a:off x="0" y="0"/>
-            <a:ext cx="12191695" cy="6858000"/>
-          </a:xfrm>
-          <a:prstGeom prst="rect">
-            <a:avLst/>
-          </a:prstGeom>
-        </p:spPr>
-      </p:pic>
-      <p:sp>
-        <p:nvSpPr>
-          <p:cNvPr id="3" name="TextBox 2"/>
-          <p:cNvSpPr txBox="1"/>
-          <p:nvPr/>
-        </p:nvSpPr>
-        <p:spPr>
-          <a:xfrm>
-            <a:off x="685800" y="274320"/>
-            <a:ext cx="5029200" cy="1554480"/>
+            <a:off x="685800" y="365760"/>
+            <a:ext cx="10817352" cy="1645920"/>
           </a:xfrm>
           <a:prstGeom prst="rect">
             <a:avLst/>
@@ -3135,21 +3119,53 @@
           <a:noFill/>
         </p:spPr>
         <p:txBody>
-          <a:bodyPr wrap="square" lIns="0" tIns="0" rIns="0" bIns="0">
+          <a:bodyPr wrap="square" lIns="0" tIns="0">
             <a:spAutoFit/>
           </a:bodyPr>
           <a:lstStyle/>
           <a:p>
             <a:pPr>
-              <a:defRPr sz="4000" b="1">
-                <a:solidFill>
-                  <a:srgbClr val="FFFFFF"/>
+              <a:defRPr sz="3200" b="1">
+                <a:solidFill>
+                  <a:srgbClr val="00205B"/>
+                </a:solidFill>
+                <a:latin typeface="Georgia"/>
+              </a:defRPr>
+            </a:pPr>
+            <a:r>
+              <a:t>SHIELD: A Multimodal Liveness Framework Securing Remote Identity Verification</a:t>
+            </a:r>
+          </a:p>
+          <a:p>
+            <a:pPr>
+              <a:spcBef>
+                <a:spcPts val="800"/>
+              </a:spcBef>
+              <a:defRPr sz="1500" i="1">
+                <a:solidFill>
+                  <a:srgbClr val="78828C"/>
                 </a:solidFill>
                 <a:latin typeface="Arial"/>
               </a:defRPr>
             </a:pPr>
             <a:r>
-              <a:t>SHIELD</a:t>
+              <a:t>Executive Briefing on Automated Anti-Spoofing and Liveness Detection</a:t>
+            </a:r>
+          </a:p>
+          <a:p>
+            <a:pPr>
+              <a:spcBef>
+                <a:spcPts val="600"/>
+              </a:spcBef>
+              <a:defRPr sz="1100" b="1">
+                <a:solidFill>
+                  <a:srgbClr val="50555F"/>
+                </a:solidFill>
+                <a:latin typeface="Arial"/>
+              </a:defRPr>
+            </a:pPr>
+            <a:r>
+              <a:t>Project Partners: Sthavir Sunil Punwatkar, [Project Partner 2]  |  Project Guide: [Project Guide Name]</a:t>
             </a:r>
           </a:p>
           <a:p>
@@ -3157,107 +3173,39 @@
               <a:spcBef>
                 <a:spcPts val="400"/>
               </a:spcBef>
-              <a:defRPr sz="1400" b="1">
-                <a:solidFill>
-                  <a:srgbClr val="8A2BE2"/>
+              <a:defRPr sz="1100">
+                <a:solidFill>
+                  <a:srgbClr val="78828C"/>
                 </a:solidFill>
                 <a:latin typeface="Arial"/>
               </a:defRPr>
             </a:pPr>
             <a:r>
-              <a:t>Multimodal Real-Time Biometric Liveness &amp; Identity Verification</a:t>
-            </a:r>
-          </a:p>
-        </p:txBody>
-      </p:sp>
-      <p:sp>
-        <p:nvSpPr>
-          <p:cNvPr id="4" name="TextBox 3"/>
-          <p:cNvSpPr txBox="1"/>
+              <a:t>CDAC Project Review Board  |  Domain: Biometrics &amp; Computer Vision</a:t>
+            </a:r>
+          </a:p>
+        </p:txBody>
+      </p:sp>
+      <p:sp>
+        <p:nvSpPr>
+          <p:cNvPr id="3" name="Rounded Rectangle 2"/>
+          <p:cNvSpPr/>
           <p:nvPr/>
         </p:nvSpPr>
         <p:spPr>
           <a:xfrm>
-            <a:off x="685800" y="1828800"/>
-            <a:ext cx="5029200" cy="1005840"/>
-          </a:xfrm>
-          <a:prstGeom prst="rect">
-            <a:avLst/>
-          </a:prstGeom>
-          <a:noFill/>
-        </p:spPr>
-        <p:txBody>
-          <a:bodyPr wrap="square" lIns="0" tIns="0" rIns="0" bIns="0">
-            <a:spAutoFit/>
-          </a:bodyPr>
-          <a:lstStyle/>
-          <a:p>
-            <a:pPr>
-              <a:defRPr sz="1100" b="1">
-                <a:solidFill>
-                  <a:srgbClr val="C8C8DC"/>
-                </a:solidFill>
-                <a:latin typeface="Arial"/>
-              </a:defRPr>
-            </a:pPr>
-            <a:r>
-              <a:t>Project Partners: Sthavir Sunil Punwatkar, [Project Partner 2]</a:t>
-            </a:r>
-          </a:p>
-          <a:p>
-            <a:pPr>
-              <a:spcBef>
-                <a:spcPts val="300"/>
-              </a:spcBef>
-              <a:defRPr sz="1100" b="1">
-                <a:solidFill>
-                  <a:srgbClr val="C8C8DC"/>
-                </a:solidFill>
-                <a:latin typeface="Arial"/>
-              </a:defRPr>
-            </a:pPr>
-            <a:r>
-              <a:t>Project Guide: [Project Guide Name]</a:t>
-            </a:r>
-          </a:p>
-          <a:p>
-            <a:pPr>
-              <a:spcBef>
-                <a:spcPts val="500"/>
-              </a:spcBef>
-              <a:defRPr sz="1100">
-                <a:solidFill>
-                  <a:srgbClr val="827896"/>
-                </a:solidFill>
-                <a:latin typeface="Arial"/>
-              </a:defRPr>
-            </a:pPr>
-            <a:r>
-              <a:t>CDAC Project Review  |  Domain: Biometrics &amp; Computer Vision</a:t>
-            </a:r>
-          </a:p>
-        </p:txBody>
-      </p:sp>
-      <p:sp>
-        <p:nvSpPr>
-          <p:cNvPr id="5" name="Rounded Rectangle 4"/>
-          <p:cNvSpPr/>
-          <p:nvPr/>
-        </p:nvSpPr>
-        <p:spPr>
-          <a:xfrm>
-            <a:off x="685800" y="2926080"/>
-            <a:ext cx="5029200" cy="3383280"/>
+            <a:off x="685800" y="2377440"/>
+            <a:ext cx="3383280" cy="3657600"/>
           </a:xfrm>
           <a:prstGeom prst="roundRect">
             <a:avLst/>
           </a:prstGeom>
           <a:solidFill>
-            <a:srgbClr val="181622"/>
+            <a:srgbClr val="F5F6F8"/>
           </a:solidFill>
           <a:ln w="12700">
             <a:solidFill>
-              <a:srgbClr val="3C325A"/>
+              <a:srgbClr val="C8CDD7"/>
             </a:solidFill>
           </a:ln>
         </p:spPr>
@@ -3276,43 +3224,234 @@
           </a:fontRef>
         </p:style>
         <p:txBody>
-          <a:bodyPr rtlCol="0" anchor="ctr" wrap="square" lIns="228600" tIns="182880" rIns="228600" bIns="182880"/>
+          <a:bodyPr rtlCol="0" anchor="ctr" wrap="square" lIns="182880" tIns="228600" rIns="182880" bIns="182880"/>
           <a:lstStyle/>
           <a:p>
             <a:pPr algn="ctr">
-              <a:defRPr sz="1400" b="1">
-                <a:solidFill>
-                  <a:srgbClr val="8A2BE2"/>
+              <a:defRPr sz="1100" b="1">
+                <a:solidFill>
+                  <a:srgbClr val="78828C"/>
                 </a:solidFill>
                 <a:latin typeface="Arial"/>
               </a:defRPr>
             </a:pPr>
             <a:r>
-              <a:t>SITUATION &amp; COMPLICATION</a:t>
+              <a:t>SITUATION</a:t>
             </a:r>
           </a:p>
           <a:p>
             <a:pPr>
               <a:spcBef>
-                <a:spcPts val="600"/>
+                <a:spcPts val="400"/>
               </a:spcBef>
-              <a:defRPr sz="1050">
-                <a:solidFill>
-                  <a:srgbClr val="C8C8DC"/>
+              <a:spcAft>
+                <a:spcPts val="1000"/>
+              </a:spcAft>
+              <a:defRPr sz="1500" b="1">
+                <a:solidFill>
+                  <a:srgbClr val="00205B"/>
+                </a:solidFill>
+                <a:latin typeface="Georgia"/>
+              </a:defRPr>
+            </a:pPr>
+            <a:r>
+              <a:t>Remote Identity Verification</a:t>
+            </a:r>
+          </a:p>
+          <a:p>
+            <a:pPr>
+              <a:spcBef>
+                <a:spcPts val="400"/>
+              </a:spcBef>
+              <a:defRPr sz="1100">
+                <a:solidFill>
+                  <a:srgbClr val="212529"/>
                 </a:solidFill>
                 <a:latin typeface="Arial"/>
               </a:defRPr>
             </a:pPr>
             <a:r>
-              <a:t>• Context: Remote high-stakes evaluations (exams, interviews) rely on standard 2D webcams for candidate authentication.</a:t>
-            </a:r>
-            <a:br/>
-            <a:r>
-              <a:t>• Complication: Traditional facial recognition is bypassed by presentation attacks (printed photos, video replay screens) and mid-session identity swapping.</a:t>
-            </a:r>
-            <a:br/>
-            <a:r>
-              <a:t>• Resolution: SHIELD introduces a unified real-time framework integrating facial texture patterns, physiological cardiac pulse (rPPG), and active behavioral challenges.</a:t>
+              <a:t>High-stakes digital platforms (virtual examinations, remote job interviews, and enterprise attendance tracking) rely increasingly on automated 2D webcam authentication pipelines to verify candidate presence.</a:t>
+            </a:r>
+          </a:p>
+        </p:txBody>
+      </p:sp>
+      <p:sp>
+        <p:nvSpPr>
+          <p:cNvPr id="4" name="Rounded Rectangle 3"/>
+          <p:cNvSpPr/>
+          <p:nvPr/>
+        </p:nvSpPr>
+        <p:spPr>
+          <a:xfrm>
+            <a:off x="4434840" y="2377440"/>
+            <a:ext cx="3383280" cy="3657600"/>
+          </a:xfrm>
+          <a:prstGeom prst="roundRect">
+            <a:avLst/>
+          </a:prstGeom>
+          <a:solidFill>
+            <a:srgbClr val="F5F6F8"/>
+          </a:solidFill>
+          <a:ln w="12700">
+            <a:solidFill>
+              <a:srgbClr val="C8CDD7"/>
+            </a:solidFill>
+          </a:ln>
+        </p:spPr>
+        <p:style>
+          <a:lnRef idx="1">
+            <a:schemeClr val="accent1"/>
+          </a:lnRef>
+          <a:fillRef idx="3">
+            <a:schemeClr val="accent1"/>
+          </a:fillRef>
+          <a:effectRef idx="2">
+            <a:schemeClr val="accent1"/>
+          </a:effectRef>
+          <a:fontRef idx="minor">
+            <a:schemeClr val="lt1"/>
+          </a:fontRef>
+        </p:style>
+        <p:txBody>
+          <a:bodyPr rtlCol="0" anchor="ctr" wrap="square" lIns="182880" tIns="228600" rIns="182880" bIns="182880"/>
+          <a:lstStyle/>
+          <a:p>
+            <a:pPr algn="ctr">
+              <a:defRPr sz="1100" b="1">
+                <a:solidFill>
+                  <a:srgbClr val="78828C"/>
+                </a:solidFill>
+                <a:latin typeface="Arial"/>
+              </a:defRPr>
+            </a:pPr>
+            <a:r>
+              <a:t>COMPLICATION</a:t>
+            </a:r>
+          </a:p>
+          <a:p>
+            <a:pPr>
+              <a:spcBef>
+                <a:spcPts val="400"/>
+              </a:spcBef>
+              <a:spcAft>
+                <a:spcPts val="1000"/>
+              </a:spcAft>
+              <a:defRPr sz="1500" b="1">
+                <a:solidFill>
+                  <a:srgbClr val="00205B"/>
+                </a:solidFill>
+                <a:latin typeface="Georgia"/>
+              </a:defRPr>
+            </a:pPr>
+            <a:r>
+              <a:t>Vulnerability to Spoof Attacks</a:t>
+            </a:r>
+          </a:p>
+          <a:p>
+            <a:pPr>
+              <a:spcBef>
+                <a:spcPts val="400"/>
+              </a:spcBef>
+              <a:defRPr sz="1100">
+                <a:solidFill>
+                  <a:srgbClr val="212529"/>
+                </a:solidFill>
+                <a:latin typeface="Arial"/>
+              </a:defRPr>
+            </a:pPr>
+            <a:r>
+              <a:t>Traditional facial recognition algorithms are highly vulnerable to presentation attacks—such as printed photos and digital replay screens—and mid-session identity swapping (tag-team authentication fraud).</a:t>
+            </a:r>
+          </a:p>
+        </p:txBody>
+      </p:sp>
+      <p:sp>
+        <p:nvSpPr>
+          <p:cNvPr id="5" name="Rounded Rectangle 4"/>
+          <p:cNvSpPr/>
+          <p:nvPr/>
+        </p:nvSpPr>
+        <p:spPr>
+          <a:xfrm>
+            <a:off x="8183880" y="2377440"/>
+            <a:ext cx="3383280" cy="3657600"/>
+          </a:xfrm>
+          <a:prstGeom prst="roundRect">
+            <a:avLst/>
+          </a:prstGeom>
+          <a:solidFill>
+            <a:srgbClr val="F5F6F8"/>
+          </a:solidFill>
+          <a:ln w="12700">
+            <a:solidFill>
+              <a:srgbClr val="C8CDD7"/>
+            </a:solidFill>
+          </a:ln>
+        </p:spPr>
+        <p:style>
+          <a:lnRef idx="1">
+            <a:schemeClr val="accent1"/>
+          </a:lnRef>
+          <a:fillRef idx="3">
+            <a:schemeClr val="accent1"/>
+          </a:fillRef>
+          <a:effectRef idx="2">
+            <a:schemeClr val="accent1"/>
+          </a:effectRef>
+          <a:fontRef idx="minor">
+            <a:schemeClr val="lt1"/>
+          </a:fontRef>
+        </p:style>
+        <p:txBody>
+          <a:bodyPr rtlCol="0" anchor="ctr" wrap="square" lIns="182880" tIns="228600" rIns="182880" bIns="182880"/>
+          <a:lstStyle/>
+          <a:p>
+            <a:pPr algn="ctr">
+              <a:defRPr sz="1100" b="1">
+                <a:solidFill>
+                  <a:srgbClr val="78828C"/>
+                </a:solidFill>
+                <a:latin typeface="Arial"/>
+              </a:defRPr>
+            </a:pPr>
+            <a:r>
+              <a:t>RESOLUTION</a:t>
+            </a:r>
+          </a:p>
+          <a:p>
+            <a:pPr>
+              <a:spcBef>
+                <a:spcPts val="400"/>
+              </a:spcBef>
+              <a:spcAft>
+                <a:spcPts val="1000"/>
+              </a:spcAft>
+              <a:defRPr sz="1500" b="1">
+                <a:solidFill>
+                  <a:srgbClr val="00205B"/>
+                </a:solidFill>
+                <a:latin typeface="Georgia"/>
+              </a:defRPr>
+            </a:pPr>
+            <a:r>
+              <a:t>Multi-Layered Biometric Fusion</a:t>
+            </a:r>
+          </a:p>
+          <a:p>
+            <a:pPr>
+              <a:spcBef>
+                <a:spcPts val="400"/>
+              </a:spcBef>
+              <a:defRPr sz="1100">
+                <a:solidFill>
+                  <a:srgbClr val="212529"/>
+                </a:solidFill>
+                <a:latin typeface="Arial"/>
+              </a:defRPr>
+            </a:pPr>
+            <a:r>
+              <a:t>SHIELD integrates passive spatial texture analysis, biological rPPG heart rate tracking, and active challenge directives into a unified, low-latency fusion framework processing video under &lt;100ms.</a:t>
             </a:r>
           </a:p>
         </p:txBody>
@@ -3331,7 +3470,7 @@
     <p:bg>
       <p:bgPr>
         <a:solidFill>
-          <a:srgbClr val="0A0A10"/>
+          <a:srgbClr val="FFFFFF"/>
         </a:solidFill>
         <a:effectLst/>
       </p:bgPr>
@@ -3351,8 +3490,8 @@
         </p:nvSpPr>
         <p:spPr>
           <a:xfrm>
-            <a:off x="685800" y="320040"/>
-            <a:ext cx="10817352" cy="914400"/>
+            <a:off x="685800" y="365760"/>
+            <a:ext cx="10817352" cy="822960"/>
           </a:xfrm>
           <a:prstGeom prst="rect">
             <a:avLst/>
@@ -3366,15 +3505,15 @@
           <a:lstStyle/>
           <a:p>
             <a:pPr>
-              <a:defRPr sz="2200" b="1">
-                <a:solidFill>
-                  <a:srgbClr val="8A2BE2"/>
-                </a:solidFill>
-                <a:latin typeface="Arial"/>
-              </a:defRPr>
-            </a:pPr>
-            <a:r>
-              <a:t>Objectives: Establishing a Standard-Compliant, Low-Latency Defense for Remote Identity Verification</a:t>
+              <a:defRPr sz="2000" b="1">
+                <a:solidFill>
+                  <a:srgbClr val="00205B"/>
+                </a:solidFill>
+                <a:latin typeface="Georgia"/>
+              </a:defRPr>
+            </a:pPr>
+            <a:r>
+              <a:t>Objectives: Building an Edge-Deployable, ISO-Compliant Biometric Defense</a:t>
             </a:r>
           </a:p>
         </p:txBody>
@@ -3407,9 +3546,9 @@
               </a:spcAft>
               <a:defRPr sz="1800" b="1">
                 <a:solidFill>
-                  <a:srgbClr val="8A2BE2"/>
-                </a:solidFill>
-                <a:latin typeface="Arial"/>
+                  <a:srgbClr val="00205B"/>
+                </a:solidFill>
+                <a:latin typeface="Georgia"/>
               </a:defRPr>
             </a:pPr>
             <a:r>
@@ -3423,7 +3562,7 @@
               </a:spcAft>
               <a:defRPr sz="1300">
                 <a:solidFill>
-                  <a:srgbClr val="C8C8DC"/>
+                  <a:srgbClr val="212529"/>
                 </a:solidFill>
                 <a:latin typeface="Arial"/>
               </a:defRPr>
@@ -3439,7 +3578,7 @@
               </a:spcAft>
               <a:defRPr sz="1300">
                 <a:solidFill>
-                  <a:srgbClr val="C8C8DC"/>
+                  <a:srgbClr val="212529"/>
                 </a:solidFill>
                 <a:latin typeface="Arial"/>
               </a:defRPr>
@@ -3455,7 +3594,7 @@
               </a:spcAft>
               <a:defRPr sz="1300">
                 <a:solidFill>
-                  <a:srgbClr val="C8C8DC"/>
+                  <a:srgbClr val="212529"/>
                 </a:solidFill>
                 <a:latin typeface="Arial"/>
               </a:defRPr>
@@ -3471,7 +3610,7 @@
               </a:spcAft>
               <a:defRPr sz="1300">
                 <a:solidFill>
-                  <a:srgbClr val="C8C8DC"/>
+                  <a:srgbClr val="212529"/>
                 </a:solidFill>
                 <a:latin typeface="Arial"/>
               </a:defRPr>
@@ -3510,9 +3649,9 @@
               </a:spcAft>
               <a:defRPr sz="1800" b="1">
                 <a:solidFill>
-                  <a:srgbClr val="FFFFFF"/>
-                </a:solidFill>
-                <a:latin typeface="Arial"/>
+                  <a:srgbClr val="00205B"/>
+                </a:solidFill>
+                <a:latin typeface="Georgia"/>
               </a:defRPr>
             </a:pPr>
             <a:r>
@@ -3526,7 +3665,7 @@
               </a:spcBef>
               <a:defRPr sz="1400" b="1">
                 <a:solidFill>
-                  <a:srgbClr val="8A2BE2"/>
+                  <a:srgbClr val="78828C"/>
                 </a:solidFill>
                 <a:latin typeface="Arial"/>
               </a:defRPr>
@@ -3542,7 +3681,7 @@
               </a:spcAft>
               <a:defRPr sz="1200">
                 <a:solidFill>
-                  <a:srgbClr val="C8C8DC"/>
+                  <a:srgbClr val="212529"/>
                 </a:solidFill>
                 <a:latin typeface="Arial"/>
               </a:defRPr>
@@ -3558,7 +3697,7 @@
               </a:spcBef>
               <a:defRPr sz="1400" b="1">
                 <a:solidFill>
-                  <a:srgbClr val="8A2BE2"/>
+                  <a:srgbClr val="78828C"/>
                 </a:solidFill>
                 <a:latin typeface="Arial"/>
               </a:defRPr>
@@ -3574,7 +3713,7 @@
               </a:spcAft>
               <a:defRPr sz="1200">
                 <a:solidFill>
-                  <a:srgbClr val="C8C8DC"/>
+                  <a:srgbClr val="212529"/>
                 </a:solidFill>
                 <a:latin typeface="Arial"/>
               </a:defRPr>
@@ -3590,7 +3729,7 @@
               </a:spcBef>
               <a:defRPr sz="1400" b="1">
                 <a:solidFill>
-                  <a:srgbClr val="8A2BE2"/>
+                  <a:srgbClr val="78828C"/>
                 </a:solidFill>
                 <a:latin typeface="Arial"/>
               </a:defRPr>
@@ -3606,7 +3745,7 @@
               </a:spcAft>
               <a:defRPr sz="1200">
                 <a:solidFill>
-                  <a:srgbClr val="C8C8DC"/>
+                  <a:srgbClr val="212529"/>
                 </a:solidFill>
                 <a:latin typeface="Arial"/>
               </a:defRPr>
@@ -3631,7 +3770,7 @@
     <p:bg>
       <p:bgPr>
         <a:solidFill>
-          <a:srgbClr val="0A0A10"/>
+          <a:srgbClr val="FFFFFF"/>
         </a:solidFill>
         <a:effectLst/>
       </p:bgPr>
@@ -3651,8 +3790,8 @@
         </p:nvSpPr>
         <p:spPr>
           <a:xfrm>
-            <a:off x="685800" y="320040"/>
-            <a:ext cx="10817352" cy="914400"/>
+            <a:off x="685800" y="365760"/>
+            <a:ext cx="10817352" cy="822960"/>
           </a:xfrm>
           <a:prstGeom prst="rect">
             <a:avLst/>
@@ -3666,11 +3805,11 @@
           <a:lstStyle/>
           <a:p>
             <a:pPr>
-              <a:defRPr sz="2200" b="1">
-                <a:solidFill>
-                  <a:srgbClr val="8A2BE2"/>
-                </a:solidFill>
-                <a:latin typeface="Arial"/>
+              <a:defRPr sz="2000" b="1">
+                <a:solidFill>
+                  <a:srgbClr val="00205B"/>
+                </a:solidFill>
+                <a:latin typeface="Georgia"/>
               </a:defRPr>
             </a:pPr>
             <a:r>
@@ -3707,9 +3846,9 @@
               </a:spcAft>
               <a:defRPr sz="1800" b="1">
                 <a:solidFill>
-                  <a:srgbClr val="8A2BE2"/>
-                </a:solidFill>
-                <a:latin typeface="Arial"/>
+                  <a:srgbClr val="00205B"/>
+                </a:solidFill>
+                <a:latin typeface="Georgia"/>
               </a:defRPr>
             </a:pPr>
             <a:r>
@@ -3723,7 +3862,7 @@
               </a:spcAft>
               <a:defRPr sz="1200">
                 <a:solidFill>
-                  <a:srgbClr val="C8C8DC"/>
+                  <a:srgbClr val="212529"/>
                 </a:solidFill>
                 <a:latin typeface="Arial"/>
               </a:defRPr>
@@ -3739,7 +3878,7 @@
               </a:spcAft>
               <a:defRPr sz="1200">
                 <a:solidFill>
-                  <a:srgbClr val="C8C8DC"/>
+                  <a:srgbClr val="212529"/>
                 </a:solidFill>
                 <a:latin typeface="Arial"/>
               </a:defRPr>
@@ -3755,7 +3894,7 @@
               </a:spcAft>
               <a:defRPr sz="1200">
                 <a:solidFill>
-                  <a:srgbClr val="C8C8DC"/>
+                  <a:srgbClr val="212529"/>
                 </a:solidFill>
                 <a:latin typeface="Arial"/>
               </a:defRPr>
@@ -3771,7 +3910,7 @@
               </a:spcAft>
               <a:defRPr sz="1200">
                 <a:solidFill>
-                  <a:srgbClr val="C8C8DC"/>
+                  <a:srgbClr val="212529"/>
                 </a:solidFill>
                 <a:latin typeface="Arial"/>
               </a:defRPr>
@@ -3797,11 +3936,11 @@
             <a:avLst/>
           </a:prstGeom>
           <a:solidFill>
-            <a:srgbClr val="F8BBD0"/>
+            <a:srgbClr val="F5F6F8"/>
           </a:solidFill>
           <a:ln w="12700">
             <a:solidFill>
-              <a:srgbClr val="3C325A"/>
+              <a:srgbClr val="C8CDD7"/>
             </a:solidFill>
           </a:ln>
         </p:spPr>
@@ -3826,7 +3965,7 @@
             <a:pPr algn="ctr">
               <a:defRPr sz="950" b="1">
                 <a:solidFill>
-                  <a:srgbClr val="282828"/>
+                  <a:srgbClr val="00205B"/>
                 </a:solidFill>
                 <a:latin typeface="Arial"/>
               </a:defRPr>
@@ -3853,7 +3992,7 @@
           </a:prstGeom>
           <a:ln w="15240">
             <a:solidFill>
-              <a:srgbClr val="3C325A"/>
+              <a:srgbClr val="8C96A0"/>
             </a:solidFill>
           </a:ln>
         </p:spPr>
@@ -3887,11 +4026,11 @@
             <a:avLst/>
           </a:prstGeom>
           <a:solidFill>
-            <a:srgbClr val="FFE0B2"/>
+            <a:srgbClr val="F5F6F8"/>
           </a:solidFill>
           <a:ln w="12700">
             <a:solidFill>
-              <a:srgbClr val="3C325A"/>
+              <a:srgbClr val="C8CDD7"/>
             </a:solidFill>
           </a:ln>
         </p:spPr>
@@ -3916,7 +4055,7 @@
             <a:pPr algn="ctr">
               <a:defRPr sz="950" b="1">
                 <a:solidFill>
-                  <a:srgbClr val="282828"/>
+                  <a:srgbClr val="00205B"/>
                 </a:solidFill>
                 <a:latin typeface="Arial"/>
               </a:defRPr>
@@ -3943,7 +4082,7 @@
           </a:prstGeom>
           <a:ln w="15240">
             <a:solidFill>
-              <a:srgbClr val="3C325A"/>
+              <a:srgbClr val="8C96A0"/>
             </a:solidFill>
           </a:ln>
         </p:spPr>
@@ -3977,11 +4116,11 @@
             <a:avLst/>
           </a:prstGeom>
           <a:solidFill>
-            <a:srgbClr val="FFF9C4"/>
+            <a:srgbClr val="F5F6F8"/>
           </a:solidFill>
           <a:ln w="12700">
             <a:solidFill>
-              <a:srgbClr val="3C325A"/>
+              <a:srgbClr val="C8CDD7"/>
             </a:solidFill>
           </a:ln>
         </p:spPr>
@@ -4006,7 +4145,7 @@
             <a:pPr algn="ctr">
               <a:defRPr sz="950" b="1">
                 <a:solidFill>
-                  <a:srgbClr val="282828"/>
+                  <a:srgbClr val="00205B"/>
                 </a:solidFill>
                 <a:latin typeface="Arial"/>
               </a:defRPr>
@@ -4031,10 +4170,12 @@
           <a:prstGeom prst="roundRect">
             <a:avLst/>
           </a:prstGeom>
-          <a:noFill/>
+          <a:solidFill>
+            <a:srgbClr val="F5F6F8"/>
+          </a:solidFill>
           <a:ln w="19050">
             <a:solidFill>
-              <a:srgbClr val="3C325A"/>
+              <a:srgbClr val="C8CDD7"/>
             </a:solidFill>
           </a:ln>
         </p:spPr>
@@ -4085,7 +4226,7 @@
             <a:pPr>
               <a:defRPr sz="1400" b="1">
                 <a:solidFill>
-                  <a:srgbClr val="8A2BE2"/>
+                  <a:srgbClr val="00205B"/>
                 </a:solidFill>
                 <a:latin typeface="Arial"/>
               </a:defRPr>
@@ -4111,11 +4252,11 @@
             <a:avLst/>
           </a:prstGeom>
           <a:solidFill>
-            <a:srgbClr val="E0F2F1"/>
+            <a:srgbClr val="003366"/>
           </a:solidFill>
           <a:ln w="12700">
             <a:solidFill>
-              <a:srgbClr val="3C325A"/>
+              <a:srgbClr val="C8CDD7"/>
             </a:solidFill>
           </a:ln>
         </p:spPr>
@@ -4140,7 +4281,7 @@
             <a:pPr algn="ctr">
               <a:defRPr sz="950" b="1">
                 <a:solidFill>
-                  <a:srgbClr val="282828"/>
+                  <a:srgbClr val="FFFFFF"/>
                 </a:solidFill>
                 <a:latin typeface="Arial"/>
               </a:defRPr>
@@ -4166,11 +4307,11 @@
             <a:avLst/>
           </a:prstGeom>
           <a:solidFill>
-            <a:srgbClr val="E0F2F1"/>
+            <a:srgbClr val="003366"/>
           </a:solidFill>
           <a:ln w="12700">
             <a:solidFill>
-              <a:srgbClr val="3C325A"/>
+              <a:srgbClr val="C8CDD7"/>
             </a:solidFill>
           </a:ln>
         </p:spPr>
@@ -4195,7 +4336,7 @@
             <a:pPr algn="ctr">
               <a:defRPr sz="950" b="1">
                 <a:solidFill>
-                  <a:srgbClr val="282828"/>
+                  <a:srgbClr val="FFFFFF"/>
                 </a:solidFill>
                 <a:latin typeface="Arial"/>
               </a:defRPr>
@@ -4221,11 +4362,11 @@
             <a:avLst/>
           </a:prstGeom>
           <a:solidFill>
-            <a:srgbClr val="E0F2F1"/>
+            <a:srgbClr val="003366"/>
           </a:solidFill>
           <a:ln w="12700">
             <a:solidFill>
-              <a:srgbClr val="3C325A"/>
+              <a:srgbClr val="C8CDD7"/>
             </a:solidFill>
           </a:ln>
         </p:spPr>
@@ -4250,7 +4391,7 @@
             <a:pPr algn="ctr">
               <a:defRPr sz="950" b="1">
                 <a:solidFill>
-                  <a:srgbClr val="282828"/>
+                  <a:srgbClr val="FFFFFF"/>
                 </a:solidFill>
                 <a:latin typeface="Arial"/>
               </a:defRPr>
@@ -4277,7 +4418,7 @@
           </a:prstGeom>
           <a:ln w="15240">
             <a:solidFill>
-              <a:srgbClr val="3C325A"/>
+              <a:srgbClr val="8C96A0"/>
             </a:solidFill>
           </a:ln>
         </p:spPr>
@@ -4312,7 +4453,7 @@
           </a:prstGeom>
           <a:ln w="15240">
             <a:solidFill>
-              <a:srgbClr val="3C325A"/>
+              <a:srgbClr val="8C96A0"/>
             </a:solidFill>
           </a:ln>
         </p:spPr>
@@ -4347,7 +4488,7 @@
           </a:prstGeom>
           <a:ln w="15240">
             <a:solidFill>
-              <a:srgbClr val="3C325A"/>
+              <a:srgbClr val="8C96A0"/>
             </a:solidFill>
           </a:ln>
         </p:spPr>
@@ -4381,11 +4522,11 @@
             <a:avLst/>
           </a:prstGeom>
           <a:solidFill>
-            <a:srgbClr val="FFF9C4"/>
+            <a:srgbClr val="F5F6F8"/>
           </a:solidFill>
           <a:ln w="12700">
             <a:solidFill>
-              <a:srgbClr val="3C325A"/>
+              <a:srgbClr val="C8CDD7"/>
             </a:solidFill>
           </a:ln>
         </p:spPr>
@@ -4410,7 +4551,7 @@
             <a:pPr algn="ctr">
               <a:defRPr sz="950" b="1">
                 <a:solidFill>
-                  <a:srgbClr val="282828"/>
+                  <a:srgbClr val="00205B"/>
                 </a:solidFill>
                 <a:latin typeface="Arial"/>
               </a:defRPr>
@@ -4437,7 +4578,7 @@
           </a:prstGeom>
           <a:ln w="15240">
             <a:solidFill>
-              <a:srgbClr val="3C325A"/>
+              <a:srgbClr val="8C96A0"/>
             </a:solidFill>
           </a:ln>
         </p:spPr>
@@ -4472,7 +4613,7 @@
           </a:prstGeom>
           <a:ln w="15240">
             <a:solidFill>
-              <a:srgbClr val="3C325A"/>
+              <a:srgbClr val="8C96A0"/>
             </a:solidFill>
           </a:ln>
         </p:spPr>
@@ -4507,7 +4648,7 @@
           </a:prstGeom>
           <a:ln w="15240">
             <a:solidFill>
-              <a:srgbClr val="3C325A"/>
+              <a:srgbClr val="8C96A0"/>
             </a:solidFill>
           </a:ln>
         </p:spPr>
@@ -4541,11 +4682,11 @@
             <a:avLst/>
           </a:prstGeom>
           <a:solidFill>
-            <a:srgbClr val="E1BEE7"/>
+            <a:srgbClr val="F5F6F8"/>
           </a:solidFill>
           <a:ln w="12700">
             <a:solidFill>
-              <a:srgbClr val="3C325A"/>
+              <a:srgbClr val="C8CDD7"/>
             </a:solidFill>
           </a:ln>
         </p:spPr>
@@ -4570,7 +4711,7 @@
             <a:pPr algn="ctr">
               <a:defRPr sz="950" b="1">
                 <a:solidFill>
-                  <a:srgbClr val="282828"/>
+                  <a:srgbClr val="00205B"/>
                 </a:solidFill>
                 <a:latin typeface="Arial"/>
               </a:defRPr>
@@ -4597,7 +4738,7 @@
           </a:prstGeom>
           <a:ln w="15240">
             <a:solidFill>
-              <a:srgbClr val="3C325A"/>
+              <a:srgbClr val="8C96A0"/>
             </a:solidFill>
           </a:ln>
         </p:spPr>
@@ -4631,11 +4772,11 @@
             <a:avLst/>
           </a:prstGeom>
           <a:solidFill>
-            <a:srgbClr val="C8E6C9"/>
+            <a:srgbClr val="00205B"/>
           </a:solidFill>
           <a:ln w="12700">
             <a:solidFill>
-              <a:srgbClr val="3C325A"/>
+              <a:srgbClr val="C8CDD7"/>
             </a:solidFill>
           </a:ln>
         </p:spPr>
@@ -4660,7 +4801,7 @@
             <a:pPr algn="ctr">
               <a:defRPr sz="950" b="1">
                 <a:solidFill>
-                  <a:srgbClr val="282828"/>
+                  <a:srgbClr val="FFFFFF"/>
                 </a:solidFill>
                 <a:latin typeface="Arial"/>
               </a:defRPr>
@@ -4685,7 +4826,7 @@
     <p:bg>
       <p:bgPr>
         <a:solidFill>
-          <a:srgbClr val="0A0A10"/>
+          <a:srgbClr val="FFFFFF"/>
         </a:solidFill>
         <a:effectLst/>
       </p:bgPr>
@@ -4705,8 +4846,8 @@
         </p:nvSpPr>
         <p:spPr>
           <a:xfrm>
-            <a:off x="685800" y="320040"/>
-            <a:ext cx="10817352" cy="914400"/>
+            <a:off x="685800" y="365760"/>
+            <a:ext cx="10817352" cy="822960"/>
           </a:xfrm>
           <a:prstGeom prst="rect">
             <a:avLst/>
@@ -4720,11 +4861,11 @@
           <a:lstStyle/>
           <a:p>
             <a:pPr>
-              <a:defRPr sz="2200" b="1">
-                <a:solidFill>
-                  <a:srgbClr val="8A2BE2"/>
-                </a:solidFill>
-                <a:latin typeface="Arial"/>
+              <a:defRPr sz="2000" b="1">
+                <a:solidFill>
+                  <a:srgbClr val="00205B"/>
+                </a:solidFill>
+                <a:latin typeface="Georgia"/>
               </a:defRPr>
             </a:pPr>
             <a:r>
@@ -4748,11 +4889,11 @@
             <a:avLst/>
           </a:prstGeom>
           <a:solidFill>
-            <a:srgbClr val="181622"/>
+            <a:srgbClr val="F5F6F8"/>
           </a:solidFill>
           <a:ln w="12700">
             <a:solidFill>
-              <a:srgbClr val="3C325A"/>
+              <a:srgbClr val="C8CDD7"/>
             </a:solidFill>
           </a:ln>
         </p:spPr>
@@ -4777,9 +4918,9 @@
             <a:pPr algn="ctr">
               <a:defRPr sz="1500" b="1">
                 <a:solidFill>
-                  <a:srgbClr val="FFFFFF"/>
-                </a:solidFill>
-                <a:latin typeface="Arial"/>
+                  <a:srgbClr val="00205B"/>
+                </a:solidFill>
+                <a:latin typeface="Georgia"/>
               </a:defRPr>
             </a:pPr>
             <a:r>
@@ -4793,7 +4934,7 @@
               </a:spcAft>
               <a:defRPr sz="900" b="1">
                 <a:solidFill>
-                  <a:srgbClr val="8A2BE2"/>
+                  <a:srgbClr val="78828C"/>
                 </a:solidFill>
                 <a:latin typeface="Arial"/>
               </a:defRPr>
@@ -4809,7 +4950,7 @@
               </a:spcBef>
               <a:defRPr sz="1150">
                 <a:solidFill>
-                  <a:srgbClr val="C8C8DC"/>
+                  <a:srgbClr val="212529"/>
                 </a:solidFill>
                 <a:latin typeface="Arial"/>
               </a:defRPr>
@@ -4835,11 +4976,11 @@
             <a:avLst/>
           </a:prstGeom>
           <a:solidFill>
-            <a:srgbClr val="181622"/>
+            <a:srgbClr val="F5F6F8"/>
           </a:solidFill>
           <a:ln w="12700">
             <a:solidFill>
-              <a:srgbClr val="3C325A"/>
+              <a:srgbClr val="C8CDD7"/>
             </a:solidFill>
           </a:ln>
         </p:spPr>
@@ -4864,9 +5005,9 @@
             <a:pPr algn="ctr">
               <a:defRPr sz="1500" b="1">
                 <a:solidFill>
-                  <a:srgbClr val="FFFFFF"/>
-                </a:solidFill>
-                <a:latin typeface="Arial"/>
+                  <a:srgbClr val="00205B"/>
+                </a:solidFill>
+                <a:latin typeface="Georgia"/>
               </a:defRPr>
             </a:pPr>
             <a:r>
@@ -4880,7 +5021,7 @@
               </a:spcAft>
               <a:defRPr sz="900" b="1">
                 <a:solidFill>
-                  <a:srgbClr val="8A2BE2"/>
+                  <a:srgbClr val="78828C"/>
                 </a:solidFill>
                 <a:latin typeface="Arial"/>
               </a:defRPr>
@@ -4896,7 +5037,7 @@
               </a:spcBef>
               <a:defRPr sz="1150">
                 <a:solidFill>
-                  <a:srgbClr val="C8C8DC"/>
+                  <a:srgbClr val="212529"/>
                 </a:solidFill>
                 <a:latin typeface="Arial"/>
               </a:defRPr>
@@ -4922,11 +5063,11 @@
             <a:avLst/>
           </a:prstGeom>
           <a:solidFill>
-            <a:srgbClr val="181622"/>
+            <a:srgbClr val="F5F6F8"/>
           </a:solidFill>
           <a:ln w="12700">
             <a:solidFill>
-              <a:srgbClr val="3C325A"/>
+              <a:srgbClr val="C8CDD7"/>
             </a:solidFill>
           </a:ln>
         </p:spPr>
@@ -4951,9 +5092,9 @@
             <a:pPr algn="ctr">
               <a:defRPr sz="1500" b="1">
                 <a:solidFill>
-                  <a:srgbClr val="FFFFFF"/>
-                </a:solidFill>
-                <a:latin typeface="Arial"/>
+                  <a:srgbClr val="00205B"/>
+                </a:solidFill>
+                <a:latin typeface="Georgia"/>
               </a:defRPr>
             </a:pPr>
             <a:r>
@@ -4967,7 +5108,7 @@
               </a:spcAft>
               <a:defRPr sz="900" b="1">
                 <a:solidFill>
-                  <a:srgbClr val="8A2BE2"/>
+                  <a:srgbClr val="78828C"/>
                 </a:solidFill>
                 <a:latin typeface="Arial"/>
               </a:defRPr>
@@ -4983,7 +5124,7 @@
               </a:spcBef>
               <a:defRPr sz="1150">
                 <a:solidFill>
-                  <a:srgbClr val="C8C8DC"/>
+                  <a:srgbClr val="212529"/>
                 </a:solidFill>
                 <a:latin typeface="Arial"/>
               </a:defRPr>
@@ -5009,11 +5150,11 @@
             <a:avLst/>
           </a:prstGeom>
           <a:solidFill>
-            <a:srgbClr val="181622"/>
+            <a:srgbClr val="F5F6F8"/>
           </a:solidFill>
           <a:ln w="12700">
             <a:solidFill>
-              <a:srgbClr val="3C325A"/>
+              <a:srgbClr val="C8CDD7"/>
             </a:solidFill>
           </a:ln>
         </p:spPr>
@@ -5038,9 +5179,9 @@
             <a:pPr algn="ctr">
               <a:defRPr sz="1500" b="1">
                 <a:solidFill>
-                  <a:srgbClr val="FFFFFF"/>
-                </a:solidFill>
-                <a:latin typeface="Arial"/>
+                  <a:srgbClr val="00205B"/>
+                </a:solidFill>
+                <a:latin typeface="Georgia"/>
               </a:defRPr>
             </a:pPr>
             <a:r>
@@ -5054,7 +5195,7 @@
               </a:spcAft>
               <a:defRPr sz="900" b="1">
                 <a:solidFill>
-                  <a:srgbClr val="8A2BE2"/>
+                  <a:srgbClr val="78828C"/>
                 </a:solidFill>
                 <a:latin typeface="Arial"/>
               </a:defRPr>
@@ -5070,7 +5211,7 @@
               </a:spcBef>
               <a:defRPr sz="1150">
                 <a:solidFill>
-                  <a:srgbClr val="C8C8DC"/>
+                  <a:srgbClr val="212529"/>
                 </a:solidFill>
                 <a:latin typeface="Arial"/>
               </a:defRPr>
@@ -5092,6 +5233,14 @@
 <file path=ppt/slides/slide5.xml><?xml version="1.0" encoding="utf-8"?>
 <p:sld xmlns:a="http://schemas.openxmlformats.org/drawingml/2006/main" xmlns:p="http://schemas.openxmlformats.org/presentationml/2006/main" xmlns:r="http://schemas.openxmlformats.org/officeDocument/2006/relationships">
   <p:cSld>
+    <p:bg>
+      <p:bgPr>
+        <a:solidFill>
+          <a:srgbClr val="FFFFFF"/>
+        </a:solidFill>
+        <a:effectLst/>
+      </p:bgPr>
+    </p:bg>
     <p:spTree>
       <p:nvGrpSpPr>
         <p:cNvPr id="1" name=""/>
@@ -5099,40 +5248,16 @@
         <p:nvPr/>
       </p:nvGrpSpPr>
       <p:grpSpPr/>
-      <p:pic>
-        <p:nvPicPr>
-          <p:cNvPr id="2" name="Picture 1" descr="telemetry_visual_1783185198779.jpg"/>
-          <p:cNvPicPr>
-            <a:picLocks noChangeAspect="1"/>
-          </p:cNvPicPr>
+      <p:sp>
+        <p:nvSpPr>
+          <p:cNvPr id="2" name="TextBox 1"/>
+          <p:cNvSpPr txBox="1"/>
           <p:nvPr/>
-        </p:nvPicPr>
-        <p:blipFill>
-          <a:blip r:embed="rId2"/>
-          <a:stretch>
-            <a:fillRect/>
-          </a:stretch>
-        </p:blipFill>
+        </p:nvSpPr>
         <p:spPr>
           <a:xfrm>
-            <a:off x="0" y="0"/>
-            <a:ext cx="12191695" cy="6858000"/>
-          </a:xfrm>
-          <a:prstGeom prst="rect">
-            <a:avLst/>
-          </a:prstGeom>
-        </p:spPr>
-      </p:pic>
-      <p:sp>
-        <p:nvSpPr>
-          <p:cNvPr id="3" name="TextBox 2"/>
-          <p:cNvSpPr txBox="1"/>
-          <p:nvPr/>
-        </p:nvSpPr>
-        <p:spPr>
-          <a:xfrm>
-            <a:off x="685800" y="274320"/>
-            <a:ext cx="5120640" cy="914400"/>
+            <a:off x="685800" y="365760"/>
+            <a:ext cx="10817352" cy="822960"/>
           </a:xfrm>
           <a:prstGeom prst="rect">
             <a:avLst/>
@@ -5146,11 +5271,11 @@
           <a:lstStyle/>
           <a:p>
             <a:pPr>
-              <a:defRPr sz="1900" b="1">
-                <a:solidFill>
-                  <a:srgbClr val="FFFFFF"/>
-                </a:solidFill>
-                <a:latin typeface="Arial"/>
+              <a:defRPr sz="2000" b="1">
+                <a:solidFill>
+                  <a:srgbClr val="00205B"/>
+                </a:solidFill>
+                <a:latin typeface="Georgia"/>
               </a:defRPr>
             </a:pPr>
             <a:r>
@@ -5161,15 +5286,15 @@
       </p:sp>
       <p:graphicFrame>
         <p:nvGraphicFramePr>
-          <p:cNvPr id="4" name="Table 3"/>
+          <p:cNvPr id="3" name="Table 2"/>
           <p:cNvGraphicFramePr>
             <a:graphicFrameLocks noGrp="1"/>
           </p:cNvGraphicFramePr>
           <p:nvPr/>
         </p:nvGraphicFramePr>
         <p:xfrm>
-          <a:off x="685800" y="1280160"/>
-          <a:ext cx="5120640" cy="2011680"/>
+          <a:off x="685800" y="1371600"/>
+          <a:ext cx="5120640" cy="4114800"/>
         </p:xfrm>
         <a:graphic>
           <a:graphicData uri="http://schemas.openxmlformats.org/drawingml/2006/table">
@@ -5181,7 +5306,7 @@
                 <a:gridCol w="3291840"/>
                 <a:gridCol w="1828800"/>
               </a:tblGrid>
-              <a:tr h="402336">
+              <a:tr h="822960">
                 <a:tc>
                   <a:txBody>
                     <a:bodyPr/>
@@ -5190,7 +5315,7 @@
                       <a:pPr algn="ctr">
                         <a:defRPr sz="1300" b="1">
                           <a:solidFill>
-                            <a:srgbClr val="8A2BE2"/>
+                            <a:srgbClr val="00205B"/>
                           </a:solidFill>
                           <a:latin typeface="Arial"/>
                         </a:defRPr>
@@ -5202,7 +5327,7 @@
                   </a:txBody>
                   <a:tcPr>
                     <a:solidFill>
-                      <a:srgbClr val="181622"/>
+                      <a:srgbClr val="F5F6F8"/>
                     </a:solidFill>
                   </a:tcPr>
                 </a:tc>
@@ -5214,7 +5339,7 @@
                       <a:pPr algn="ctr">
                         <a:defRPr sz="1300" b="1">
                           <a:solidFill>
-                            <a:srgbClr val="8A2BE2"/>
+                            <a:srgbClr val="00205B"/>
                           </a:solidFill>
                           <a:latin typeface="Arial"/>
                         </a:defRPr>
@@ -5226,12 +5351,12 @@
                   </a:txBody>
                   <a:tcPr>
                     <a:solidFill>
-                      <a:srgbClr val="181622"/>
+                      <a:srgbClr val="F5F6F8"/>
                     </a:solidFill>
                   </a:tcPr>
                 </a:tc>
               </a:tr>
-              <a:tr h="402336">
+              <a:tr h="822960">
                 <a:tc>
                   <a:txBody>
                     <a:bodyPr/>
@@ -5240,7 +5365,7 @@
                       <a:pPr algn="ctr">
                         <a:defRPr sz="1100">
                           <a:solidFill>
-                            <a:srgbClr val="C8C8DC"/>
+                            <a:srgbClr val="212529"/>
                           </a:solidFill>
                           <a:latin typeface="Arial"/>
                         </a:defRPr>
@@ -5252,7 +5377,7 @@
                   </a:txBody>
                   <a:tcPr>
                     <a:solidFill>
-                      <a:srgbClr val="0A0A10"/>
+                      <a:srgbClr val="F5F6F8"/>
                     </a:solidFill>
                   </a:tcPr>
                 </a:tc>
@@ -5264,7 +5389,7 @@
                       <a:pPr algn="ctr">
                         <a:defRPr sz="1100" b="1">
                           <a:solidFill>
-                            <a:srgbClr val="FFFFFF"/>
+                            <a:srgbClr val="00205B"/>
                           </a:solidFill>
                           <a:latin typeface="Arial"/>
                         </a:defRPr>
@@ -5276,12 +5401,12 @@
                   </a:txBody>
                   <a:tcPr>
                     <a:solidFill>
-                      <a:srgbClr val="0A0A10"/>
+                      <a:srgbClr val="F5F6F8"/>
                     </a:solidFill>
                   </a:tcPr>
                 </a:tc>
               </a:tr>
-              <a:tr h="402336">
+              <a:tr h="822960">
                 <a:tc>
                   <a:txBody>
                     <a:bodyPr/>
@@ -5290,7 +5415,7 @@
                       <a:pPr algn="ctr">
                         <a:defRPr sz="1100">
                           <a:solidFill>
-                            <a:srgbClr val="C8C8DC"/>
+                            <a:srgbClr val="212529"/>
                           </a:solidFill>
                           <a:latin typeface="Arial"/>
                         </a:defRPr>
@@ -5302,7 +5427,7 @@
                   </a:txBody>
                   <a:tcPr>
                     <a:solidFill>
-                      <a:srgbClr val="0A0A10"/>
+                      <a:srgbClr val="FFFFFF"/>
                     </a:solidFill>
                   </a:tcPr>
                 </a:tc>
@@ -5314,7 +5439,7 @@
                       <a:pPr algn="ctr">
                         <a:defRPr sz="1100" b="1">
                           <a:solidFill>
-                            <a:srgbClr val="FFFFFF"/>
+                            <a:srgbClr val="00205B"/>
                           </a:solidFill>
                           <a:latin typeface="Arial"/>
                         </a:defRPr>
@@ -5326,12 +5451,12 @@
                   </a:txBody>
                   <a:tcPr>
                     <a:solidFill>
-                      <a:srgbClr val="0A0A10"/>
+                      <a:srgbClr val="FFFFFF"/>
                     </a:solidFill>
                   </a:tcPr>
                 </a:tc>
               </a:tr>
-              <a:tr h="402336">
+              <a:tr h="822960">
                 <a:tc>
                   <a:txBody>
                     <a:bodyPr/>
@@ -5340,7 +5465,7 @@
                       <a:pPr algn="ctr">
                         <a:defRPr sz="1100">
                           <a:solidFill>
-                            <a:srgbClr val="C8C8DC"/>
+                            <a:srgbClr val="212529"/>
                           </a:solidFill>
                           <a:latin typeface="Arial"/>
                         </a:defRPr>
@@ -5352,7 +5477,7 @@
                   </a:txBody>
                   <a:tcPr>
                     <a:solidFill>
-                      <a:srgbClr val="0A0A10"/>
+                      <a:srgbClr val="F5F6F8"/>
                     </a:solidFill>
                   </a:tcPr>
                 </a:tc>
@@ -5364,7 +5489,7 @@
                       <a:pPr algn="ctr">
                         <a:defRPr sz="1100" b="1">
                           <a:solidFill>
-                            <a:srgbClr val="FFFFFF"/>
+                            <a:srgbClr val="00205B"/>
                           </a:solidFill>
                           <a:latin typeface="Arial"/>
                         </a:defRPr>
@@ -5376,12 +5501,12 @@
                   </a:txBody>
                   <a:tcPr>
                     <a:solidFill>
-                      <a:srgbClr val="0A0A10"/>
+                      <a:srgbClr val="F5F6F8"/>
                     </a:solidFill>
                   </a:tcPr>
                 </a:tc>
               </a:tr>
-              <a:tr h="402336">
+              <a:tr h="822960">
                 <a:tc>
                   <a:txBody>
                     <a:bodyPr/>
@@ -5390,7 +5515,7 @@
                       <a:pPr algn="ctr">
                         <a:defRPr sz="1100">
                           <a:solidFill>
-                            <a:srgbClr val="C8C8DC"/>
+                            <a:srgbClr val="212529"/>
                           </a:solidFill>
                           <a:latin typeface="Arial"/>
                         </a:defRPr>
@@ -5402,7 +5527,7 @@
                   </a:txBody>
                   <a:tcPr>
                     <a:solidFill>
-                      <a:srgbClr val="0A0A10"/>
+                      <a:srgbClr val="FFFFFF"/>
                     </a:solidFill>
                   </a:tcPr>
                 </a:tc>
@@ -5414,7 +5539,7 @@
                       <a:pPr algn="ctr">
                         <a:defRPr sz="1100" b="1">
                           <a:solidFill>
-                            <a:srgbClr val="FFFFFF"/>
+                            <a:srgbClr val="00205B"/>
                           </a:solidFill>
                           <a:latin typeface="Arial"/>
                         </a:defRPr>
@@ -5426,7 +5551,7 @@
                   </a:txBody>
                   <a:tcPr>
                     <a:solidFill>
-                      <a:srgbClr val="0A0A10"/>
+                      <a:srgbClr val="FFFFFF"/>
                     </a:solidFill>
                   </a:tcPr>
                 </a:tc>
@@ -5437,14 +5562,14 @@
       </p:graphicFrame>
       <p:sp>
         <p:nvSpPr>
-          <p:cNvPr id="5" name="TextBox 4"/>
+          <p:cNvPr id="4" name="TextBox 3"/>
           <p:cNvSpPr txBox="1"/>
           <p:nvPr/>
         </p:nvSpPr>
         <p:spPr>
           <a:xfrm>
-            <a:off x="685800" y="3474720"/>
-            <a:ext cx="5120640" cy="2926080"/>
+            <a:off x="6217920" y="1371600"/>
+            <a:ext cx="5212080" cy="4572000"/>
           </a:xfrm>
           <a:prstGeom prst="rect">
             <a:avLst/>
@@ -5459,13 +5584,13 @@
           <a:p>
             <a:pPr>
               <a:spcAft>
-                <a:spcPts val="600"/>
+                <a:spcPts val="1000"/>
               </a:spcAft>
-              <a:defRPr sz="1500" b="1">
-                <a:solidFill>
-                  <a:srgbClr val="8A2BE2"/>
-                </a:solidFill>
-                <a:latin typeface="Arial"/>
+              <a:defRPr sz="1800" b="1">
+                <a:solidFill>
+                  <a:srgbClr val="00205B"/>
+                </a:solidFill>
+                <a:latin typeface="Georgia"/>
               </a:defRPr>
             </a:pPr>
             <a:r>
@@ -5475,11 +5600,11 @@
           <a:p>
             <a:pPr>
               <a:spcAft>
-                <a:spcPts val="400"/>
+                <a:spcPts val="800"/>
               </a:spcAft>
-              <a:defRPr sz="1050">
-                <a:solidFill>
-                  <a:srgbClr val="C8C8DC"/>
+              <a:defRPr sz="1200">
+                <a:solidFill>
+                  <a:srgbClr val="212529"/>
                 </a:solidFill>
                 <a:latin typeface="Arial"/>
               </a:defRPr>
@@ -5491,11 +5616,11 @@
           <a:p>
             <a:pPr>
               <a:spcAft>
-                <a:spcPts val="400"/>
+                <a:spcPts val="800"/>
               </a:spcAft>
-              <a:defRPr sz="1050">
-                <a:solidFill>
-                  <a:srgbClr val="C8C8DC"/>
+              <a:defRPr sz="1200">
+                <a:solidFill>
+                  <a:srgbClr val="212529"/>
                 </a:solidFill>
                 <a:latin typeface="Arial"/>
               </a:defRPr>
@@ -5507,11 +5632,11 @@
           <a:p>
             <a:pPr>
               <a:spcAft>
-                <a:spcPts val="400"/>
+                <a:spcPts val="800"/>
               </a:spcAft>
-              <a:defRPr sz="1050">
-                <a:solidFill>
-                  <a:srgbClr val="C8C8DC"/>
+              <a:defRPr sz="1200">
+                <a:solidFill>
+                  <a:srgbClr val="212529"/>
                 </a:solidFill>
                 <a:latin typeface="Arial"/>
               </a:defRPr>
@@ -5523,11 +5648,11 @@
           <a:p>
             <a:pPr>
               <a:spcAft>
-                <a:spcPts val="400"/>
+                <a:spcPts val="800"/>
               </a:spcAft>
-              <a:defRPr sz="1050">
-                <a:solidFill>
-                  <a:srgbClr val="C8C8DC"/>
+              <a:defRPr sz="1200">
+                <a:solidFill>
+                  <a:srgbClr val="212529"/>
                 </a:solidFill>
                 <a:latin typeface="Arial"/>
               </a:defRPr>
@@ -5549,6 +5674,14 @@
 <file path=ppt/slides/slide6.xml><?xml version="1.0" encoding="utf-8"?>
 <p:sld xmlns:a="http://schemas.openxmlformats.org/drawingml/2006/main" xmlns:p="http://schemas.openxmlformats.org/presentationml/2006/main" xmlns:r="http://schemas.openxmlformats.org/officeDocument/2006/relationships">
   <p:cSld>
+    <p:bg>
+      <p:bgPr>
+        <a:solidFill>
+          <a:srgbClr val="FFFFFF"/>
+        </a:solidFill>
+        <a:effectLst/>
+      </p:bgPr>
+    </p:bg>
     <p:spTree>
       <p:nvGrpSpPr>
         <p:cNvPr id="1" name=""/>
@@ -5556,40 +5689,16 @@
         <p:nvPr/>
       </p:nvGrpSpPr>
       <p:grpSpPr/>
-      <p:pic>
-        <p:nvPicPr>
-          <p:cNvPr id="2" name="Picture 1" descr="facial_mesh_visual_1783185185503.jpg"/>
-          <p:cNvPicPr>
-            <a:picLocks noChangeAspect="1"/>
-          </p:cNvPicPr>
+      <p:sp>
+        <p:nvSpPr>
+          <p:cNvPr id="2" name="TextBox 1"/>
+          <p:cNvSpPr txBox="1"/>
           <p:nvPr/>
-        </p:nvPicPr>
-        <p:blipFill>
-          <a:blip r:embed="rId2"/>
-          <a:stretch>
-            <a:fillRect/>
-          </a:stretch>
-        </p:blipFill>
+        </p:nvSpPr>
         <p:spPr>
           <a:xfrm>
-            <a:off x="0" y="0"/>
-            <a:ext cx="12191695" cy="6858000"/>
-          </a:xfrm>
-          <a:prstGeom prst="rect">
-            <a:avLst/>
-          </a:prstGeom>
-        </p:spPr>
-      </p:pic>
-      <p:sp>
-        <p:nvSpPr>
-          <p:cNvPr id="3" name="TextBox 2"/>
-          <p:cNvSpPr txBox="1"/>
-          <p:nvPr/>
-        </p:nvSpPr>
-        <p:spPr>
-          <a:xfrm>
-            <a:off x="685800" y="274320"/>
-            <a:ext cx="5120640" cy="914400"/>
+            <a:off x="685800" y="365760"/>
+            <a:ext cx="10817352" cy="822960"/>
           </a:xfrm>
           <a:prstGeom prst="rect">
             <a:avLst/>
@@ -5603,29 +5712,29 @@
           <a:lstStyle/>
           <a:p>
             <a:pPr>
-              <a:defRPr sz="1900" b="1">
-                <a:solidFill>
-                  <a:srgbClr val="FFFFFF"/>
-                </a:solidFill>
-                <a:latin typeface="Arial"/>
-              </a:defRPr>
-            </a:pPr>
-            <a:r>
-              <a:t>Novelty: Scale-Invariant Identity Landmark Trajectories Prevent Mid-Session Swapping</a:t>
-            </a:r>
-          </a:p>
-        </p:txBody>
-      </p:sp>
-      <p:sp>
-        <p:nvSpPr>
-          <p:cNvPr id="4" name="TextBox 3"/>
+              <a:defRPr sz="2000" b="1">
+                <a:solidFill>
+                  <a:srgbClr val="00205B"/>
+                </a:solidFill>
+                <a:latin typeface="Georgia"/>
+              </a:defRPr>
+            </a:pPr>
+            <a:r>
+              <a:t>Novelty: Scale-Invariant Landmarks Block Candidate Swapping and Adversarial Noise</a:t>
+            </a:r>
+          </a:p>
+        </p:txBody>
+      </p:sp>
+      <p:sp>
+        <p:nvSpPr>
+          <p:cNvPr id="3" name="TextBox 2"/>
           <p:cNvSpPr txBox="1"/>
           <p:nvPr/>
         </p:nvSpPr>
         <p:spPr>
           <a:xfrm>
-            <a:off x="685800" y="1280160"/>
-            <a:ext cx="5120640" cy="5212080"/>
+            <a:off x="685800" y="1371600"/>
+            <a:ext cx="10817352" cy="4572000"/>
           </a:xfrm>
           <a:prstGeom prst="rect">
             <a:avLst/>
@@ -5640,13 +5749,13 @@
           <a:p>
             <a:pPr>
               <a:spcBef>
-                <a:spcPts val="800"/>
+                <a:spcPts val="1200"/>
               </a:spcBef>
-              <a:defRPr sz="1400" b="1">
-                <a:solidFill>
-                  <a:srgbClr val="8A2BE2"/>
-                </a:solidFill>
-                <a:latin typeface="Arial"/>
+              <a:defRPr sz="1600" b="1">
+                <a:solidFill>
+                  <a:srgbClr val="00205B"/>
+                </a:solidFill>
+                <a:latin typeface="Georgia"/>
               </a:defRPr>
             </a:pPr>
             <a:r>
@@ -5656,11 +5765,11 @@
           <a:p>
             <a:pPr>
               <a:spcAft>
-                <a:spcPts val="600"/>
+                <a:spcPts val="800"/>
               </a:spcAft>
-              <a:defRPr sz="1100">
-                <a:solidFill>
-                  <a:srgbClr val="C8C8DC"/>
+              <a:defRPr sz="1250">
+                <a:solidFill>
+                  <a:srgbClr val="212529"/>
                 </a:solidFill>
                 <a:latin typeface="Arial"/>
               </a:defRPr>
@@ -5680,13 +5789,13 @@
           <a:p>
             <a:pPr>
               <a:spcBef>
-                <a:spcPts val="800"/>
+                <a:spcPts val="1200"/>
               </a:spcBef>
-              <a:defRPr sz="1400" b="1">
-                <a:solidFill>
-                  <a:srgbClr val="8A2BE2"/>
-                </a:solidFill>
-                <a:latin typeface="Arial"/>
+              <a:defRPr sz="1600" b="1">
+                <a:solidFill>
+                  <a:srgbClr val="00205B"/>
+                </a:solidFill>
+                <a:latin typeface="Georgia"/>
               </a:defRPr>
             </a:pPr>
             <a:r>
@@ -5696,11 +5805,11 @@
           <a:p>
             <a:pPr>
               <a:spcAft>
-                <a:spcPts val="600"/>
+                <a:spcPts val="800"/>
               </a:spcAft>
-              <a:defRPr sz="1100">
-                <a:solidFill>
-                  <a:srgbClr val="C8C8DC"/>
+              <a:defRPr sz="1250">
+                <a:solidFill>
+                  <a:srgbClr val="212529"/>
                 </a:solidFill>
                 <a:latin typeface="Arial"/>
               </a:defRPr>
@@ -5716,13 +5825,13 @@
           <a:p>
             <a:pPr>
               <a:spcBef>
-                <a:spcPts val="800"/>
+                <a:spcPts val="1200"/>
               </a:spcBef>
-              <a:defRPr sz="1400" b="1">
-                <a:solidFill>
-                  <a:srgbClr val="8A2BE2"/>
-                </a:solidFill>
-                <a:latin typeface="Arial"/>
+              <a:defRPr sz="1600" b="1">
+                <a:solidFill>
+                  <a:srgbClr val="00205B"/>
+                </a:solidFill>
+                <a:latin typeface="Georgia"/>
               </a:defRPr>
             </a:pPr>
             <a:r>
@@ -5732,11 +5841,11 @@
           <a:p>
             <a:pPr>
               <a:spcAft>
-                <a:spcPts val="600"/>
+                <a:spcPts val="800"/>
               </a:spcAft>
-              <a:defRPr sz="1100">
-                <a:solidFill>
-                  <a:srgbClr val="C8C8DC"/>
+              <a:defRPr sz="1250">
+                <a:solidFill>
+                  <a:srgbClr val="212529"/>
                 </a:solidFill>
                 <a:latin typeface="Arial"/>
               </a:defRPr>
@@ -5761,7 +5870,7 @@
     <p:bg>
       <p:bgPr>
         <a:solidFill>
-          <a:srgbClr val="0A0A10"/>
+          <a:srgbClr val="FFFFFF"/>
         </a:solidFill>
         <a:effectLst/>
       </p:bgPr>
@@ -5781,8 +5890,8 @@
         </p:nvSpPr>
         <p:spPr>
           <a:xfrm>
-            <a:off x="685800" y="320040"/>
-            <a:ext cx="10817352" cy="914400"/>
+            <a:off x="685800" y="365760"/>
+            <a:ext cx="10817352" cy="822960"/>
           </a:xfrm>
           <a:prstGeom prst="rect">
             <a:avLst/>
@@ -5796,11 +5905,11 @@
           <a:lstStyle/>
           <a:p>
             <a:pPr>
-              <a:defRPr sz="2200" b="1">
-                <a:solidFill>
-                  <a:srgbClr val="8A2BE2"/>
-                </a:solidFill>
-                <a:latin typeface="Arial"/>
+              <a:defRPr sz="2000" b="1">
+                <a:solidFill>
+                  <a:srgbClr val="00205B"/>
+                </a:solidFill>
+                <a:latin typeface="Georgia"/>
               </a:defRPr>
             </a:pPr>
             <a:r>
@@ -5818,17 +5927,17 @@
         <p:spPr>
           <a:xfrm>
             <a:off x="685800" y="1645920"/>
-            <a:ext cx="5120640" cy="4114800"/>
+            <a:ext cx="5120640" cy="4389120"/>
           </a:xfrm>
           <a:prstGeom prst="roundRect">
             <a:avLst/>
           </a:prstGeom>
           <a:solidFill>
-            <a:srgbClr val="181622"/>
+            <a:srgbClr val="F5F6F8"/>
           </a:solidFill>
           <a:ln w="12700">
             <a:solidFill>
-              <a:srgbClr val="3C325A"/>
+              <a:srgbClr val="C8CDD7"/>
             </a:solidFill>
           </a:ln>
         </p:spPr>
@@ -5856,9 +5965,9 @@
               </a:spcAft>
               <a:defRPr sz="1800" b="1">
                 <a:solidFill>
-                  <a:srgbClr val="FFFFFF"/>
-                </a:solidFill>
-                <a:latin typeface="Arial"/>
+                  <a:srgbClr val="00205B"/>
+                </a:solidFill>
+                <a:latin typeface="Georgia"/>
               </a:defRPr>
             </a:pPr>
             <a:r>
@@ -5872,7 +5981,7 @@
               </a:spcAft>
               <a:defRPr sz="1300">
                 <a:solidFill>
-                  <a:srgbClr val="C8C8DC"/>
+                  <a:srgbClr val="212529"/>
                 </a:solidFill>
                 <a:latin typeface="Arial"/>
               </a:defRPr>
@@ -5888,7 +5997,7 @@
               </a:spcAft>
               <a:defRPr sz="1300">
                 <a:solidFill>
-                  <a:srgbClr val="C8C8DC"/>
+                  <a:srgbClr val="212529"/>
                 </a:solidFill>
                 <a:latin typeface="Arial"/>
               </a:defRPr>
@@ -5904,7 +6013,7 @@
               </a:spcAft>
               <a:defRPr sz="1300">
                 <a:solidFill>
-                  <a:srgbClr val="C8C8DC"/>
+                  <a:srgbClr val="212529"/>
                 </a:solidFill>
                 <a:latin typeface="Arial"/>
               </a:defRPr>
@@ -5924,17 +6033,17 @@
         <p:spPr>
           <a:xfrm>
             <a:off x="6217920" y="1645920"/>
-            <a:ext cx="5212080" cy="4114800"/>
+            <a:ext cx="5212080" cy="4389120"/>
           </a:xfrm>
           <a:prstGeom prst="roundRect">
             <a:avLst/>
           </a:prstGeom>
           <a:solidFill>
-            <a:srgbClr val="181622"/>
+            <a:srgbClr val="F5F6F8"/>
           </a:solidFill>
           <a:ln w="12700">
             <a:solidFill>
-              <a:srgbClr val="3C325A"/>
+              <a:srgbClr val="C8CDD7"/>
             </a:solidFill>
           </a:ln>
         </p:spPr>
@@ -5962,9 +6071,9 @@
               </a:spcAft>
               <a:defRPr sz="1800" b="1">
                 <a:solidFill>
-                  <a:srgbClr val="8A2BE2"/>
-                </a:solidFill>
-                <a:latin typeface="Arial"/>
+                  <a:srgbClr val="00205B"/>
+                </a:solidFill>
+                <a:latin typeface="Georgia"/>
               </a:defRPr>
             </a:pPr>
             <a:r>
@@ -5978,7 +6087,7 @@
               </a:spcBef>
               <a:defRPr sz="1200">
                 <a:solidFill>
-                  <a:srgbClr val="C8C8DC"/>
+                  <a:srgbClr val="212529"/>
                 </a:solidFill>
                 <a:latin typeface="Arial"/>
               </a:defRPr>

</xml_diff>